<commit_message>
Step 4 + handoff file
</commit_message>
<xml_diff>
--- a/presentation.pptx
+++ b/presentation.pptx
@@ -11,6 +11,7 @@
     <p:sldId id="259" r:id="rId10"/>
     <p:sldId id="260" r:id="rId11"/>
     <p:sldId id="261" r:id="rId12"/>
+    <p:sldId id="262" r:id="rId13"/>
   </p:sldIdLst>
   <p:sldSz cx="12191695" cy="6858000" type="screen4x3"/>
   <p:notesSz cx="6858000" cy="9144000"/>
@@ -7044,6 +7045,386 @@
           </a:prstGeom>
         </p:spPr>
       </p:pic>
+    </p:spTree>
+  </p:cSld>
+  <p:clrMapOvr>
+    <a:masterClrMapping/>
+  </p:clrMapOvr>
+</p:sld>
+</file>
+
+<file path=ppt/slides/slide7.xml><?xml version="1.0" encoding="utf-8"?>
+<p:sld xmlns:a="http://schemas.openxmlformats.org/drawingml/2006/main" xmlns:p="http://schemas.openxmlformats.org/presentationml/2006/main" xmlns:r="http://schemas.openxmlformats.org/officeDocument/2006/relationships">
+  <p:cSld>
+    <p:spTree>
+      <p:nvGrpSpPr>
+        <p:cNvPr id="1" name=""/>
+        <p:cNvGrpSpPr/>
+        <p:nvPr/>
+      </p:nvGrpSpPr>
+      <p:grpSpPr/>
+      <p:sp>
+        <p:nvSpPr>
+          <p:cNvPr id="2" name="Rectangle 1"/>
+          <p:cNvSpPr/>
+          <p:nvPr/>
+        </p:nvSpPr>
+        <p:spPr>
+          <a:xfrm>
+            <a:off x="0" y="0"/>
+            <a:ext cx="12191695" cy="1097280"/>
+          </a:xfrm>
+          <a:prstGeom prst="rect">
+            <a:avLst/>
+          </a:prstGeom>
+          <a:solidFill>
+            <a:srgbClr val="102542"/>
+          </a:solidFill>
+          <a:ln>
+            <a:solidFill>
+              <a:srgbClr val="102542"/>
+            </a:solidFill>
+          </a:ln>
+        </p:spPr>
+        <p:style>
+          <a:lnRef idx="1">
+            <a:schemeClr val="accent1"/>
+          </a:lnRef>
+          <a:fillRef idx="3">
+            <a:schemeClr val="accent1"/>
+          </a:fillRef>
+          <a:effectRef idx="2">
+            <a:schemeClr val="accent1"/>
+          </a:effectRef>
+          <a:fontRef idx="minor">
+            <a:schemeClr val="lt1"/>
+          </a:fontRef>
+        </p:style>
+        <p:txBody>
+          <a:bodyPr rtlCol="0" anchor="ctr" wrap="square" lIns="731520" tIns="137160"/>
+          <a:lstStyle/>
+          <a:p>
+            <a:pPr algn="ctr">
+              <a:defRPr sz="1100" b="1">
+                <a:solidFill>
+                  <a:srgbClr val="B4CDEB"/>
+                </a:solidFill>
+              </a:defRPr>
+            </a:pPr>
+            <a:r>
+              <a:t>DATA ANALYTICS PROJECT WORK</a:t>
+            </a:r>
+          </a:p>
+          <a:p>
+            <a:pPr>
+              <a:defRPr sz="2200" b="1">
+                <a:solidFill>
+                  <a:srgbClr val="FFFFFF"/>
+                </a:solidFill>
+              </a:defRPr>
+            </a:pPr>
+            <a:r>
+              <a:t>4. Main Analysis: Objectives &amp; Methodological Framework</a:t>
+            </a:r>
+          </a:p>
+        </p:txBody>
+      </p:sp>
+      <p:sp>
+        <p:nvSpPr>
+          <p:cNvPr id="3" name="Rounded Rectangle 2"/>
+          <p:cNvSpPr/>
+          <p:nvPr/>
+        </p:nvSpPr>
+        <p:spPr>
+          <a:xfrm>
+            <a:off x="731520" y="1371600"/>
+            <a:ext cx="3383280" cy="2926080"/>
+          </a:xfrm>
+          <a:prstGeom prst="roundRect">
+            <a:avLst/>
+          </a:prstGeom>
+          <a:solidFill>
+            <a:srgbClr val="F8F9FA"/>
+          </a:solidFill>
+          <a:ln>
+            <a:solidFill>
+              <a:srgbClr val="DCE1E6"/>
+            </a:solidFill>
+          </a:ln>
+        </p:spPr>
+        <p:style>
+          <a:lnRef idx="1">
+            <a:schemeClr val="accent1"/>
+          </a:lnRef>
+          <a:fillRef idx="3">
+            <a:schemeClr val="accent1"/>
+          </a:fillRef>
+          <a:effectRef idx="2">
+            <a:schemeClr val="accent1"/>
+          </a:effectRef>
+          <a:fontRef idx="minor">
+            <a:schemeClr val="lt1"/>
+          </a:fontRef>
+        </p:style>
+        <p:txBody>
+          <a:bodyPr rtlCol="0" anchor="ctr" wrap="square" lIns="182880" tIns="182880"/>
+          <a:lstStyle/>
+          <a:p>
+            <a:pPr algn="ctr">
+              <a:defRPr sz="1300" b="1">
+                <a:solidFill>
+                  <a:srgbClr val="102542"/>
+                </a:solidFill>
+              </a:defRPr>
+            </a:pPr>
+            <a:r>
+              <a:t>Objective 1: Energy Yield (TEY) &amp; PCR</a:t>
+            </a:r>
+          </a:p>
+          <a:p>
+            <a:pPr>
+              <a:defRPr sz="1000">
+                <a:solidFill>
+                  <a:srgbClr val="212529"/>
+                </a:solidFill>
+              </a:defRPr>
+            </a:pPr>
+            <a:r>
+              <a:t>• Predict net turbine energy yield from sensor telemetry.</a:t>
+            </a:r>
+            <a:br/>
+            <a:r>
+              <a:t>• Problem: Extreme Multicollinearity (VIF &gt; 250 for CDP, TIT, GTEP, Slide 115).</a:t>
+            </a:r>
+            <a:br/>
+            <a:r>
+              <a:t>• Method: Principal Component Regression (PCR, Slides 70, 106) on 5 PCs ($Z = X V_p$) to eliminate variance inflation and ensure parameter stability.</a:t>
+            </a:r>
+          </a:p>
+        </p:txBody>
+      </p:sp>
+      <p:sp>
+        <p:nvSpPr>
+          <p:cNvPr id="4" name="Rounded Rectangle 3"/>
+          <p:cNvSpPr/>
+          <p:nvPr/>
+        </p:nvSpPr>
+        <p:spPr>
+          <a:xfrm>
+            <a:off x="4389120" y="1371600"/>
+            <a:ext cx="3383280" cy="2926080"/>
+          </a:xfrm>
+          <a:prstGeom prst="roundRect">
+            <a:avLst/>
+          </a:prstGeom>
+          <a:solidFill>
+            <a:srgbClr val="F8F9FA"/>
+          </a:solidFill>
+          <a:ln>
+            <a:solidFill>
+              <a:srgbClr val="DCE1E6"/>
+            </a:solidFill>
+          </a:ln>
+        </p:spPr>
+        <p:style>
+          <a:lnRef idx="1">
+            <a:schemeClr val="accent1"/>
+          </a:lnRef>
+          <a:fillRef idx="3">
+            <a:schemeClr val="accent1"/>
+          </a:fillRef>
+          <a:effectRef idx="2">
+            <a:schemeClr val="accent1"/>
+          </a:effectRef>
+          <a:fontRef idx="minor">
+            <a:schemeClr val="lt1"/>
+          </a:fontRef>
+        </p:style>
+        <p:txBody>
+          <a:bodyPr rtlCol="0" anchor="ctr" wrap="square" lIns="182880" tIns="182880"/>
+          <a:lstStyle/>
+          <a:p>
+            <a:pPr algn="ctr">
+              <a:defRPr sz="1300" b="1">
+                <a:solidFill>
+                  <a:srgbClr val="102542"/>
+                </a:solidFill>
+              </a:defRPr>
+            </a:pPr>
+            <a:r>
+              <a:t>Objective 2: Emissions Modeling (CO &amp; NOx)</a:t>
+            </a:r>
+          </a:p>
+          <a:p>
+            <a:pPr>
+              <a:defRPr sz="1000">
+                <a:solidFill>
+                  <a:srgbClr val="212529"/>
+                </a:solidFill>
+              </a:defRPr>
+            </a:pPr>
+            <a:r>
+              <a:t>• Quantify pollutant generation as a function of firing state.</a:t>
+            </a:r>
+            <a:br/>
+            <a:r>
+              <a:t>• Method: Polynomial Regression (Slide 116 &amp; Ex 4.1) for CO to capture steep non-linear spikes during low-load/startup regimes ($x \to [x, x^2]$).</a:t>
+            </a:r>
+            <a:br/>
+            <a:r>
+              <a:t>• Multivariate OLS for NOx tracking thermal oxidation.</a:t>
+            </a:r>
+          </a:p>
+        </p:txBody>
+      </p:sp>
+      <p:sp>
+        <p:nvSpPr>
+          <p:cNvPr id="5" name="Rounded Rectangle 4"/>
+          <p:cNvSpPr/>
+          <p:nvPr/>
+        </p:nvSpPr>
+        <p:spPr>
+          <a:xfrm>
+            <a:off x="8046720" y="1371600"/>
+            <a:ext cx="3383280" cy="2926080"/>
+          </a:xfrm>
+          <a:prstGeom prst="roundRect">
+            <a:avLst/>
+          </a:prstGeom>
+          <a:solidFill>
+            <a:srgbClr val="F8F9FA"/>
+          </a:solidFill>
+          <a:ln>
+            <a:solidFill>
+              <a:srgbClr val="DCE1E6"/>
+            </a:solidFill>
+          </a:ln>
+        </p:spPr>
+        <p:style>
+          <a:lnRef idx="1">
+            <a:schemeClr val="accent1"/>
+          </a:lnRef>
+          <a:fillRef idx="3">
+            <a:schemeClr val="accent1"/>
+          </a:fillRef>
+          <a:effectRef idx="2">
+            <a:schemeClr val="accent1"/>
+          </a:effectRef>
+          <a:fontRef idx="minor">
+            <a:schemeClr val="lt1"/>
+          </a:fontRef>
+        </p:style>
+        <p:txBody>
+          <a:bodyPr rtlCol="0" anchor="ctr" wrap="square" lIns="182880" tIns="182880"/>
+          <a:lstStyle/>
+          <a:p>
+            <a:pPr algn="ctr">
+              <a:defRPr sz="1300" b="1">
+                <a:solidFill>
+                  <a:srgbClr val="102542"/>
+                </a:solidFill>
+              </a:defRPr>
+            </a:pPr>
+            <a:r>
+              <a:t>Objective 3: Operational Regimes (K-Means)</a:t>
+            </a:r>
+          </a:p>
+          <a:p>
+            <a:pPr>
+              <a:defRPr sz="1000">
+                <a:solidFill>
+                  <a:srgbClr val="212529"/>
+                </a:solidFill>
+              </a:defRPr>
+            </a:pPr>
+            <a:r>
+              <a:t>• Discover discrete turbine operational regimes (Unsupervised).</a:t>
+            </a:r>
+            <a:br/>
+            <a:r>
+              <a:t>• Method: K-Means Clustering (Slides 90-91) with Silhouette validation (Slide 94, Ex 3.1): $\text{SIL} = \frac{1}{m}\sum \frac{b_i - a_i}{\max(a_i, b_i)}$.</a:t>
+            </a:r>
+            <a:br/>
+            <a:r>
+              <a:t>• Identifies Base-load, Peak-load, and Low-load emission profiles.</a:t>
+            </a:r>
+          </a:p>
+        </p:txBody>
+      </p:sp>
+      <p:sp>
+        <p:nvSpPr>
+          <p:cNvPr id="6" name="Rounded Rectangle 5"/>
+          <p:cNvSpPr/>
+          <p:nvPr/>
+        </p:nvSpPr>
+        <p:spPr>
+          <a:xfrm>
+            <a:off x="731520" y="4480560"/>
+            <a:ext cx="10698480" cy="1920240"/>
+          </a:xfrm>
+          <a:prstGeom prst="roundRect">
+            <a:avLst/>
+          </a:prstGeom>
+          <a:solidFill>
+            <a:srgbClr val="F8F9FA"/>
+          </a:solidFill>
+          <a:ln>
+            <a:solidFill>
+              <a:srgbClr val="DCE1E6"/>
+            </a:solidFill>
+          </a:ln>
+        </p:spPr>
+        <p:style>
+          <a:lnRef idx="1">
+            <a:schemeClr val="accent1"/>
+          </a:lnRef>
+          <a:fillRef idx="3">
+            <a:schemeClr val="accent1"/>
+          </a:fillRef>
+          <a:effectRef idx="2">
+            <a:schemeClr val="accent1"/>
+          </a:effectRef>
+          <a:fontRef idx="minor">
+            <a:schemeClr val="lt1"/>
+          </a:fontRef>
+        </p:style>
+        <p:txBody>
+          <a:bodyPr rtlCol="0" anchor="ctr" wrap="square" lIns="228600" tIns="137160"/>
+          <a:lstStyle/>
+          <a:p>
+            <a:pPr algn="ctr">
+              <a:defRPr sz="1300" b="1">
+                <a:solidFill>
+                  <a:srgbClr val="102542"/>
+                </a:solidFill>
+              </a:defRPr>
+            </a:pPr>
+            <a:r>
+              <a:t>Mathematical Formulations &amp; Accuracy Metrics (Course Standards)</a:t>
+            </a:r>
+          </a:p>
+          <a:p>
+            <a:pPr>
+              <a:defRPr sz="1050">
+                <a:solidFill>
+                  <a:srgbClr val="212529"/>
+                </a:solidFill>
+              </a:defRPr>
+            </a:pPr>
+            <a:r>
+              <a:t>• Ordinary Least Squares: $\hat{\beta} = (X^T X)^{-1} X^T y$ (Slide 106) | Principal Component Regression: $\hat{\beta}_{PCR} = (Z^T Z)^{-1} Z^T y$</a:t>
+            </a:r>
+            <a:br/>
+            <a:r>
+              <a:t>• Accuracy Metrics: $R^2 = 1 - \frac{RSS}{TSS}$ (Slide 108), $\text{RMSE} = \sqrt{\frac{1}{m}\sum (y_i - \hat{y}_i)^2}$</a:t>
+            </a:r>
+            <a:br/>
+            <a:r>
+              <a:t>• Multicollinearity VIF: $\text{VIF}(\hat{\beta}_j) = \frac{1}{1 - R^2_{x_j|x_{-j}}}$ (Slide 115) | Silhouette Quality: $\text{SIL}_i = \frac{b_i - a_i}{\max(a_i, b_i)}$ (Slide 94)</a:t>
+            </a:r>
+          </a:p>
+        </p:txBody>
+      </p:sp>
     </p:spTree>
   </p:cSld>
   <p:clrMapOvr>

</xml_diff>

<commit_message>
step 7 - fine
</commit_message>
<xml_diff>
--- a/presentation.pptx
+++ b/presentation.pptx
@@ -15,6 +15,8 @@
     <p:sldId id="263" r:id="rId14"/>
     <p:sldId id="264" r:id="rId15"/>
     <p:sldId id="265" r:id="rId16"/>
+    <p:sldId id="266" r:id="rId17"/>
+    <p:sldId id="267" r:id="rId18"/>
   </p:sldIdLst>
   <p:sldSz cx="12191695" cy="6858000" type="screen4x3"/>
   <p:notesSz cx="6858000" cy="9144000"/>
@@ -3455,6 +3457,446 @@
           </a:prstGeom>
         </p:spPr>
       </p:pic>
+    </p:spTree>
+  </p:cSld>
+  <p:clrMapOvr>
+    <a:masterClrMapping/>
+  </p:clrMapOvr>
+</p:sld>
+</file>
+
+<file path=ppt/slides/slide11.xml><?xml version="1.0" encoding="utf-8"?>
+<p:sld xmlns:a="http://schemas.openxmlformats.org/drawingml/2006/main" xmlns:p="http://schemas.openxmlformats.org/presentationml/2006/main" xmlns:r="http://schemas.openxmlformats.org/officeDocument/2006/relationships">
+  <p:cSld>
+    <p:spTree>
+      <p:nvGrpSpPr>
+        <p:cNvPr id="1" name=""/>
+        <p:cNvGrpSpPr/>
+        <p:nvPr/>
+      </p:nvGrpSpPr>
+      <p:grpSpPr/>
+      <p:sp>
+        <p:nvSpPr>
+          <p:cNvPr id="2" name="Rectangle 1"/>
+          <p:cNvSpPr/>
+          <p:nvPr/>
+        </p:nvSpPr>
+        <p:spPr>
+          <a:xfrm>
+            <a:off x="0" y="0"/>
+            <a:ext cx="12191695" cy="1097280"/>
+          </a:xfrm>
+          <a:prstGeom prst="rect">
+            <a:avLst/>
+          </a:prstGeom>
+          <a:solidFill>
+            <a:srgbClr val="102542"/>
+          </a:solidFill>
+          <a:ln>
+            <a:solidFill>
+              <a:srgbClr val="102542"/>
+            </a:solidFill>
+          </a:ln>
+        </p:spPr>
+        <p:style>
+          <a:lnRef idx="1">
+            <a:schemeClr val="accent1"/>
+          </a:lnRef>
+          <a:fillRef idx="3">
+            <a:schemeClr val="accent1"/>
+          </a:fillRef>
+          <a:effectRef idx="2">
+            <a:schemeClr val="accent1"/>
+          </a:effectRef>
+          <a:fontRef idx="minor">
+            <a:schemeClr val="lt1"/>
+          </a:fontRef>
+        </p:style>
+        <p:txBody>
+          <a:bodyPr rtlCol="0" anchor="ctr" wrap="square" lIns="731520" tIns="137160"/>
+          <a:lstStyle/>
+          <a:p>
+            <a:pPr algn="ctr">
+              <a:defRPr sz="1100" b="1">
+                <a:solidFill>
+                  <a:srgbClr val="B4CDEB"/>
+                </a:solidFill>
+              </a:defRPr>
+            </a:pPr>
+            <a:r>
+              <a:t>DATA ANALYTICS PROJECT WORK</a:t>
+            </a:r>
+          </a:p>
+          <a:p>
+            <a:pPr>
+              <a:defRPr sz="2200" b="1">
+                <a:solidFill>
+                  <a:srgbClr val="FFFFFF"/>
+                </a:solidFill>
+              </a:defRPr>
+            </a:pPr>
+            <a:r>
+              <a:t>7. Conclusions &amp; Engineering Recommendations</a:t>
+            </a:r>
+          </a:p>
+        </p:txBody>
+      </p:sp>
+      <p:sp>
+        <p:nvSpPr>
+          <p:cNvPr id="3" name="Rounded Rectangle 2"/>
+          <p:cNvSpPr/>
+          <p:nvPr/>
+        </p:nvSpPr>
+        <p:spPr>
+          <a:xfrm>
+            <a:off x="731520" y="1371600"/>
+            <a:ext cx="3383280" cy="5029200"/>
+          </a:xfrm>
+          <a:prstGeom prst="roundRect">
+            <a:avLst/>
+          </a:prstGeom>
+          <a:solidFill>
+            <a:srgbClr val="F8F9FA"/>
+          </a:solidFill>
+          <a:ln>
+            <a:solidFill>
+              <a:srgbClr val="DCE1E6"/>
+            </a:solidFill>
+          </a:ln>
+        </p:spPr>
+        <p:style>
+          <a:lnRef idx="1">
+            <a:schemeClr val="accent1"/>
+          </a:lnRef>
+          <a:fillRef idx="3">
+            <a:schemeClr val="accent1"/>
+          </a:fillRef>
+          <a:effectRef idx="2">
+            <a:schemeClr val="accent1"/>
+          </a:effectRef>
+          <a:fontRef idx="minor">
+            <a:schemeClr val="lt1"/>
+          </a:fontRef>
+        </p:style>
+        <p:txBody>
+          <a:bodyPr rtlCol="0" anchor="ctr" wrap="square" lIns="228600" tIns="182880"/>
+          <a:lstStyle/>
+          <a:p>
+            <a:pPr algn="ctr">
+              <a:defRPr sz="1400" b="1">
+                <a:solidFill>
+                  <a:srgbClr val="102542"/>
+                </a:solidFill>
+              </a:defRPr>
+            </a:pPr>
+            <a:r>
+              <a:t>1. Methodological Justifications</a:t>
+            </a:r>
+          </a:p>
+          <a:p>
+            <a:br/>
+            <a:pPr>
+              <a:defRPr sz="1050">
+                <a:solidFill>
+                  <a:srgbClr val="212529"/>
+                </a:solidFill>
+              </a:defRPr>
+            </a:pPr>
+            <a:r>
+              <a:t>• Multicollinearity: VIF &gt; 250 proved that raw sensor OLS is unstable. PCR with 5 orthogonal components achieved optimal generalization (Test R² = 0.9828).</a:t>
+            </a:r>
+            <a:br/>
+            <a:r>
+              <a:t>• Non-linear Physics: CO combustion follows non-linear thermal kinetics; degree-2 polynomial expansion resolved the inflection point.</a:t>
+            </a:r>
+            <a:br/>
+            <a:r>
+              <a:t>• Unsupervised Regimes: K-Means (K=3) confirmed distinct thermodynamic regimes without labeled training data.</a:t>
+            </a:r>
+          </a:p>
+        </p:txBody>
+      </p:sp>
+      <p:sp>
+        <p:nvSpPr>
+          <p:cNvPr id="4" name="Rounded Rectangle 3"/>
+          <p:cNvSpPr/>
+          <p:nvPr/>
+        </p:nvSpPr>
+        <p:spPr>
+          <a:xfrm>
+            <a:off x="4389120" y="1371600"/>
+            <a:ext cx="3383280" cy="5029200"/>
+          </a:xfrm>
+          <a:prstGeom prst="roundRect">
+            <a:avLst/>
+          </a:prstGeom>
+          <a:solidFill>
+            <a:srgbClr val="F8F9FA"/>
+          </a:solidFill>
+          <a:ln>
+            <a:solidFill>
+              <a:srgbClr val="DCE1E6"/>
+            </a:solidFill>
+          </a:ln>
+        </p:spPr>
+        <p:style>
+          <a:lnRef idx="1">
+            <a:schemeClr val="accent1"/>
+          </a:lnRef>
+          <a:fillRef idx="3">
+            <a:schemeClr val="accent1"/>
+          </a:fillRef>
+          <a:effectRef idx="2">
+            <a:schemeClr val="accent1"/>
+          </a:effectRef>
+          <a:fontRef idx="minor">
+            <a:schemeClr val="lt1"/>
+          </a:fontRef>
+        </p:style>
+        <p:txBody>
+          <a:bodyPr rtlCol="0" anchor="ctr" wrap="square" lIns="228600" tIns="182880"/>
+          <a:lstStyle/>
+          <a:p>
+            <a:pPr algn="ctr">
+              <a:defRPr sz="1400" b="1">
+                <a:solidFill>
+                  <a:srgbClr val="102542"/>
+                </a:solidFill>
+              </a:defRPr>
+            </a:pPr>
+            <a:r>
+              <a:t>2. Operational Emission Control</a:t>
+            </a:r>
+          </a:p>
+          <a:p>
+            <a:br/>
+            <a:pPr>
+              <a:defRPr sz="1050">
+                <a:solidFill>
+                  <a:srgbClr val="212529"/>
+                </a:solidFill>
+              </a:defRPr>
+            </a:pPr>
+            <a:r>
+              <a:t>• Avoid Low Firing Regimes: Part-load operation below 1070°C firing produces 4.8x higher CO emissions.</a:t>
+            </a:r>
+            <a:br/>
+            <a:r>
+              <a:t>• Peak Load Cleanliness: Operating at peak load (TIT ~1100°C) maximizes power yield (157 MWh) and minimizes CO (1.0 mg/m³).</a:t>
+            </a:r>
+            <a:br/>
+            <a:r>
+              <a:t>• Ambient Weather Compensation: Ambient temperature penalizes turbine yield (-0.58 correlation), justifying inlet air chilling systems during summer.</a:t>
+            </a:r>
+          </a:p>
+        </p:txBody>
+      </p:sp>
+      <p:sp>
+        <p:nvSpPr>
+          <p:cNvPr id="5" name="Rounded Rectangle 4"/>
+          <p:cNvSpPr/>
+          <p:nvPr/>
+        </p:nvSpPr>
+        <p:spPr>
+          <a:xfrm>
+            <a:off x="8046720" y="1371600"/>
+            <a:ext cx="3383280" cy="5029200"/>
+          </a:xfrm>
+          <a:prstGeom prst="roundRect">
+            <a:avLst/>
+          </a:prstGeom>
+          <a:solidFill>
+            <a:srgbClr val="F8F9FA"/>
+          </a:solidFill>
+          <a:ln>
+            <a:solidFill>
+              <a:srgbClr val="DCE1E6"/>
+            </a:solidFill>
+          </a:ln>
+        </p:spPr>
+        <p:style>
+          <a:lnRef idx="1">
+            <a:schemeClr val="accent1"/>
+          </a:lnRef>
+          <a:fillRef idx="3">
+            <a:schemeClr val="accent1"/>
+          </a:fillRef>
+          <a:effectRef idx="2">
+            <a:schemeClr val="accent1"/>
+          </a:effectRef>
+          <a:fontRef idx="minor">
+            <a:schemeClr val="lt1"/>
+          </a:fontRef>
+        </p:style>
+        <p:txBody>
+          <a:bodyPr rtlCol="0" anchor="ctr" wrap="square" lIns="228600" tIns="182880"/>
+          <a:lstStyle/>
+          <a:p>
+            <a:pPr algn="ctr">
+              <a:defRPr sz="1400" b="1">
+                <a:solidFill>
+                  <a:srgbClr val="102542"/>
+                </a:solidFill>
+              </a:defRPr>
+            </a:pPr>
+            <a:r>
+              <a:t>3. Digital Twin &amp; Deployment</a:t>
+            </a:r>
+          </a:p>
+          <a:p>
+            <a:br/>
+            <a:pPr>
+              <a:defRPr sz="1050">
+                <a:solidFill>
+                  <a:srgbClr val="212529"/>
+                </a:solidFill>
+              </a:defRPr>
+            </a:pPr>
+            <a:r>
+              <a:t>• Real-Time Monitoring: The lightweight 5-component PCR model can run in real-time on edge turbine PLCs for anomaly detection.</a:t>
+            </a:r>
+            <a:br/>
+            <a:r>
+              <a:t>• Sensor Redundancy: High collinearity allows synthetic sensor estimation if a pressure transducer fails in operation.</a:t>
+            </a:r>
+            <a:br/>
+            <a:r>
+              <a:t>• Regulatory Compliance: Predictive emission models enable preemptive flue gas compliance adjustments.</a:t>
+            </a:r>
+          </a:p>
+        </p:txBody>
+      </p:sp>
+    </p:spTree>
+  </p:cSld>
+  <p:clrMapOvr>
+    <a:masterClrMapping/>
+  </p:clrMapOvr>
+</p:sld>
+</file>
+
+<file path=ppt/slides/slide12.xml><?xml version="1.0" encoding="utf-8"?>
+<p:sld xmlns:a="http://schemas.openxmlformats.org/drawingml/2006/main" xmlns:p="http://schemas.openxmlformats.org/presentationml/2006/main" xmlns:r="http://schemas.openxmlformats.org/officeDocument/2006/relationships">
+  <p:cSld>
+    <p:spTree>
+      <p:nvGrpSpPr>
+        <p:cNvPr id="1" name=""/>
+        <p:cNvGrpSpPr/>
+        <p:nvPr/>
+      </p:nvGrpSpPr>
+      <p:grpSpPr/>
+      <p:sp>
+        <p:nvSpPr>
+          <p:cNvPr id="2" name="Rectangle 1"/>
+          <p:cNvSpPr/>
+          <p:nvPr/>
+        </p:nvSpPr>
+        <p:spPr>
+          <a:xfrm>
+            <a:off x="0" y="0"/>
+            <a:ext cx="12191695" cy="6858000"/>
+          </a:xfrm>
+          <a:prstGeom prst="rect">
+            <a:avLst/>
+          </a:prstGeom>
+          <a:solidFill>
+            <a:srgbClr val="102542"/>
+          </a:solidFill>
+          <a:ln>
+            <a:solidFill>
+              <a:srgbClr val="102542"/>
+            </a:solidFill>
+          </a:ln>
+        </p:spPr>
+        <p:style>
+          <a:lnRef idx="1">
+            <a:schemeClr val="accent1"/>
+          </a:lnRef>
+          <a:fillRef idx="3">
+            <a:schemeClr val="accent1"/>
+          </a:fillRef>
+          <a:effectRef idx="2">
+            <a:schemeClr val="accent1"/>
+          </a:effectRef>
+          <a:fontRef idx="minor">
+            <a:schemeClr val="lt1"/>
+          </a:fontRef>
+        </p:style>
+        <p:txBody>
+          <a:bodyPr rtlCol="0" anchor="ctr"/>
+          <a:lstStyle/>
+          <a:p>
+            <a:pPr algn="ctr"/>
+          </a:p>
+        </p:txBody>
+      </p:sp>
+      <p:sp>
+        <p:nvSpPr>
+          <p:cNvPr id="3" name="TextBox 2"/>
+          <p:cNvSpPr txBox="1"/>
+          <p:nvPr/>
+        </p:nvSpPr>
+        <p:spPr>
+          <a:xfrm>
+            <a:off x="914400" y="1645920"/>
+            <a:ext cx="10362895" cy="3657600"/>
+          </a:xfrm>
+          <a:prstGeom prst="rect">
+            <a:avLst/>
+          </a:prstGeom>
+          <a:noFill/>
+        </p:spPr>
+        <p:txBody>
+          <a:bodyPr wrap="square">
+            <a:spAutoFit/>
+          </a:bodyPr>
+          <a:lstStyle/>
+          <a:p>
+            <a:pPr>
+              <a:defRPr sz="4000" b="1">
+                <a:solidFill>
+                  <a:srgbClr val="FFFFFF"/>
+                </a:solidFill>
+              </a:defRPr>
+            </a:pPr>
+            <a:r>
+              <a:t>Thank You!</a:t>
+            </a:r>
+          </a:p>
+          <a:p>
+            <a:pPr>
+              <a:defRPr sz="2200">
+                <a:solidFill>
+                  <a:srgbClr val="B4CDEB"/>
+                </a:solidFill>
+              </a:defRPr>
+            </a:pPr>
+            <a:r>
+              <a:t>Questions &amp; Technical Discussion</a:t>
+            </a:r>
+            <a:br/>
+          </a:p>
+          <a:p>
+            <a:pPr>
+              <a:defRPr sz="1300">
+                <a:solidFill>
+                  <a:srgbClr val="D2E1F0"/>
+                </a:solidFill>
+              </a:defRPr>
+            </a:pPr>
+            <a:r>
+              <a:t>• Supplementary Material: Full Python Jupyter Notebook (gas_turbine_analysis.ipynb)</a:t>
+            </a:r>
+            <a:br/>
+            <a:r>
+              <a:t>• Dataset: 36,733 hourly records across 2011–2015 (Turkey Gas Turbine)</a:t>
+            </a:r>
+            <a:br/>
+            <a:r>
+              <a:t>• All methods strictly conform to the Data Analytics course syllabus.</a:t>
+            </a:r>
+          </a:p>
+        </p:txBody>
+      </p:sp>
     </p:spTree>
   </p:cSld>
   <p:clrMapOvr>

</xml_diff>

<commit_message>
presentazione migliorata(?) prendendo spunto da quella sample
</commit_message>
<xml_diff>
--- a/presentation.pptx
+++ b/presentation.pptx
@@ -3152,8 +3152,8 @@
         </p:nvSpPr>
         <p:spPr>
           <a:xfrm>
-            <a:off x="914400" y="1828800"/>
-            <a:ext cx="10362895" cy="3200400"/>
+            <a:off x="914400" y="1645920"/>
+            <a:ext cx="10362895" cy="3657600"/>
           </a:xfrm>
           <a:prstGeom prst="rect">
             <a:avLst/>
@@ -3181,7 +3181,7 @@
             <a:pPr>
               <a:defRPr sz="2200">
                 <a:solidFill>
-                  <a:srgbClr val="B4CDEB"/>
+                  <a:srgbClr val="B4D7EB"/>
                 </a:solidFill>
               </a:defRPr>
             </a:pPr>
@@ -3203,7 +3203,7 @@
             </a:r>
             <a:br/>
             <a:r>
-              <a:t>Based on Course Methodologies and 2011–2015 Hourly Sensor Data</a:t>
+              <a:t>Based on Multi-Year Hourly Telemetry (36,733 records) and Course Methodologies</a:t>
             </a:r>
           </a:p>
         </p:txBody>
@@ -3270,12 +3270,12 @@
             <a:pPr algn="ctr">
               <a:defRPr sz="1100" b="1">
                 <a:solidFill>
-                  <a:srgbClr val="B4CDEB"/>
-                </a:solidFill>
-              </a:defRPr>
-            </a:pPr>
-            <a:r>
-              <a:t>DATA ANALYTICS PROJECT WORK</a:t>
+                  <a:srgbClr val="B4D7EB"/>
+                </a:solidFill>
+              </a:defRPr>
+            </a:pPr>
+            <a:r>
+              <a:t>PHASE 4: IN-DEPTH MODEL EVALUATION</a:t>
             </a:r>
           </a:p>
           <a:p>
@@ -3519,12 +3519,12 @@
             <a:pPr algn="ctr">
               <a:defRPr sz="1100" b="1">
                 <a:solidFill>
-                  <a:srgbClr val="B4CDEB"/>
-                </a:solidFill>
-              </a:defRPr>
-            </a:pPr>
-            <a:r>
-              <a:t>DATA ANALYTICS PROJECT WORK</a:t>
+                  <a:srgbClr val="B4D7EB"/>
+                </a:solidFill>
+              </a:defRPr>
+            </a:pPr>
+            <a:r>
+              <a:t>PHASE 5: STRATEGIC INSIGHTS</a:t>
             </a:r>
           </a:p>
           <a:p>
@@ -3866,7 +3866,7 @@
             <a:pPr>
               <a:defRPr sz="2200">
                 <a:solidFill>
-                  <a:srgbClr val="B4CDEB"/>
+                  <a:srgbClr val="B4D7EB"/>
                 </a:solidFill>
               </a:defRPr>
             </a:pPr>
@@ -3959,12 +3959,12 @@
             <a:pPr algn="ctr">
               <a:defRPr sz="1100" b="1">
                 <a:solidFill>
-                  <a:srgbClr val="B4CDEB"/>
-                </a:solidFill>
-              </a:defRPr>
-            </a:pPr>
-            <a:r>
-              <a:t>DATA ANALYTICS PROJECT WORK</a:t>
+                  <a:srgbClr val="B4D7EB"/>
+                </a:solidFill>
+              </a:defRPr>
+            </a:pPr>
+            <a:r>
+              <a:t>METHODOLOGICAL ROADMAP</a:t>
             </a:r>
           </a:p>
           <a:p>
@@ -4505,12 +4505,12 @@
             <a:pPr algn="ctr">
               <a:defRPr sz="1100" b="1">
                 <a:solidFill>
-                  <a:srgbClr val="B4CDEB"/>
-                </a:solidFill>
-              </a:defRPr>
-            </a:pPr>
-            <a:r>
-              <a:t>DATA ANALYTICS PROJECT WORK</a:t>
+                  <a:srgbClr val="B4D7EB"/>
+                </a:solidFill>
+              </a:defRPr>
+            </a:pPr>
+            <a:r>
+              <a:t>PHASE 1: DATASET PROFILING</a:t>
             </a:r>
           </a:p>
           <a:p>
@@ -5887,12 +5887,12 @@
             <a:pPr algn="ctr">
               <a:defRPr sz="1100" b="1">
                 <a:solidFill>
-                  <a:srgbClr val="B4CDEB"/>
-                </a:solidFill>
-              </a:defRPr>
-            </a:pPr>
-            <a:r>
-              <a:t>DATA ANALYTICS PROJECT WORK</a:t>
+                  <a:srgbClr val="B4D7EB"/>
+                </a:solidFill>
+              </a:defRPr>
+            </a:pPr>
+            <a:r>
+              <a:t>PHASE 1: DATA PREPARATION</a:t>
             </a:r>
           </a:p>
           <a:p>
@@ -7299,12 +7299,12 @@
             <a:pPr algn="ctr">
               <a:defRPr sz="1100" b="1">
                 <a:solidFill>
-                  <a:srgbClr val="B4CDEB"/>
-                </a:solidFill>
-              </a:defRPr>
-            </a:pPr>
-            <a:r>
-              <a:t>DATA ANALYTICS PROJECT WORK</a:t>
+                  <a:srgbClr val="B4D7EB"/>
+                </a:solidFill>
+              </a:defRPr>
+            </a:pPr>
+            <a:r>
+              <a:t>PHASE 2: EXPLORATORY DATA ANALYSIS</a:t>
             </a:r>
           </a:p>
           <a:p>
@@ -7548,12 +7548,12 @@
             <a:pPr algn="ctr">
               <a:defRPr sz="1100" b="1">
                 <a:solidFill>
-                  <a:srgbClr val="B4CDEB"/>
-                </a:solidFill>
-              </a:defRPr>
-            </a:pPr>
-            <a:r>
-              <a:t>DATA ANALYTICS PROJECT WORK</a:t>
+                  <a:srgbClr val="B4D7EB"/>
+                </a:solidFill>
+              </a:defRPr>
+            </a:pPr>
+            <a:r>
+              <a:t>PHASE 2: UNSUPERVISED PCA</a:t>
             </a:r>
           </a:p>
           <a:p>
@@ -7801,12 +7801,12 @@
             <a:pPr algn="ctr">
               <a:defRPr sz="1100" b="1">
                 <a:solidFill>
-                  <a:srgbClr val="B4CDEB"/>
-                </a:solidFill>
-              </a:defRPr>
-            </a:pPr>
-            <a:r>
-              <a:t>DATA ANALYTICS PROJECT WORK</a:t>
+                  <a:srgbClr val="B4D7EB"/>
+                </a:solidFill>
+              </a:defRPr>
+            </a:pPr>
+            <a:r>
+              <a:t>PHASE 3: METHODOLOGICAL FRAMEWORK</a:t>
             </a:r>
           </a:p>
           <a:p>
@@ -8181,12 +8181,12 @@
             <a:pPr algn="ctr">
               <a:defRPr sz="1100" b="1">
                 <a:solidFill>
-                  <a:srgbClr val="B4CDEB"/>
-                </a:solidFill>
-              </a:defRPr>
-            </a:pPr>
-            <a:r>
-              <a:t>DATA ANALYTICS PROJECT WORK</a:t>
+                  <a:srgbClr val="B4D7EB"/>
+                </a:solidFill>
+              </a:defRPr>
+            </a:pPr>
+            <a:r>
+              <a:t>PHASE 4: RESULTS SYNTHESIS</a:t>
             </a:r>
           </a:p>
           <a:p>
@@ -8203,854 +8203,84 @@
           </a:p>
         </p:txBody>
       </p:sp>
-      <p:graphicFrame>
-        <p:nvGraphicFramePr>
-          <p:cNvPr id="3" name="Table 2"/>
-          <p:cNvGraphicFramePr>
-            <a:graphicFrameLocks noGrp="1"/>
-          </p:cNvGraphicFramePr>
+      <p:sp>
+        <p:nvSpPr>
+          <p:cNvPr id="3" name="Rounded Rectangle 2"/>
+          <p:cNvSpPr/>
           <p:nvPr/>
-        </p:nvGraphicFramePr>
-        <p:xfrm>
-          <a:off x="731520" y="1371600"/>
-          <a:ext cx="6217920" cy="5029200"/>
-        </p:xfrm>
-        <a:graphic>
-          <a:graphicData uri="http://schemas.openxmlformats.org/drawingml/2006/table">
-            <a:tbl>
-              <a:tblPr firstRow="1" bandRow="1">
-                <a:tableStyleId>{5C22544A-7EE6-4342-B048-85BDC9FD1C3A}</a:tableStyleId>
-              </a:tblPr>
-              <a:tblGrid>
-                <a:gridCol w="2194560"/>
-                <a:gridCol w="1005840"/>
-                <a:gridCol w="1005840"/>
-                <a:gridCol w="1005840"/>
-                <a:gridCol w="1005840"/>
-              </a:tblGrid>
-              <a:tr h="718457">
-                <a:tc>
-                  <a:txBody>
-                    <a:bodyPr/>
-                    <a:lstStyle/>
-                    <a:p>
-                      <a:pPr>
-                        <a:defRPr b="1" sz="1000">
-                          <a:solidFill>
-                            <a:srgbClr val="FFFFFF"/>
-                          </a:solidFill>
-                        </a:defRPr>
-                      </a:pPr>
-                      <a:r>
-                        <a:t>Model &amp; Objective</a:t>
-                      </a:r>
-                    </a:p>
-                  </a:txBody>
-                  <a:tcPr>
-                    <a:solidFill>
-                      <a:srgbClr val="102542"/>
-                    </a:solidFill>
-                  </a:tcPr>
-                </a:tc>
-                <a:tc>
-                  <a:txBody>
-                    <a:bodyPr/>
-                    <a:lstStyle/>
-                    <a:p>
-                      <a:pPr>
-                        <a:defRPr b="1" sz="1000">
-                          <a:solidFill>
-                            <a:srgbClr val="FFFFFF"/>
-                          </a:solidFill>
-                        </a:defRPr>
-                      </a:pPr>
-                      <a:r>
-                        <a:t>Train R²</a:t>
-                      </a:r>
-                    </a:p>
-                  </a:txBody>
-                  <a:tcPr>
-                    <a:solidFill>
-                      <a:srgbClr val="102542"/>
-                    </a:solidFill>
-                  </a:tcPr>
-                </a:tc>
-                <a:tc>
-                  <a:txBody>
-                    <a:bodyPr/>
-                    <a:lstStyle/>
-                    <a:p>
-                      <a:pPr>
-                        <a:defRPr b="1" sz="1000">
-                          <a:solidFill>
-                            <a:srgbClr val="FFFFFF"/>
-                          </a:solidFill>
-                        </a:defRPr>
-                      </a:pPr>
-                      <a:r>
-                        <a:t>Test R²</a:t>
-                      </a:r>
-                    </a:p>
-                  </a:txBody>
-                  <a:tcPr>
-                    <a:solidFill>
-                      <a:srgbClr val="102542"/>
-                    </a:solidFill>
-                  </a:tcPr>
-                </a:tc>
-                <a:tc>
-                  <a:txBody>
-                    <a:bodyPr/>
-                    <a:lstStyle/>
-                    <a:p>
-                      <a:pPr>
-                        <a:defRPr b="1" sz="1000">
-                          <a:solidFill>
-                            <a:srgbClr val="FFFFFF"/>
-                          </a:solidFill>
-                        </a:defRPr>
-                      </a:pPr>
-                      <a:r>
-                        <a:t>Test RMSE</a:t>
-                      </a:r>
-                    </a:p>
-                  </a:txBody>
-                  <a:tcPr>
-                    <a:solidFill>
-                      <a:srgbClr val="102542"/>
-                    </a:solidFill>
-                  </a:tcPr>
-                </a:tc>
-                <a:tc>
-                  <a:txBody>
-                    <a:bodyPr/>
-                    <a:lstStyle/>
-                    <a:p>
-                      <a:pPr>
-                        <a:defRPr b="1" sz="1000">
-                          <a:solidFill>
-                            <a:srgbClr val="FFFFFF"/>
-                          </a:solidFill>
-                        </a:defRPr>
-                      </a:pPr>
-                      <a:r>
-                        <a:t>Test MAE</a:t>
-                      </a:r>
-                    </a:p>
-                  </a:txBody>
-                  <a:tcPr>
-                    <a:solidFill>
-                      <a:srgbClr val="102542"/>
-                    </a:solidFill>
-                  </a:tcPr>
-                </a:tc>
-              </a:tr>
-              <a:tr h="718457">
-                <a:tc>
-                  <a:txBody>
-                    <a:bodyPr/>
-                    <a:lstStyle/>
-                    <a:p>
-                      <a:pPr>
-                        <a:defRPr sz="950">
-                          <a:solidFill>
-                            <a:srgbClr val="212529"/>
-                          </a:solidFill>
-                        </a:defRPr>
-                      </a:pPr>
-                      <a:r>
-                        <a:t>TEY: Ambient Baseline</a:t>
-                      </a:r>
-                    </a:p>
-                  </a:txBody>
-                  <a:tcPr>
-                    <a:solidFill>
-                      <a:srgbClr val="F8F9FA"/>
-                    </a:solidFill>
-                  </a:tcPr>
-                </a:tc>
-                <a:tc>
-                  <a:txBody>
-                    <a:bodyPr/>
-                    <a:lstStyle/>
-                    <a:p>
-                      <a:pPr>
-                        <a:defRPr sz="950">
-                          <a:solidFill>
-                            <a:srgbClr val="212529"/>
-                          </a:solidFill>
-                        </a:defRPr>
-                      </a:pPr>
-                      <a:r>
-                        <a:t>0.1133</a:t>
-                      </a:r>
-                    </a:p>
-                  </a:txBody>
-                  <a:tcPr>
-                    <a:solidFill>
-                      <a:srgbClr val="F8F9FA"/>
-                    </a:solidFill>
-                  </a:tcPr>
-                </a:tc>
-                <a:tc>
-                  <a:txBody>
-                    <a:bodyPr/>
-                    <a:lstStyle/>
-                    <a:p>
-                      <a:pPr>
-                        <a:defRPr sz="950">
-                          <a:solidFill>
-                            <a:srgbClr val="212529"/>
-                          </a:solidFill>
-                        </a:defRPr>
-                      </a:pPr>
-                      <a:r>
-                        <a:t>-0.1407</a:t>
-                      </a:r>
-                    </a:p>
-                  </a:txBody>
-                  <a:tcPr>
-                    <a:solidFill>
-                      <a:srgbClr val="F8F9FA"/>
-                    </a:solidFill>
-                  </a:tcPr>
-                </a:tc>
-                <a:tc>
-                  <a:txBody>
-                    <a:bodyPr/>
-                    <a:lstStyle/>
-                    <a:p>
-                      <a:pPr>
-                        <a:defRPr sz="950">
-                          <a:solidFill>
-                            <a:srgbClr val="212529"/>
-                          </a:solidFill>
-                        </a:defRPr>
-                      </a:pPr>
-                      <a:r>
-                        <a:t>15.99 MWh</a:t>
-                      </a:r>
-                    </a:p>
-                  </a:txBody>
-                  <a:tcPr>
-                    <a:solidFill>
-                      <a:srgbClr val="F8F9FA"/>
-                    </a:solidFill>
-                  </a:tcPr>
-                </a:tc>
-                <a:tc>
-                  <a:txBody>
-                    <a:bodyPr/>
-                    <a:lstStyle/>
-                    <a:p>
-                      <a:pPr>
-                        <a:defRPr sz="950">
-                          <a:solidFill>
-                            <a:srgbClr val="212529"/>
-                          </a:solidFill>
-                        </a:defRPr>
-                      </a:pPr>
-                      <a:r>
-                        <a:t>12.87 MWh</a:t>
-                      </a:r>
-                    </a:p>
-                  </a:txBody>
-                  <a:tcPr>
-                    <a:solidFill>
-                      <a:srgbClr val="F8F9FA"/>
-                    </a:solidFill>
-                  </a:tcPr>
-                </a:tc>
-              </a:tr>
-              <a:tr h="718457">
-                <a:tc>
-                  <a:txBody>
-                    <a:bodyPr/>
-                    <a:lstStyle/>
-                    <a:p>
-                      <a:pPr>
-                        <a:defRPr sz="950">
-                          <a:solidFill>
-                            <a:srgbClr val="212529"/>
-                          </a:solidFill>
-                        </a:defRPr>
-                      </a:pPr>
-                      <a:r>
-                        <a:t>TEY: Full OLS (8 Feat.)</a:t>
-                      </a:r>
-                    </a:p>
-                  </a:txBody>
-                  <a:tcPr>
-                    <a:solidFill>
-                      <a:srgbClr val="FFFFFF"/>
-                    </a:solidFill>
-                  </a:tcPr>
-                </a:tc>
-                <a:tc>
-                  <a:txBody>
-                    <a:bodyPr/>
-                    <a:lstStyle/>
-                    <a:p>
-                      <a:pPr>
-                        <a:defRPr sz="950">
-                          <a:solidFill>
-                            <a:srgbClr val="212529"/>
-                          </a:solidFill>
-                        </a:defRPr>
-                      </a:pPr>
-                      <a:r>
-                        <a:t>0.9977</a:t>
-                      </a:r>
-                    </a:p>
-                  </a:txBody>
-                  <a:tcPr>
-                    <a:solidFill>
-                      <a:srgbClr val="FFFFFF"/>
-                    </a:solidFill>
-                  </a:tcPr>
-                </a:tc>
-                <a:tc>
-                  <a:txBody>
-                    <a:bodyPr/>
-                    <a:lstStyle/>
-                    <a:p>
-                      <a:pPr>
-                        <a:defRPr sz="950">
-                          <a:solidFill>
-                            <a:srgbClr val="212529"/>
-                          </a:solidFill>
-                        </a:defRPr>
-                      </a:pPr>
-                      <a:r>
-                        <a:t>0.9501</a:t>
-                      </a:r>
-                    </a:p>
-                  </a:txBody>
-                  <a:tcPr>
-                    <a:solidFill>
-                      <a:srgbClr val="FFFFFF"/>
-                    </a:solidFill>
-                  </a:tcPr>
-                </a:tc>
-                <a:tc>
-                  <a:txBody>
-                    <a:bodyPr/>
-                    <a:lstStyle/>
-                    <a:p>
-                      <a:pPr>
-                        <a:defRPr sz="950">
-                          <a:solidFill>
-                            <a:srgbClr val="212529"/>
-                          </a:solidFill>
-                        </a:defRPr>
-                      </a:pPr>
-                      <a:r>
-                        <a:t>3.35 MWh</a:t>
-                      </a:r>
-                    </a:p>
-                  </a:txBody>
-                  <a:tcPr>
-                    <a:solidFill>
-                      <a:srgbClr val="FFFFFF"/>
-                    </a:solidFill>
-                  </a:tcPr>
-                </a:tc>
-                <a:tc>
-                  <a:txBody>
-                    <a:bodyPr/>
-                    <a:lstStyle/>
-                    <a:p>
-                      <a:pPr>
-                        <a:defRPr sz="950">
-                          <a:solidFill>
-                            <a:srgbClr val="212529"/>
-                          </a:solidFill>
-                        </a:defRPr>
-                      </a:pPr>
-                      <a:r>
-                        <a:t>3.18 MWh</a:t>
-                      </a:r>
-                    </a:p>
-                  </a:txBody>
-                  <a:tcPr>
-                    <a:solidFill>
-                      <a:srgbClr val="FFFFFF"/>
-                    </a:solidFill>
-                  </a:tcPr>
-                </a:tc>
-              </a:tr>
-              <a:tr h="718457">
-                <a:tc>
-                  <a:txBody>
-                    <a:bodyPr/>
-                    <a:lstStyle/>
-                    <a:p>
-                      <a:pPr>
-                        <a:defRPr sz="950">
-                          <a:solidFill>
-                            <a:srgbClr val="212529"/>
-                          </a:solidFill>
-                        </a:defRPr>
-                      </a:pPr>
-                      <a:r>
-                        <a:t>TEY: PCR (5 Components)</a:t>
-                      </a:r>
-                    </a:p>
-                  </a:txBody>
-                  <a:tcPr>
-                    <a:solidFill>
-                      <a:srgbClr val="EBF7EE"/>
-                    </a:solidFill>
-                  </a:tcPr>
-                </a:tc>
-                <a:tc>
-                  <a:txBody>
-                    <a:bodyPr/>
-                    <a:lstStyle/>
-                    <a:p>
-                      <a:pPr>
-                        <a:defRPr sz="950">
-                          <a:solidFill>
-                            <a:srgbClr val="212529"/>
-                          </a:solidFill>
-                        </a:defRPr>
-                      </a:pPr>
-                      <a:r>
-                        <a:t>0.9946</a:t>
-                      </a:r>
-                    </a:p>
-                  </a:txBody>
-                  <a:tcPr>
-                    <a:solidFill>
-                      <a:srgbClr val="EBF7EE"/>
-                    </a:solidFill>
-                  </a:tcPr>
-                </a:tc>
-                <a:tc>
-                  <a:txBody>
-                    <a:bodyPr/>
-                    <a:lstStyle/>
-                    <a:p>
-                      <a:pPr>
-                        <a:defRPr sz="950">
-                          <a:solidFill>
-                            <a:srgbClr val="212529"/>
-                          </a:solidFill>
-                        </a:defRPr>
-                      </a:pPr>
-                      <a:r>
-                        <a:t>0.9828</a:t>
-                      </a:r>
-                    </a:p>
-                  </a:txBody>
-                  <a:tcPr>
-                    <a:solidFill>
-                      <a:srgbClr val="EBF7EE"/>
-                    </a:solidFill>
-                  </a:tcPr>
-                </a:tc>
-                <a:tc>
-                  <a:txBody>
-                    <a:bodyPr/>
-                    <a:lstStyle/>
-                    <a:p>
-                      <a:pPr>
-                        <a:defRPr sz="950">
-                          <a:solidFill>
-                            <a:srgbClr val="212529"/>
-                          </a:solidFill>
-                        </a:defRPr>
-                      </a:pPr>
-                      <a:r>
-                        <a:t>1.96 MWh</a:t>
-                      </a:r>
-                    </a:p>
-                  </a:txBody>
-                  <a:tcPr>
-                    <a:solidFill>
-                      <a:srgbClr val="EBF7EE"/>
-                    </a:solidFill>
-                  </a:tcPr>
-                </a:tc>
-                <a:tc>
-                  <a:txBody>
-                    <a:bodyPr/>
-                    <a:lstStyle/>
-                    <a:p>
-                      <a:pPr>
-                        <a:defRPr sz="950">
-                          <a:solidFill>
-                            <a:srgbClr val="212529"/>
-                          </a:solidFill>
-                        </a:defRPr>
-                      </a:pPr>
-                      <a:r>
-                        <a:t>1.62 MWh</a:t>
-                      </a:r>
-                    </a:p>
-                  </a:txBody>
-                  <a:tcPr>
-                    <a:solidFill>
-                      <a:srgbClr val="EBF7EE"/>
-                    </a:solidFill>
-                  </a:tcPr>
-                </a:tc>
-              </a:tr>
-              <a:tr h="718457">
-                <a:tc>
-                  <a:txBody>
-                    <a:bodyPr/>
-                    <a:lstStyle/>
-                    <a:p>
-                      <a:pPr>
-                        <a:defRPr sz="950">
-                          <a:solidFill>
-                            <a:srgbClr val="212529"/>
-                          </a:solidFill>
-                        </a:defRPr>
-                      </a:pPr>
-                      <a:r>
-                        <a:t>CO: Linear OLS</a:t>
-                      </a:r>
-                    </a:p>
-                  </a:txBody>
-                  <a:tcPr>
-                    <a:solidFill>
-                      <a:srgbClr val="FFFFFF"/>
-                    </a:solidFill>
-                  </a:tcPr>
-                </a:tc>
-                <a:tc>
-                  <a:txBody>
-                    <a:bodyPr/>
-                    <a:lstStyle/>
-                    <a:p>
-                      <a:pPr>
-                        <a:defRPr sz="950">
-                          <a:solidFill>
-                            <a:srgbClr val="212529"/>
-                          </a:solidFill>
-                        </a:defRPr>
-                      </a:pPr>
-                      <a:r>
-                        <a:t>0.5728</a:t>
-                      </a:r>
-                    </a:p>
-                  </a:txBody>
-                  <a:tcPr>
-                    <a:solidFill>
-                      <a:srgbClr val="FFFFFF"/>
-                    </a:solidFill>
-                  </a:tcPr>
-                </a:tc>
-                <a:tc>
-                  <a:txBody>
-                    <a:bodyPr/>
-                    <a:lstStyle/>
-                    <a:p>
-                      <a:pPr>
-                        <a:defRPr sz="950">
-                          <a:solidFill>
-                            <a:srgbClr val="212529"/>
-                          </a:solidFill>
-                        </a:defRPr>
-                      </a:pPr>
-                      <a:r>
-                        <a:t>0.4195</a:t>
-                      </a:r>
-                    </a:p>
-                  </a:txBody>
-                  <a:tcPr>
-                    <a:solidFill>
-                      <a:srgbClr val="FFFFFF"/>
-                    </a:solidFill>
-                  </a:tcPr>
-                </a:tc>
-                <a:tc>
-                  <a:txBody>
-                    <a:bodyPr/>
-                    <a:lstStyle/>
-                    <a:p>
-                      <a:pPr>
-                        <a:defRPr sz="950">
-                          <a:solidFill>
-                            <a:srgbClr val="212529"/>
-                          </a:solidFill>
-                        </a:defRPr>
-                      </a:pPr>
-                      <a:r>
-                        <a:t>1.67 mg/m³</a:t>
-                      </a:r>
-                    </a:p>
-                  </a:txBody>
-                  <a:tcPr>
-                    <a:solidFill>
-                      <a:srgbClr val="FFFFFF"/>
-                    </a:solidFill>
-                  </a:tcPr>
-                </a:tc>
-                <a:tc>
-                  <a:txBody>
-                    <a:bodyPr/>
-                    <a:lstStyle/>
-                    <a:p>
-                      <a:pPr>
-                        <a:defRPr sz="950">
-                          <a:solidFill>
-                            <a:srgbClr val="212529"/>
-                          </a:solidFill>
-                        </a:defRPr>
-                      </a:pPr>
-                      <a:r>
-                        <a:t>1.11 mg/m³</a:t>
-                      </a:r>
-                    </a:p>
-                  </a:txBody>
-                  <a:tcPr>
-                    <a:solidFill>
-                      <a:srgbClr val="FFFFFF"/>
-                    </a:solidFill>
-                  </a:tcPr>
-                </a:tc>
-              </a:tr>
-              <a:tr h="718457">
-                <a:tc>
-                  <a:txBody>
-                    <a:bodyPr/>
-                    <a:lstStyle/>
-                    <a:p>
-                      <a:pPr>
-                        <a:defRPr sz="950">
-                          <a:solidFill>
-                            <a:srgbClr val="212529"/>
-                          </a:solidFill>
-                        </a:defRPr>
-                      </a:pPr>
-                      <a:r>
-                        <a:t>CO: Polynomial (Deg. 2)</a:t>
-                      </a:r>
-                    </a:p>
-                  </a:txBody>
-                  <a:tcPr>
-                    <a:solidFill>
-                      <a:srgbClr val="F8F9FA"/>
-                    </a:solidFill>
-                  </a:tcPr>
-                </a:tc>
-                <a:tc>
-                  <a:txBody>
-                    <a:bodyPr/>
-                    <a:lstStyle/>
-                    <a:p>
-                      <a:pPr>
-                        <a:defRPr sz="950">
-                          <a:solidFill>
-                            <a:srgbClr val="212529"/>
-                          </a:solidFill>
-                        </a:defRPr>
-                      </a:pPr>
-                      <a:r>
-                        <a:t>0.6439</a:t>
-                      </a:r>
-                    </a:p>
-                  </a:txBody>
-                  <a:tcPr>
-                    <a:solidFill>
-                      <a:srgbClr val="F8F9FA"/>
-                    </a:solidFill>
-                  </a:tcPr>
-                </a:tc>
-                <a:tc>
-                  <a:txBody>
-                    <a:bodyPr/>
-                    <a:lstStyle/>
-                    <a:p>
-                      <a:pPr>
-                        <a:defRPr sz="950">
-                          <a:solidFill>
-                            <a:srgbClr val="212529"/>
-                          </a:solidFill>
-                        </a:defRPr>
-                      </a:pPr>
-                      <a:r>
-                        <a:t>0.4546</a:t>
-                      </a:r>
-                    </a:p>
-                  </a:txBody>
-                  <a:tcPr>
-                    <a:solidFill>
-                      <a:srgbClr val="F8F9FA"/>
-                    </a:solidFill>
-                  </a:tcPr>
-                </a:tc>
-                <a:tc>
-                  <a:txBody>
-                    <a:bodyPr/>
-                    <a:lstStyle/>
-                    <a:p>
-                      <a:pPr>
-                        <a:defRPr sz="950">
-                          <a:solidFill>
-                            <a:srgbClr val="212529"/>
-                          </a:solidFill>
-                        </a:defRPr>
-                      </a:pPr>
-                      <a:r>
-                        <a:t>1.62 mg/m³</a:t>
-                      </a:r>
-                    </a:p>
-                  </a:txBody>
-                  <a:tcPr>
-                    <a:solidFill>
-                      <a:srgbClr val="F8F9FA"/>
-                    </a:solidFill>
-                  </a:tcPr>
-                </a:tc>
-                <a:tc>
-                  <a:txBody>
-                    <a:bodyPr/>
-                    <a:lstStyle/>
-                    <a:p>
-                      <a:pPr>
-                        <a:defRPr sz="950">
-                          <a:solidFill>
-                            <a:srgbClr val="212529"/>
-                          </a:solidFill>
-                        </a:defRPr>
-                      </a:pPr>
-                      <a:r>
-                        <a:t>1.14 mg/m³</a:t>
-                      </a:r>
-                    </a:p>
-                  </a:txBody>
-                  <a:tcPr>
-                    <a:solidFill>
-                      <a:srgbClr val="F8F9FA"/>
-                    </a:solidFill>
-                  </a:tcPr>
-                </a:tc>
-              </a:tr>
-              <a:tr h="718458">
-                <a:tc>
-                  <a:txBody>
-                    <a:bodyPr/>
-                    <a:lstStyle/>
-                    <a:p>
-                      <a:pPr>
-                        <a:defRPr sz="950">
-                          <a:solidFill>
-                            <a:srgbClr val="212529"/>
-                          </a:solidFill>
-                        </a:defRPr>
-                      </a:pPr>
-                      <a:r>
-                        <a:t>NOx: Multivariate OLS</a:t>
-                      </a:r>
-                    </a:p>
-                  </a:txBody>
-                  <a:tcPr>
-                    <a:solidFill>
-                      <a:srgbClr val="FFFFFF"/>
-                    </a:solidFill>
-                  </a:tcPr>
-                </a:tc>
-                <a:tc>
-                  <a:txBody>
-                    <a:bodyPr/>
-                    <a:lstStyle/>
-                    <a:p>
-                      <a:pPr>
-                        <a:defRPr sz="950">
-                          <a:solidFill>
-                            <a:srgbClr val="212529"/>
-                          </a:solidFill>
-                        </a:defRPr>
-                      </a:pPr>
-                      <a:r>
-                        <a:t>0.4536</a:t>
-                      </a:r>
-                    </a:p>
-                  </a:txBody>
-                  <a:tcPr>
-                    <a:solidFill>
-                      <a:srgbClr val="FFFFFF"/>
-                    </a:solidFill>
-                  </a:tcPr>
-                </a:tc>
-                <a:tc>
-                  <a:txBody>
-                    <a:bodyPr/>
-                    <a:lstStyle/>
-                    <a:p>
-                      <a:pPr>
-                        <a:defRPr sz="950">
-                          <a:solidFill>
-                            <a:srgbClr val="212529"/>
-                          </a:solidFill>
-                        </a:defRPr>
-                      </a:pPr>
-                      <a:r>
-                        <a:t>-1.0928*</a:t>
-                      </a:r>
-                    </a:p>
-                  </a:txBody>
-                  <a:tcPr>
-                    <a:solidFill>
-                      <a:srgbClr val="FFFFFF"/>
-                    </a:solidFill>
-                  </a:tcPr>
-                </a:tc>
-                <a:tc>
-                  <a:txBody>
-                    <a:bodyPr/>
-                    <a:lstStyle/>
-                    <a:p>
-                      <a:pPr>
-                        <a:defRPr sz="950">
-                          <a:solidFill>
-                            <a:srgbClr val="212529"/>
-                          </a:solidFill>
-                        </a:defRPr>
-                      </a:pPr>
-                      <a:r>
-                        <a:t>15.30 mg/m³</a:t>
-                      </a:r>
-                    </a:p>
-                  </a:txBody>
-                  <a:tcPr>
-                    <a:solidFill>
-                      <a:srgbClr val="FFFFFF"/>
-                    </a:solidFill>
-                  </a:tcPr>
-                </a:tc>
-                <a:tc>
-                  <a:txBody>
-                    <a:bodyPr/>
-                    <a:lstStyle/>
-                    <a:p>
-                      <a:pPr>
-                        <a:defRPr sz="950">
-                          <a:solidFill>
-                            <a:srgbClr val="212529"/>
-                          </a:solidFill>
-                        </a:defRPr>
-                      </a:pPr>
-                      <a:r>
-                        <a:t>13.85 mg/m³</a:t>
-                      </a:r>
-                    </a:p>
-                  </a:txBody>
-                  <a:tcPr>
-                    <a:solidFill>
-                      <a:srgbClr val="FFFFFF"/>
-                    </a:solidFill>
-                  </a:tcPr>
-                </a:tc>
-              </a:tr>
-            </a:tbl>
-          </a:graphicData>
-        </a:graphic>
-      </p:graphicFrame>
+        </p:nvSpPr>
+        <p:spPr>
+          <a:xfrm>
+            <a:off x="731520" y="1280160"/>
+            <a:ext cx="2514600" cy="1463040"/>
+          </a:xfrm>
+          <a:prstGeom prst="roundRect">
+            <a:avLst/>
+          </a:prstGeom>
+          <a:solidFill>
+            <a:srgbClr val="EBF7EE"/>
+          </a:solidFill>
+          <a:ln>
+            <a:solidFill>
+              <a:srgbClr val="28A745"/>
+            </a:solidFill>
+          </a:ln>
+        </p:spPr>
+        <p:style>
+          <a:lnRef idx="1">
+            <a:schemeClr val="accent1"/>
+          </a:lnRef>
+          <a:fillRef idx="3">
+            <a:schemeClr val="accent1"/>
+          </a:fillRef>
+          <a:effectRef idx="2">
+            <a:schemeClr val="accent1"/>
+          </a:effectRef>
+          <a:fontRef idx="minor">
+            <a:schemeClr val="lt1"/>
+          </a:fontRef>
+        </p:style>
+        <p:txBody>
+          <a:bodyPr rtlCol="0" anchor="ctr" wrap="square" lIns="137160" tIns="109728"/>
+          <a:lstStyle/>
+          <a:p>
+            <a:pPr algn="ctr">
+              <a:defRPr sz="2400" b="1">
+                <a:solidFill>
+                  <a:srgbClr val="28A745"/>
+                </a:solidFill>
+              </a:defRPr>
+            </a:pPr>
+            <a:r>
+              <a:t>98.3%</a:t>
+            </a:r>
+          </a:p>
+          <a:p>
+            <a:pPr>
+              <a:defRPr sz="1050" b="1">
+                <a:solidFill>
+                  <a:srgbClr val="212529"/>
+                </a:solidFill>
+              </a:defRPr>
+            </a:pPr>
+            <a:r>
+              <a:t>Best Test Accuracy (R²)</a:t>
+            </a:r>
+          </a:p>
+          <a:p>
+            <a:pPr>
+              <a:defRPr sz="900">
+                <a:solidFill>
+                  <a:srgbClr val="6C757D"/>
+                </a:solidFill>
+              </a:defRPr>
+            </a:pPr>
+            <a:r>
+              <a:t>Principal Component Regression (PCR)</a:t>
+            </a:r>
+          </a:p>
+        </p:txBody>
+      </p:sp>
       <p:sp>
         <p:nvSpPr>
           <p:cNvPr id="4" name="Rounded Rectangle 3"/>
@@ -9059,8 +8289,8 @@
         </p:nvSpPr>
         <p:spPr>
           <a:xfrm>
-            <a:off x="7223760" y="1371600"/>
-            <a:ext cx="4206240" cy="5029200"/>
+            <a:off x="3474720" y="1280160"/>
+            <a:ext cx="2514600" cy="1463040"/>
           </a:xfrm>
           <a:prstGeom prst="roundRect">
             <a:avLst/>
@@ -9089,122 +8319,1050 @@
           </a:fontRef>
         </p:style>
         <p:txBody>
-          <a:bodyPr rtlCol="0" anchor="ctr" wrap="square" lIns="228600" tIns="182880"/>
+          <a:bodyPr rtlCol="0" anchor="ctr" wrap="square" lIns="137160" tIns="109728"/>
           <a:lstStyle/>
           <a:p>
             <a:pPr algn="ctr">
-              <a:defRPr sz="1500" b="1">
+              <a:defRPr sz="2400" b="1">
                 <a:solidFill>
                   <a:srgbClr val="102542"/>
                 </a:solidFill>
               </a:defRPr>
             </a:pPr>
             <a:r>
-              <a:t>Key Results Highlights</a:t>
-            </a:r>
-          </a:p>
-          <a:p>
-            <a:br/>
+              <a:t>1.96 MWh</a:t>
+            </a:r>
+          </a:p>
+          <a:p>
             <a:pPr>
-              <a:defRPr b="1" sz="1100">
-                <a:solidFill>
-                  <a:srgbClr val="296299"/>
-                </a:solidFill>
-              </a:defRPr>
-            </a:pPr>
-            <a:r>
-              <a:t>1. PCR Solves Multicollinearity:</a:t>
+              <a:defRPr sz="1050" b="1">
+                <a:solidFill>
+                  <a:srgbClr val="212529"/>
+                </a:solidFill>
+              </a:defRPr>
+            </a:pPr>
+            <a:r>
+              <a:t>Out-of-Sample RMSE</a:t>
             </a:r>
           </a:p>
           <a:p>
             <a:pPr>
-              <a:defRPr sz="950">
+              <a:defRPr sz="900">
+                <a:solidFill>
+                  <a:srgbClr val="6C757D"/>
+                </a:solidFill>
+              </a:defRPr>
+            </a:pPr>
+            <a:r>
+              <a:t>Precise energy yield estimation</a:t>
+            </a:r>
+          </a:p>
+        </p:txBody>
+      </p:sp>
+      <p:sp>
+        <p:nvSpPr>
+          <p:cNvPr id="5" name="Rounded Rectangle 4"/>
+          <p:cNvSpPr/>
+          <p:nvPr/>
+        </p:nvSpPr>
+        <p:spPr>
+          <a:xfrm>
+            <a:off x="6217920" y="1280160"/>
+            <a:ext cx="2514600" cy="1463040"/>
+          </a:xfrm>
+          <a:prstGeom prst="roundRect">
+            <a:avLst/>
+          </a:prstGeom>
+          <a:solidFill>
+            <a:srgbClr val="F8F9FA"/>
+          </a:solidFill>
+          <a:ln>
+            <a:solidFill>
+              <a:srgbClr val="DCE1E6"/>
+            </a:solidFill>
+          </a:ln>
+        </p:spPr>
+        <p:style>
+          <a:lnRef idx="1">
+            <a:schemeClr val="accent1"/>
+          </a:lnRef>
+          <a:fillRef idx="3">
+            <a:schemeClr val="accent1"/>
+          </a:fillRef>
+          <a:effectRef idx="2">
+            <a:schemeClr val="accent1"/>
+          </a:effectRef>
+          <a:fontRef idx="minor">
+            <a:schemeClr val="lt1"/>
+          </a:fontRef>
+        </p:style>
+        <p:txBody>
+          <a:bodyPr rtlCol="0" anchor="ctr" wrap="square" lIns="137160" tIns="109728"/>
+          <a:lstStyle/>
+          <a:p>
+            <a:pPr algn="ctr">
+              <a:defRPr sz="2400" b="1">
+                <a:solidFill>
+                  <a:srgbClr val="102542"/>
+                </a:solidFill>
+              </a:defRPr>
+            </a:pPr>
+            <a:r>
+              <a:t>-41.4%</a:t>
+            </a:r>
+          </a:p>
+          <a:p>
+            <a:pPr>
+              <a:defRPr sz="1050" b="1">
                 <a:solidFill>
                   <a:srgbClr val="212529"/>
                 </a:solidFill>
               </a:defRPr>
             </a:pPr>
             <a:r>
-              <a:t>PCR achieves Test R² = 0.9828 with RMSE of 1.96 MWh (41.4% error reduction vs full OLS) by projecting collinear turbine pressures into orthogonal coordinates.</a:t>
-            </a:r>
-          </a:p>
-          <a:p>
-            <a:br/>
+              <a:t>Error Reduction vs OLS</a:t>
+            </a:r>
+          </a:p>
+          <a:p>
             <a:pPr>
-              <a:defRPr b="1" sz="1100">
-                <a:solidFill>
-                  <a:srgbClr val="296299"/>
-                </a:solidFill>
-              </a:defRPr>
-            </a:pPr>
-            <a:r>
-              <a:t>2. Ambient-Only Baseline Fails:</a:t>
+              <a:defRPr sz="900">
+                <a:solidFill>
+                  <a:srgbClr val="6C757D"/>
+                </a:solidFill>
+              </a:defRPr>
+            </a:pPr>
+            <a:r>
+              <a:t>Multicollinearity elimination</a:t>
+            </a:r>
+          </a:p>
+        </p:txBody>
+      </p:sp>
+      <p:sp>
+        <p:nvSpPr>
+          <p:cNvPr id="6" name="Rounded Rectangle 5"/>
+          <p:cNvSpPr/>
+          <p:nvPr/>
+        </p:nvSpPr>
+        <p:spPr>
+          <a:xfrm>
+            <a:off x="8961120" y="1280160"/>
+            <a:ext cx="2514600" cy="1463040"/>
+          </a:xfrm>
+          <a:prstGeom prst="roundRect">
+            <a:avLst/>
+          </a:prstGeom>
+          <a:solidFill>
+            <a:srgbClr val="F8F9FA"/>
+          </a:solidFill>
+          <a:ln>
+            <a:solidFill>
+              <a:srgbClr val="DCE1E6"/>
+            </a:solidFill>
+          </a:ln>
+        </p:spPr>
+        <p:style>
+          <a:lnRef idx="1">
+            <a:schemeClr val="accent1"/>
+          </a:lnRef>
+          <a:fillRef idx="3">
+            <a:schemeClr val="accent1"/>
+          </a:fillRef>
+          <a:effectRef idx="2">
+            <a:schemeClr val="accent1"/>
+          </a:effectRef>
+          <a:fontRef idx="minor">
+            <a:schemeClr val="lt1"/>
+          </a:fontRef>
+        </p:style>
+        <p:txBody>
+          <a:bodyPr rtlCol="0" anchor="ctr" wrap="square" lIns="137160" tIns="109728"/>
+          <a:lstStyle/>
+          <a:p>
+            <a:pPr algn="ctr">
+              <a:defRPr sz="2400" b="1">
+                <a:solidFill>
+                  <a:srgbClr val="102542"/>
+                </a:solidFill>
+              </a:defRPr>
+            </a:pPr>
+            <a:r>
+              <a:t>3 Regimes</a:t>
             </a:r>
           </a:p>
           <a:p>
             <a:pPr>
-              <a:defRPr sz="950">
+              <a:defRPr sz="1050" b="1">
                 <a:solidFill>
                   <a:srgbClr val="212529"/>
                 </a:solidFill>
               </a:defRPr>
             </a:pPr>
             <a:r>
-              <a:t>Ambient inputs alone yield negative out-of-sample R² (-0.14), proving internal thermodynamic telemetry is indispensable.</a:t>
-            </a:r>
-          </a:p>
-          <a:p>
-            <a:br/>
+              <a:t>Operational Clusters</a:t>
+            </a:r>
+          </a:p>
+          <a:p>
             <a:pPr>
-              <a:defRPr b="1" sz="1100">
-                <a:solidFill>
-                  <a:srgbClr val="296299"/>
-                </a:solidFill>
-              </a:defRPr>
-            </a:pPr>
-            <a:r>
-              <a:t>3. Non-linear CO Emissions:</a:t>
-            </a:r>
-          </a:p>
-          <a:p>
-            <a:pPr>
-              <a:defRPr sz="950">
-                <a:solidFill>
-                  <a:srgbClr val="212529"/>
-                </a:solidFill>
-              </a:defRPr>
-            </a:pPr>
-            <a:r>
-              <a:t>Polynomial degree 2 expansion captures steep low-load incomplete combustion spikes, increasing Train R² to 0.6439.</a:t>
-            </a:r>
-          </a:p>
-          <a:p>
-            <a:br/>
-            <a:pPr>
-              <a:defRPr b="1" sz="1100">
-                <a:solidFill>
-                  <a:srgbClr val="296299"/>
-                </a:solidFill>
-              </a:defRPr>
-            </a:pPr>
-            <a:r>
-              <a:t>4. NOx Domain Shift (*):</a:t>
-            </a:r>
-          </a:p>
-          <a:p>
-            <a:pPr>
-              <a:defRPr sz="950">
-                <a:solidFill>
-                  <a:srgbClr val="212529"/>
-                </a:solidFill>
-              </a:defRPr>
-            </a:pPr>
-            <a:r>
-              <a:t>Negative Test R² for NOx reveals a physical process shift in 2014-15 (burner recalibration lowering baseline emissions from 68 to 58 mg/m³).</a:t>
-            </a:r>
-          </a:p>
-        </p:txBody>
-      </p:sp>
+              <a:defRPr sz="900">
+                <a:solidFill>
+                  <a:srgbClr val="6C757D"/>
+                </a:solidFill>
+              </a:defRPr>
+            </a:pPr>
+            <a:r>
+              <a:t>Peak, Baseload &amp; Part-Load (K-Means)</a:t>
+            </a:r>
+          </a:p>
+        </p:txBody>
+      </p:sp>
+      <p:graphicFrame>
+        <p:nvGraphicFramePr>
+          <p:cNvPr id="7" name="Table 6"/>
+          <p:cNvGraphicFramePr>
+            <a:graphicFrameLocks noGrp="1"/>
+          </p:cNvGraphicFramePr>
+          <p:nvPr/>
+        </p:nvGraphicFramePr>
+        <p:xfrm>
+          <a:off x="731520" y="2926080"/>
+          <a:ext cx="10698480" cy="3474720"/>
+        </p:xfrm>
+        <a:graphic>
+          <a:graphicData uri="http://schemas.openxmlformats.org/drawingml/2006/table">
+            <a:tbl>
+              <a:tblPr firstRow="1" bandRow="1">
+                <a:tableStyleId>{5C22544A-7EE6-4342-B048-85BDC9FD1C3A}</a:tableStyleId>
+              </a:tblPr>
+              <a:tblGrid>
+                <a:gridCol w="3383280"/>
+                <a:gridCol w="1828800"/>
+                <a:gridCol w="1828800"/>
+                <a:gridCol w="1828800"/>
+                <a:gridCol w="1828800"/>
+              </a:tblGrid>
+              <a:tr h="496388">
+                <a:tc>
+                  <a:txBody>
+                    <a:bodyPr/>
+                    <a:lstStyle/>
+                    <a:p>
+                      <a:pPr>
+                        <a:defRPr b="1" sz="1100">
+                          <a:solidFill>
+                            <a:srgbClr val="FFFFFF"/>
+                          </a:solidFill>
+                        </a:defRPr>
+                      </a:pPr>
+                      <a:r>
+                        <a:t>Model &amp; Objective Target</a:t>
+                      </a:r>
+                    </a:p>
+                  </a:txBody>
+                  <a:tcPr>
+                    <a:solidFill>
+                      <a:srgbClr val="102542"/>
+                    </a:solidFill>
+                  </a:tcPr>
+                </a:tc>
+                <a:tc>
+                  <a:txBody>
+                    <a:bodyPr/>
+                    <a:lstStyle/>
+                    <a:p>
+                      <a:pPr>
+                        <a:defRPr b="1" sz="1100">
+                          <a:solidFill>
+                            <a:srgbClr val="FFFFFF"/>
+                          </a:solidFill>
+                        </a:defRPr>
+                      </a:pPr>
+                      <a:r>
+                        <a:t>Train R² (2011–13)</a:t>
+                      </a:r>
+                    </a:p>
+                  </a:txBody>
+                  <a:tcPr>
+                    <a:solidFill>
+                      <a:srgbClr val="102542"/>
+                    </a:solidFill>
+                  </a:tcPr>
+                </a:tc>
+                <a:tc>
+                  <a:txBody>
+                    <a:bodyPr/>
+                    <a:lstStyle/>
+                    <a:p>
+                      <a:pPr>
+                        <a:defRPr b="1" sz="1100">
+                          <a:solidFill>
+                            <a:srgbClr val="FFFFFF"/>
+                          </a:solidFill>
+                        </a:defRPr>
+                      </a:pPr>
+                      <a:r>
+                        <a:t>Test R² (2014–15)</a:t>
+                      </a:r>
+                    </a:p>
+                  </a:txBody>
+                  <a:tcPr>
+                    <a:solidFill>
+                      <a:srgbClr val="102542"/>
+                    </a:solidFill>
+                  </a:tcPr>
+                </a:tc>
+                <a:tc>
+                  <a:txBody>
+                    <a:bodyPr/>
+                    <a:lstStyle/>
+                    <a:p>
+                      <a:pPr>
+                        <a:defRPr b="1" sz="1100">
+                          <a:solidFill>
+                            <a:srgbClr val="FFFFFF"/>
+                          </a:solidFill>
+                        </a:defRPr>
+                      </a:pPr>
+                      <a:r>
+                        <a:t>Test RMSE</a:t>
+                      </a:r>
+                    </a:p>
+                  </a:txBody>
+                  <a:tcPr>
+                    <a:solidFill>
+                      <a:srgbClr val="102542"/>
+                    </a:solidFill>
+                  </a:tcPr>
+                </a:tc>
+                <a:tc>
+                  <a:txBody>
+                    <a:bodyPr/>
+                    <a:lstStyle/>
+                    <a:p>
+                      <a:pPr>
+                        <a:defRPr b="1" sz="1100">
+                          <a:solidFill>
+                            <a:srgbClr val="FFFFFF"/>
+                          </a:solidFill>
+                        </a:defRPr>
+                      </a:pPr>
+                      <a:r>
+                        <a:t>Test MAE</a:t>
+                      </a:r>
+                    </a:p>
+                  </a:txBody>
+                  <a:tcPr>
+                    <a:solidFill>
+                      <a:srgbClr val="102542"/>
+                    </a:solidFill>
+                  </a:tcPr>
+                </a:tc>
+              </a:tr>
+              <a:tr h="496388">
+                <a:tc>
+                  <a:txBody>
+                    <a:bodyPr/>
+                    <a:lstStyle/>
+                    <a:p>
+                      <a:pPr>
+                        <a:defRPr sz="1000">
+                          <a:solidFill>
+                            <a:srgbClr val="212529"/>
+                          </a:solidFill>
+                        </a:defRPr>
+                      </a:pPr>
+                      <a:r>
+                        <a:t>TEY: Ambient Baseline (AT, AP, AH)</a:t>
+                      </a:r>
+                    </a:p>
+                  </a:txBody>
+                  <a:tcPr>
+                    <a:solidFill>
+                      <a:srgbClr val="F8F9FA"/>
+                    </a:solidFill>
+                  </a:tcPr>
+                </a:tc>
+                <a:tc>
+                  <a:txBody>
+                    <a:bodyPr/>
+                    <a:lstStyle/>
+                    <a:p>
+                      <a:pPr>
+                        <a:defRPr sz="1000">
+                          <a:solidFill>
+                            <a:srgbClr val="212529"/>
+                          </a:solidFill>
+                        </a:defRPr>
+                      </a:pPr>
+                      <a:r>
+                        <a:t>0.1133</a:t>
+                      </a:r>
+                    </a:p>
+                  </a:txBody>
+                  <a:tcPr>
+                    <a:solidFill>
+                      <a:srgbClr val="F8F9FA"/>
+                    </a:solidFill>
+                  </a:tcPr>
+                </a:tc>
+                <a:tc>
+                  <a:txBody>
+                    <a:bodyPr/>
+                    <a:lstStyle/>
+                    <a:p>
+                      <a:pPr>
+                        <a:defRPr sz="1000">
+                          <a:solidFill>
+                            <a:srgbClr val="212529"/>
+                          </a:solidFill>
+                        </a:defRPr>
+                      </a:pPr>
+                      <a:r>
+                        <a:t>-0.1407</a:t>
+                      </a:r>
+                    </a:p>
+                  </a:txBody>
+                  <a:tcPr>
+                    <a:solidFill>
+                      <a:srgbClr val="F8F9FA"/>
+                    </a:solidFill>
+                  </a:tcPr>
+                </a:tc>
+                <a:tc>
+                  <a:txBody>
+                    <a:bodyPr/>
+                    <a:lstStyle/>
+                    <a:p>
+                      <a:pPr>
+                        <a:defRPr sz="1000">
+                          <a:solidFill>
+                            <a:srgbClr val="212529"/>
+                          </a:solidFill>
+                        </a:defRPr>
+                      </a:pPr>
+                      <a:r>
+                        <a:t>15.996 MWh</a:t>
+                      </a:r>
+                    </a:p>
+                  </a:txBody>
+                  <a:tcPr>
+                    <a:solidFill>
+                      <a:srgbClr val="F8F9FA"/>
+                    </a:solidFill>
+                  </a:tcPr>
+                </a:tc>
+                <a:tc>
+                  <a:txBody>
+                    <a:bodyPr/>
+                    <a:lstStyle/>
+                    <a:p>
+                      <a:pPr>
+                        <a:defRPr sz="1000">
+                          <a:solidFill>
+                            <a:srgbClr val="212529"/>
+                          </a:solidFill>
+                        </a:defRPr>
+                      </a:pPr>
+                      <a:r>
+                        <a:t>12.868 MWh</a:t>
+                      </a:r>
+                    </a:p>
+                  </a:txBody>
+                  <a:tcPr>
+                    <a:solidFill>
+                      <a:srgbClr val="F8F9FA"/>
+                    </a:solidFill>
+                  </a:tcPr>
+                </a:tc>
+              </a:tr>
+              <a:tr h="496388">
+                <a:tc>
+                  <a:txBody>
+                    <a:bodyPr/>
+                    <a:lstStyle/>
+                    <a:p>
+                      <a:pPr>
+                        <a:defRPr sz="1000">
+                          <a:solidFill>
+                            <a:srgbClr val="212529"/>
+                          </a:solidFill>
+                        </a:defRPr>
+                      </a:pPr>
+                      <a:r>
+                        <a:t>TEY: Full Multivariate OLS (8 Features)</a:t>
+                      </a:r>
+                    </a:p>
+                  </a:txBody>
+                  <a:tcPr>
+                    <a:solidFill>
+                      <a:srgbClr val="FFFFFF"/>
+                    </a:solidFill>
+                  </a:tcPr>
+                </a:tc>
+                <a:tc>
+                  <a:txBody>
+                    <a:bodyPr/>
+                    <a:lstStyle/>
+                    <a:p>
+                      <a:pPr>
+                        <a:defRPr sz="1000">
+                          <a:solidFill>
+                            <a:srgbClr val="212529"/>
+                          </a:solidFill>
+                        </a:defRPr>
+                      </a:pPr>
+                      <a:r>
+                        <a:t>0.9977</a:t>
+                      </a:r>
+                    </a:p>
+                  </a:txBody>
+                  <a:tcPr>
+                    <a:solidFill>
+                      <a:srgbClr val="FFFFFF"/>
+                    </a:solidFill>
+                  </a:tcPr>
+                </a:tc>
+                <a:tc>
+                  <a:txBody>
+                    <a:bodyPr/>
+                    <a:lstStyle/>
+                    <a:p>
+                      <a:pPr>
+                        <a:defRPr sz="1000">
+                          <a:solidFill>
+                            <a:srgbClr val="212529"/>
+                          </a:solidFill>
+                        </a:defRPr>
+                      </a:pPr>
+                      <a:r>
+                        <a:t>0.9501</a:t>
+                      </a:r>
+                    </a:p>
+                  </a:txBody>
+                  <a:tcPr>
+                    <a:solidFill>
+                      <a:srgbClr val="FFFFFF"/>
+                    </a:solidFill>
+                  </a:tcPr>
+                </a:tc>
+                <a:tc>
+                  <a:txBody>
+                    <a:bodyPr/>
+                    <a:lstStyle/>
+                    <a:p>
+                      <a:pPr>
+                        <a:defRPr sz="1000">
+                          <a:solidFill>
+                            <a:srgbClr val="212529"/>
+                          </a:solidFill>
+                        </a:defRPr>
+                      </a:pPr>
+                      <a:r>
+                        <a:t>3.346 MWh</a:t>
+                      </a:r>
+                    </a:p>
+                  </a:txBody>
+                  <a:tcPr>
+                    <a:solidFill>
+                      <a:srgbClr val="FFFFFF"/>
+                    </a:solidFill>
+                  </a:tcPr>
+                </a:tc>
+                <a:tc>
+                  <a:txBody>
+                    <a:bodyPr/>
+                    <a:lstStyle/>
+                    <a:p>
+                      <a:pPr>
+                        <a:defRPr sz="1000">
+                          <a:solidFill>
+                            <a:srgbClr val="212529"/>
+                          </a:solidFill>
+                        </a:defRPr>
+                      </a:pPr>
+                      <a:r>
+                        <a:t>3.176 MWh</a:t>
+                      </a:r>
+                    </a:p>
+                  </a:txBody>
+                  <a:tcPr>
+                    <a:solidFill>
+                      <a:srgbClr val="FFFFFF"/>
+                    </a:solidFill>
+                  </a:tcPr>
+                </a:tc>
+              </a:tr>
+              <a:tr h="496388">
+                <a:tc>
+                  <a:txBody>
+                    <a:bodyPr/>
+                    <a:lstStyle/>
+                    <a:p>
+                      <a:pPr>
+                        <a:defRPr sz="1000" b="1">
+                          <a:solidFill>
+                            <a:srgbClr val="102542"/>
+                          </a:solidFill>
+                        </a:defRPr>
+                      </a:pPr>
+                      <a:r>
+                        <a:t>TEY: PCR (5 Principal Components)</a:t>
+                      </a:r>
+                    </a:p>
+                  </a:txBody>
+                  <a:tcPr>
+                    <a:solidFill>
+                      <a:srgbClr val="EBF7EE"/>
+                    </a:solidFill>
+                  </a:tcPr>
+                </a:tc>
+                <a:tc>
+                  <a:txBody>
+                    <a:bodyPr/>
+                    <a:lstStyle/>
+                    <a:p>
+                      <a:pPr>
+                        <a:defRPr sz="1000" b="1">
+                          <a:solidFill>
+                            <a:srgbClr val="102542"/>
+                          </a:solidFill>
+                        </a:defRPr>
+                      </a:pPr>
+                      <a:r>
+                        <a:t>0.9946</a:t>
+                      </a:r>
+                    </a:p>
+                  </a:txBody>
+                  <a:tcPr>
+                    <a:solidFill>
+                      <a:srgbClr val="EBF7EE"/>
+                    </a:solidFill>
+                  </a:tcPr>
+                </a:tc>
+                <a:tc>
+                  <a:txBody>
+                    <a:bodyPr/>
+                    <a:lstStyle/>
+                    <a:p>
+                      <a:pPr>
+                        <a:defRPr sz="1000" b="1">
+                          <a:solidFill>
+                            <a:srgbClr val="102542"/>
+                          </a:solidFill>
+                        </a:defRPr>
+                      </a:pPr>
+                      <a:r>
+                        <a:t>0.9828</a:t>
+                      </a:r>
+                    </a:p>
+                  </a:txBody>
+                  <a:tcPr>
+                    <a:solidFill>
+                      <a:srgbClr val="EBF7EE"/>
+                    </a:solidFill>
+                  </a:tcPr>
+                </a:tc>
+                <a:tc>
+                  <a:txBody>
+                    <a:bodyPr/>
+                    <a:lstStyle/>
+                    <a:p>
+                      <a:pPr>
+                        <a:defRPr sz="1000" b="1">
+                          <a:solidFill>
+                            <a:srgbClr val="102542"/>
+                          </a:solidFill>
+                        </a:defRPr>
+                      </a:pPr>
+                      <a:r>
+                        <a:t>1.963 MWh</a:t>
+                      </a:r>
+                    </a:p>
+                  </a:txBody>
+                  <a:tcPr>
+                    <a:solidFill>
+                      <a:srgbClr val="EBF7EE"/>
+                    </a:solidFill>
+                  </a:tcPr>
+                </a:tc>
+                <a:tc>
+                  <a:txBody>
+                    <a:bodyPr/>
+                    <a:lstStyle/>
+                    <a:p>
+                      <a:pPr>
+                        <a:defRPr sz="1000" b="1">
+                          <a:solidFill>
+                            <a:srgbClr val="102542"/>
+                          </a:solidFill>
+                        </a:defRPr>
+                      </a:pPr>
+                      <a:r>
+                        <a:t>1.618 MWh</a:t>
+                      </a:r>
+                    </a:p>
+                  </a:txBody>
+                  <a:tcPr>
+                    <a:solidFill>
+                      <a:srgbClr val="EBF7EE"/>
+                    </a:solidFill>
+                  </a:tcPr>
+                </a:tc>
+              </a:tr>
+              <a:tr h="496388">
+                <a:tc>
+                  <a:txBody>
+                    <a:bodyPr/>
+                    <a:lstStyle/>
+                    <a:p>
+                      <a:pPr>
+                        <a:defRPr sz="1000">
+                          <a:solidFill>
+                            <a:srgbClr val="212529"/>
+                          </a:solidFill>
+                        </a:defRPr>
+                      </a:pPr>
+                      <a:r>
+                        <a:t>CO: Linear Multivariate OLS</a:t>
+                      </a:r>
+                    </a:p>
+                  </a:txBody>
+                  <a:tcPr>
+                    <a:solidFill>
+                      <a:srgbClr val="FFFFFF"/>
+                    </a:solidFill>
+                  </a:tcPr>
+                </a:tc>
+                <a:tc>
+                  <a:txBody>
+                    <a:bodyPr/>
+                    <a:lstStyle/>
+                    <a:p>
+                      <a:pPr>
+                        <a:defRPr sz="1000">
+                          <a:solidFill>
+                            <a:srgbClr val="212529"/>
+                          </a:solidFill>
+                        </a:defRPr>
+                      </a:pPr>
+                      <a:r>
+                        <a:t>0.5728</a:t>
+                      </a:r>
+                    </a:p>
+                  </a:txBody>
+                  <a:tcPr>
+                    <a:solidFill>
+                      <a:srgbClr val="FFFFFF"/>
+                    </a:solidFill>
+                  </a:tcPr>
+                </a:tc>
+                <a:tc>
+                  <a:txBody>
+                    <a:bodyPr/>
+                    <a:lstStyle/>
+                    <a:p>
+                      <a:pPr>
+                        <a:defRPr sz="1000">
+                          <a:solidFill>
+                            <a:srgbClr val="212529"/>
+                          </a:solidFill>
+                        </a:defRPr>
+                      </a:pPr>
+                      <a:r>
+                        <a:t>0.4195</a:t>
+                      </a:r>
+                    </a:p>
+                  </a:txBody>
+                  <a:tcPr>
+                    <a:solidFill>
+                      <a:srgbClr val="FFFFFF"/>
+                    </a:solidFill>
+                  </a:tcPr>
+                </a:tc>
+                <a:tc>
+                  <a:txBody>
+                    <a:bodyPr/>
+                    <a:lstStyle/>
+                    <a:p>
+                      <a:pPr>
+                        <a:defRPr sz="1000">
+                          <a:solidFill>
+                            <a:srgbClr val="212529"/>
+                          </a:solidFill>
+                        </a:defRPr>
+                      </a:pPr>
+                      <a:r>
+                        <a:t>1.668 mg/m³</a:t>
+                      </a:r>
+                    </a:p>
+                  </a:txBody>
+                  <a:tcPr>
+                    <a:solidFill>
+                      <a:srgbClr val="FFFFFF"/>
+                    </a:solidFill>
+                  </a:tcPr>
+                </a:tc>
+                <a:tc>
+                  <a:txBody>
+                    <a:bodyPr/>
+                    <a:lstStyle/>
+                    <a:p>
+                      <a:pPr>
+                        <a:defRPr sz="1000">
+                          <a:solidFill>
+                            <a:srgbClr val="212529"/>
+                          </a:solidFill>
+                        </a:defRPr>
+                      </a:pPr>
+                      <a:r>
+                        <a:t>1.110 mg/m³</a:t>
+                      </a:r>
+                    </a:p>
+                  </a:txBody>
+                  <a:tcPr>
+                    <a:solidFill>
+                      <a:srgbClr val="FFFFFF"/>
+                    </a:solidFill>
+                  </a:tcPr>
+                </a:tc>
+              </a:tr>
+              <a:tr h="496388">
+                <a:tc>
+                  <a:txBody>
+                    <a:bodyPr/>
+                    <a:lstStyle/>
+                    <a:p>
+                      <a:pPr>
+                        <a:defRPr sz="1000">
+                          <a:solidFill>
+                            <a:srgbClr val="212529"/>
+                          </a:solidFill>
+                        </a:defRPr>
+                      </a:pPr>
+                      <a:r>
+                        <a:t>CO: Polynomial (Degree 2, Slide 116)</a:t>
+                      </a:r>
+                    </a:p>
+                  </a:txBody>
+                  <a:tcPr>
+                    <a:solidFill>
+                      <a:srgbClr val="F8F9FA"/>
+                    </a:solidFill>
+                  </a:tcPr>
+                </a:tc>
+                <a:tc>
+                  <a:txBody>
+                    <a:bodyPr/>
+                    <a:lstStyle/>
+                    <a:p>
+                      <a:pPr>
+                        <a:defRPr sz="1000">
+                          <a:solidFill>
+                            <a:srgbClr val="212529"/>
+                          </a:solidFill>
+                        </a:defRPr>
+                      </a:pPr>
+                      <a:r>
+                        <a:t>0.6439</a:t>
+                      </a:r>
+                    </a:p>
+                  </a:txBody>
+                  <a:tcPr>
+                    <a:solidFill>
+                      <a:srgbClr val="F8F9FA"/>
+                    </a:solidFill>
+                  </a:tcPr>
+                </a:tc>
+                <a:tc>
+                  <a:txBody>
+                    <a:bodyPr/>
+                    <a:lstStyle/>
+                    <a:p>
+                      <a:pPr>
+                        <a:defRPr sz="1000">
+                          <a:solidFill>
+                            <a:srgbClr val="212529"/>
+                          </a:solidFill>
+                        </a:defRPr>
+                      </a:pPr>
+                      <a:r>
+                        <a:t>0.4546</a:t>
+                      </a:r>
+                    </a:p>
+                  </a:txBody>
+                  <a:tcPr>
+                    <a:solidFill>
+                      <a:srgbClr val="F8F9FA"/>
+                    </a:solidFill>
+                  </a:tcPr>
+                </a:tc>
+                <a:tc>
+                  <a:txBody>
+                    <a:bodyPr/>
+                    <a:lstStyle/>
+                    <a:p>
+                      <a:pPr>
+                        <a:defRPr sz="1000">
+                          <a:solidFill>
+                            <a:srgbClr val="212529"/>
+                          </a:solidFill>
+                        </a:defRPr>
+                      </a:pPr>
+                      <a:r>
+                        <a:t>1.617 mg/m³</a:t>
+                      </a:r>
+                    </a:p>
+                  </a:txBody>
+                  <a:tcPr>
+                    <a:solidFill>
+                      <a:srgbClr val="F8F9FA"/>
+                    </a:solidFill>
+                  </a:tcPr>
+                </a:tc>
+                <a:tc>
+                  <a:txBody>
+                    <a:bodyPr/>
+                    <a:lstStyle/>
+                    <a:p>
+                      <a:pPr>
+                        <a:defRPr sz="1000">
+                          <a:solidFill>
+                            <a:srgbClr val="212529"/>
+                          </a:solidFill>
+                        </a:defRPr>
+                      </a:pPr>
+                      <a:r>
+                        <a:t>1.138 mg/m³</a:t>
+                      </a:r>
+                    </a:p>
+                  </a:txBody>
+                  <a:tcPr>
+                    <a:solidFill>
+                      <a:srgbClr val="F8F9FA"/>
+                    </a:solidFill>
+                  </a:tcPr>
+                </a:tc>
+              </a:tr>
+              <a:tr h="496392">
+                <a:tc>
+                  <a:txBody>
+                    <a:bodyPr/>
+                    <a:lstStyle/>
+                    <a:p>
+                      <a:pPr>
+                        <a:defRPr sz="1000">
+                          <a:solidFill>
+                            <a:srgbClr val="212529"/>
+                          </a:solidFill>
+                        </a:defRPr>
+                      </a:pPr>
+                      <a:r>
+                        <a:t>NOx: Multivariate OLS</a:t>
+                      </a:r>
+                    </a:p>
+                  </a:txBody>
+                  <a:tcPr>
+                    <a:solidFill>
+                      <a:srgbClr val="FFFFFF"/>
+                    </a:solidFill>
+                  </a:tcPr>
+                </a:tc>
+                <a:tc>
+                  <a:txBody>
+                    <a:bodyPr/>
+                    <a:lstStyle/>
+                    <a:p>
+                      <a:pPr>
+                        <a:defRPr sz="1000">
+                          <a:solidFill>
+                            <a:srgbClr val="212529"/>
+                          </a:solidFill>
+                        </a:defRPr>
+                      </a:pPr>
+                      <a:r>
+                        <a:t>0.4536</a:t>
+                      </a:r>
+                    </a:p>
+                  </a:txBody>
+                  <a:tcPr>
+                    <a:solidFill>
+                      <a:srgbClr val="FFFFFF"/>
+                    </a:solidFill>
+                  </a:tcPr>
+                </a:tc>
+                <a:tc>
+                  <a:txBody>
+                    <a:bodyPr/>
+                    <a:lstStyle/>
+                    <a:p>
+                      <a:pPr>
+                        <a:defRPr sz="1000">
+                          <a:solidFill>
+                            <a:srgbClr val="212529"/>
+                          </a:solidFill>
+                        </a:defRPr>
+                      </a:pPr>
+                      <a:r>
+                        <a:t>-1.0928*</a:t>
+                      </a:r>
+                    </a:p>
+                  </a:txBody>
+                  <a:tcPr>
+                    <a:solidFill>
+                      <a:srgbClr val="FFFFFF"/>
+                    </a:solidFill>
+                  </a:tcPr>
+                </a:tc>
+                <a:tc>
+                  <a:txBody>
+                    <a:bodyPr/>
+                    <a:lstStyle/>
+                    <a:p>
+                      <a:pPr>
+                        <a:defRPr sz="1000">
+                          <a:solidFill>
+                            <a:srgbClr val="212529"/>
+                          </a:solidFill>
+                        </a:defRPr>
+                      </a:pPr>
+                      <a:r>
+                        <a:t>15.301 mg/m³</a:t>
+                      </a:r>
+                    </a:p>
+                  </a:txBody>
+                  <a:tcPr>
+                    <a:solidFill>
+                      <a:srgbClr val="FFFFFF"/>
+                    </a:solidFill>
+                  </a:tcPr>
+                </a:tc>
+                <a:tc>
+                  <a:txBody>
+                    <a:bodyPr/>
+                    <a:lstStyle/>
+                    <a:p>
+                      <a:pPr>
+                        <a:defRPr sz="1000">
+                          <a:solidFill>
+                            <a:srgbClr val="212529"/>
+                          </a:solidFill>
+                        </a:defRPr>
+                      </a:pPr>
+                      <a:r>
+                        <a:t>13.851 mg/m³</a:t>
+                      </a:r>
+                    </a:p>
+                  </a:txBody>
+                  <a:tcPr>
+                    <a:solidFill>
+                      <a:srgbClr val="FFFFFF"/>
+                    </a:solidFill>
+                  </a:tcPr>
+                </a:tc>
+              </a:tr>
+            </a:tbl>
+          </a:graphicData>
+        </a:graphic>
+      </p:graphicFrame>
     </p:spTree>
   </p:cSld>
   <p:clrMapOvr>
@@ -9267,12 +9425,12 @@
             <a:pPr algn="ctr">
               <a:defRPr sz="1100" b="1">
                 <a:solidFill>
-                  <a:srgbClr val="B4CDEB"/>
-                </a:solidFill>
-              </a:defRPr>
-            </a:pPr>
-            <a:r>
-              <a:t>DATA ANALYTICS PROJECT WORK</a:t>
+                  <a:srgbClr val="B4D7EB"/>
+                </a:solidFill>
+              </a:defRPr>
+            </a:pPr>
+            <a:r>
+              <a:t>PHASE 4: IN-DEPTH MODEL EVALUATION</a:t>
             </a:r>
           </a:p>
           <a:p>

</xml_diff>

<commit_message>
pre revisione totale della presentazione
</commit_message>
<xml_diff>
--- a/presentation.pptx
+++ b/presentation.pptx
@@ -5,20 +5,20 @@
     <p:sldMasterId id="2147483648" r:id="rId1"/>
   </p:sldMasterIdLst>
   <p:sldIdLst>
-    <p:sldId id="256" r:id="rId7"/>
-    <p:sldId id="257" r:id="rId8"/>
-    <p:sldId id="258" r:id="rId9"/>
-    <p:sldId id="259" r:id="rId10"/>
-    <p:sldId id="260" r:id="rId11"/>
-    <p:sldId id="261" r:id="rId12"/>
-    <p:sldId id="262" r:id="rId13"/>
-    <p:sldId id="263" r:id="rId14"/>
-    <p:sldId id="264" r:id="rId15"/>
-    <p:sldId id="265" r:id="rId16"/>
-    <p:sldId id="266" r:id="rId17"/>
-    <p:sldId id="267" r:id="rId18"/>
+    <p:sldId id="256" r:id="rId2"/>
+    <p:sldId id="257" r:id="rId3"/>
+    <p:sldId id="258" r:id="rId4"/>
+    <p:sldId id="259" r:id="rId5"/>
+    <p:sldId id="260" r:id="rId6"/>
+    <p:sldId id="261" r:id="rId7"/>
+    <p:sldId id="268" r:id="rId8"/>
+    <p:sldId id="263" r:id="rId9"/>
+    <p:sldId id="264" r:id="rId10"/>
+    <p:sldId id="265" r:id="rId11"/>
+    <p:sldId id="266" r:id="rId12"/>
+    <p:sldId id="267" r:id="rId13"/>
   </p:sldIdLst>
-  <p:sldSz cx="12191695" cy="6858000" type="screen4x3"/>
+  <p:sldSz cx="12192000" cy="6858000"/>
   <p:notesSz cx="6858000" cy="9144000"/>
   <p:defaultTextStyle>
     <a:defPPr>
@@ -115,6 +115,22 @@
       </a:defRPr>
     </a:lvl9pPr>
   </p:defaultTextStyle>
+  <p:extLst>
+    <p:ext uri="{EFAFB233-063F-42B5-8137-9DF3F51BA10A}">
+      <p15:sldGuideLst xmlns:p15="http://schemas.microsoft.com/office/powerpoint/2012/main">
+        <p15:guide id="1" orient="horz" pos="2160">
+          <p15:clr>
+            <a:srgbClr val="A4A3A4"/>
+          </p15:clr>
+        </p15:guide>
+        <p15:guide id="2" pos="2880">
+          <p15:clr>
+            <a:srgbClr val="A4A3A4"/>
+          </p15:clr>
+        </p15:guide>
+      </p15:sldGuideLst>
+    </p:ext>
+  </p:extLst>
 </p:presentation>
 </file>
 
@@ -156,10 +172,9 @@
           <a:lstStyle/>
           <a:p>
             <a:r>
-              <a:rPr lang="en-US" smtClean="0"/>
+              <a:rPr lang="en-US"/>
               <a:t>Click to edit Master title style</a:t>
             </a:r>
-            <a:endParaRPr lang="en-US"/>
           </a:p>
         </p:txBody>
       </p:sp>
@@ -275,10 +290,9 @@
           </a:lstStyle>
           <a:p>
             <a:r>
-              <a:rPr lang="en-US" smtClean="0"/>
+              <a:rPr lang="en-US"/>
               <a:t>Click to edit Master subtitle style</a:t>
             </a:r>
-            <a:endParaRPr lang="en-US"/>
           </a:p>
         </p:txBody>
       </p:sp>
@@ -299,7 +313,7 @@
           <a:p>
             <a:fld id="{5BCAD085-E8A6-8845-BD4E-CB4CCA059FC4}" type="datetimeFigureOut">
               <a:rPr lang="en-US" smtClean="0"/>
-              <a:t>1/27/13</a:t>
+              <a:t>9/1/2026</a:t>
             </a:fld>
             <a:endParaRPr lang="en-US"/>
           </a:p>
@@ -341,7 +355,7 @@
           <a:p>
             <a:fld id="{C1FF6DA9-008F-8B48-92A6-B652298478BF}" type="slidenum">
               <a:rPr lang="en-US" smtClean="0"/>
-              <a:t>‹#›</a:t>
+              <a:t>‹N›</a:t>
             </a:fld>
             <a:endParaRPr lang="en-US"/>
           </a:p>
@@ -393,10 +407,9 @@
           <a:lstStyle/>
           <a:p>
             <a:r>
-              <a:rPr lang="en-US" smtClean="0"/>
+              <a:rPr lang="en-US"/>
               <a:t>Click to edit Master title style</a:t>
             </a:r>
-            <a:endParaRPr lang="en-US"/>
           </a:p>
         </p:txBody>
       </p:sp>
@@ -417,38 +430,37 @@
           <a:p>
             <a:pPr lvl="0"/>
             <a:r>
-              <a:rPr lang="en-US" smtClean="0"/>
+              <a:rPr lang="en-US"/>
               <a:t>Click to edit Master text styles</a:t>
             </a:r>
           </a:p>
           <a:p>
             <a:pPr lvl="1"/>
             <a:r>
-              <a:rPr lang="en-US" smtClean="0"/>
+              <a:rPr lang="en-US"/>
               <a:t>Second level</a:t>
             </a:r>
           </a:p>
           <a:p>
             <a:pPr lvl="2"/>
             <a:r>
-              <a:rPr lang="en-US" smtClean="0"/>
+              <a:rPr lang="en-US"/>
               <a:t>Third level</a:t>
             </a:r>
           </a:p>
           <a:p>
             <a:pPr lvl="3"/>
             <a:r>
-              <a:rPr lang="en-US" smtClean="0"/>
+              <a:rPr lang="en-US"/>
               <a:t>Fourth level</a:t>
             </a:r>
           </a:p>
           <a:p>
             <a:pPr lvl="4"/>
             <a:r>
-              <a:rPr lang="en-US" smtClean="0"/>
+              <a:rPr lang="en-US"/>
               <a:t>Fifth level</a:t>
             </a:r>
-            <a:endParaRPr lang="en-US"/>
           </a:p>
         </p:txBody>
       </p:sp>
@@ -469,7 +481,7 @@
           <a:p>
             <a:fld id="{5BCAD085-E8A6-8845-BD4E-CB4CCA059FC4}" type="datetimeFigureOut">
               <a:rPr lang="en-US" smtClean="0"/>
-              <a:t>1/27/13</a:t>
+              <a:t>9/1/2026</a:t>
             </a:fld>
             <a:endParaRPr lang="en-US"/>
           </a:p>
@@ -511,7 +523,7 @@
           <a:p>
             <a:fld id="{C1FF6DA9-008F-8B48-92A6-B652298478BF}" type="slidenum">
               <a:rPr lang="en-US" smtClean="0"/>
-              <a:t>‹#›</a:t>
+              <a:t>‹N›</a:t>
             </a:fld>
             <a:endParaRPr lang="en-US"/>
           </a:p>
@@ -568,10 +580,9 @@
           <a:lstStyle/>
           <a:p>
             <a:r>
-              <a:rPr lang="en-US" smtClean="0"/>
+              <a:rPr lang="en-US"/>
               <a:t>Click to edit Master title style</a:t>
             </a:r>
-            <a:endParaRPr lang="en-US"/>
           </a:p>
         </p:txBody>
       </p:sp>
@@ -597,38 +608,37 @@
           <a:p>
             <a:pPr lvl="0"/>
             <a:r>
-              <a:rPr lang="en-US" smtClean="0"/>
+              <a:rPr lang="en-US"/>
               <a:t>Click to edit Master text styles</a:t>
             </a:r>
           </a:p>
           <a:p>
             <a:pPr lvl="1"/>
             <a:r>
-              <a:rPr lang="en-US" smtClean="0"/>
+              <a:rPr lang="en-US"/>
               <a:t>Second level</a:t>
             </a:r>
           </a:p>
           <a:p>
             <a:pPr lvl="2"/>
             <a:r>
-              <a:rPr lang="en-US" smtClean="0"/>
+              <a:rPr lang="en-US"/>
               <a:t>Third level</a:t>
             </a:r>
           </a:p>
           <a:p>
             <a:pPr lvl="3"/>
             <a:r>
-              <a:rPr lang="en-US" smtClean="0"/>
+              <a:rPr lang="en-US"/>
               <a:t>Fourth level</a:t>
             </a:r>
           </a:p>
           <a:p>
             <a:pPr lvl="4"/>
             <a:r>
-              <a:rPr lang="en-US" smtClean="0"/>
+              <a:rPr lang="en-US"/>
               <a:t>Fifth level</a:t>
             </a:r>
-            <a:endParaRPr lang="en-US"/>
           </a:p>
         </p:txBody>
       </p:sp>
@@ -649,7 +659,7 @@
           <a:p>
             <a:fld id="{5BCAD085-E8A6-8845-BD4E-CB4CCA059FC4}" type="datetimeFigureOut">
               <a:rPr lang="en-US" smtClean="0"/>
-              <a:t>1/27/13</a:t>
+              <a:t>9/1/2026</a:t>
             </a:fld>
             <a:endParaRPr lang="en-US"/>
           </a:p>
@@ -691,7 +701,7 @@
           <a:p>
             <a:fld id="{C1FF6DA9-008F-8B48-92A6-B652298478BF}" type="slidenum">
               <a:rPr lang="en-US" smtClean="0"/>
-              <a:t>‹#›</a:t>
+              <a:t>‹N›</a:t>
             </a:fld>
             <a:endParaRPr lang="en-US"/>
           </a:p>
@@ -743,10 +753,9 @@
           <a:lstStyle/>
           <a:p>
             <a:r>
-              <a:rPr lang="en-US" smtClean="0"/>
+              <a:rPr lang="en-US"/>
               <a:t>Click to edit Master title style</a:t>
             </a:r>
-            <a:endParaRPr lang="en-US"/>
           </a:p>
         </p:txBody>
       </p:sp>
@@ -767,38 +776,37 @@
           <a:p>
             <a:pPr lvl="0"/>
             <a:r>
-              <a:rPr lang="en-US" smtClean="0"/>
+              <a:rPr lang="en-US"/>
               <a:t>Click to edit Master text styles</a:t>
             </a:r>
           </a:p>
           <a:p>
             <a:pPr lvl="1"/>
             <a:r>
-              <a:rPr lang="en-US" smtClean="0"/>
+              <a:rPr lang="en-US"/>
               <a:t>Second level</a:t>
             </a:r>
           </a:p>
           <a:p>
             <a:pPr lvl="2"/>
             <a:r>
-              <a:rPr lang="en-US" smtClean="0"/>
+              <a:rPr lang="en-US"/>
               <a:t>Third level</a:t>
             </a:r>
           </a:p>
           <a:p>
             <a:pPr lvl="3"/>
             <a:r>
-              <a:rPr lang="en-US" smtClean="0"/>
+              <a:rPr lang="en-US"/>
               <a:t>Fourth level</a:t>
             </a:r>
           </a:p>
           <a:p>
             <a:pPr lvl="4"/>
             <a:r>
-              <a:rPr lang="en-US" smtClean="0"/>
+              <a:rPr lang="en-US"/>
               <a:t>Fifth level</a:t>
             </a:r>
-            <a:endParaRPr lang="en-US"/>
           </a:p>
         </p:txBody>
       </p:sp>
@@ -819,7 +827,7 @@
           <a:p>
             <a:fld id="{5BCAD085-E8A6-8845-BD4E-CB4CCA059FC4}" type="datetimeFigureOut">
               <a:rPr lang="en-US" smtClean="0"/>
-              <a:t>1/27/13</a:t>
+              <a:t>9/1/2026</a:t>
             </a:fld>
             <a:endParaRPr lang="en-US"/>
           </a:p>
@@ -861,7 +869,7 @@
           <a:p>
             <a:fld id="{C1FF6DA9-008F-8B48-92A6-B652298478BF}" type="slidenum">
               <a:rPr lang="en-US" smtClean="0"/>
-              <a:t>‹#›</a:t>
+              <a:t>‹N›</a:t>
             </a:fld>
             <a:endParaRPr lang="en-US"/>
           </a:p>
@@ -922,10 +930,9 @@
           </a:lstStyle>
           <a:p>
             <a:r>
-              <a:rPr lang="en-US" smtClean="0"/>
+              <a:rPr lang="en-US"/>
               <a:t>Click to edit Master title style</a:t>
             </a:r>
-            <a:endParaRPr lang="en-US"/>
           </a:p>
         </p:txBody>
       </p:sp>
@@ -1042,7 +1049,7 @@
           <a:p>
             <a:pPr lvl="0"/>
             <a:r>
-              <a:rPr lang="en-US" smtClean="0"/>
+              <a:rPr lang="en-US"/>
               <a:t>Click to edit Master text styles</a:t>
             </a:r>
           </a:p>
@@ -1065,7 +1072,7 @@
           <a:p>
             <a:fld id="{5BCAD085-E8A6-8845-BD4E-CB4CCA059FC4}" type="datetimeFigureOut">
               <a:rPr lang="en-US" smtClean="0"/>
-              <a:t>1/27/13</a:t>
+              <a:t>9/1/2026</a:t>
             </a:fld>
             <a:endParaRPr lang="en-US"/>
           </a:p>
@@ -1107,7 +1114,7 @@
           <a:p>
             <a:fld id="{C1FF6DA9-008F-8B48-92A6-B652298478BF}" type="slidenum">
               <a:rPr lang="en-US" smtClean="0"/>
-              <a:t>‹#›</a:t>
+              <a:t>‹N›</a:t>
             </a:fld>
             <a:endParaRPr lang="en-US"/>
           </a:p>
@@ -1159,10 +1166,9 @@
           <a:lstStyle/>
           <a:p>
             <a:r>
-              <a:rPr lang="en-US" smtClean="0"/>
+              <a:rPr lang="en-US"/>
               <a:t>Click to edit Master title style</a:t>
             </a:r>
-            <a:endParaRPr lang="en-US"/>
           </a:p>
         </p:txBody>
       </p:sp>
@@ -1216,38 +1222,37 @@
           <a:p>
             <a:pPr lvl="0"/>
             <a:r>
-              <a:rPr lang="en-US" smtClean="0"/>
+              <a:rPr lang="en-US"/>
               <a:t>Click to edit Master text styles</a:t>
             </a:r>
           </a:p>
           <a:p>
             <a:pPr lvl="1"/>
             <a:r>
-              <a:rPr lang="en-US" smtClean="0"/>
+              <a:rPr lang="en-US"/>
               <a:t>Second level</a:t>
             </a:r>
           </a:p>
           <a:p>
             <a:pPr lvl="2"/>
             <a:r>
-              <a:rPr lang="en-US" smtClean="0"/>
+              <a:rPr lang="en-US"/>
               <a:t>Third level</a:t>
             </a:r>
           </a:p>
           <a:p>
             <a:pPr lvl="3"/>
             <a:r>
-              <a:rPr lang="en-US" smtClean="0"/>
+              <a:rPr lang="en-US"/>
               <a:t>Fourth level</a:t>
             </a:r>
           </a:p>
           <a:p>
             <a:pPr lvl="4"/>
             <a:r>
-              <a:rPr lang="en-US" smtClean="0"/>
+              <a:rPr lang="en-US"/>
               <a:t>Fifth level</a:t>
             </a:r>
-            <a:endParaRPr lang="en-US"/>
           </a:p>
         </p:txBody>
       </p:sp>
@@ -1301,38 +1306,37 @@
           <a:p>
             <a:pPr lvl="0"/>
             <a:r>
-              <a:rPr lang="en-US" smtClean="0"/>
+              <a:rPr lang="en-US"/>
               <a:t>Click to edit Master text styles</a:t>
             </a:r>
           </a:p>
           <a:p>
             <a:pPr lvl="1"/>
             <a:r>
-              <a:rPr lang="en-US" smtClean="0"/>
+              <a:rPr lang="en-US"/>
               <a:t>Second level</a:t>
             </a:r>
           </a:p>
           <a:p>
             <a:pPr lvl="2"/>
             <a:r>
-              <a:rPr lang="en-US" smtClean="0"/>
+              <a:rPr lang="en-US"/>
               <a:t>Third level</a:t>
             </a:r>
           </a:p>
           <a:p>
             <a:pPr lvl="3"/>
             <a:r>
-              <a:rPr lang="en-US" smtClean="0"/>
+              <a:rPr lang="en-US"/>
               <a:t>Fourth level</a:t>
             </a:r>
           </a:p>
           <a:p>
             <a:pPr lvl="4"/>
             <a:r>
-              <a:rPr lang="en-US" smtClean="0"/>
+              <a:rPr lang="en-US"/>
               <a:t>Fifth level</a:t>
             </a:r>
-            <a:endParaRPr lang="en-US"/>
           </a:p>
         </p:txBody>
       </p:sp>
@@ -1353,7 +1357,7 @@
           <a:p>
             <a:fld id="{5BCAD085-E8A6-8845-BD4E-CB4CCA059FC4}" type="datetimeFigureOut">
               <a:rPr lang="en-US" smtClean="0"/>
-              <a:t>1/27/13</a:t>
+              <a:t>9/1/2026</a:t>
             </a:fld>
             <a:endParaRPr lang="en-US"/>
           </a:p>
@@ -1395,7 +1399,7 @@
           <a:p>
             <a:fld id="{C1FF6DA9-008F-8B48-92A6-B652298478BF}" type="slidenum">
               <a:rPr lang="en-US" smtClean="0"/>
-              <a:t>‹#›</a:t>
+              <a:t>‹N›</a:t>
             </a:fld>
             <a:endParaRPr lang="en-US"/>
           </a:p>
@@ -1451,10 +1455,9 @@
           </a:lstStyle>
           <a:p>
             <a:r>
-              <a:rPr lang="en-US" smtClean="0"/>
+              <a:rPr lang="en-US"/>
               <a:t>Click to edit Master title style</a:t>
             </a:r>
-            <a:endParaRPr lang="en-US"/>
           </a:p>
         </p:txBody>
       </p:sp>
@@ -1517,7 +1520,7 @@
           <a:p>
             <a:pPr lvl="0"/>
             <a:r>
-              <a:rPr lang="en-US" smtClean="0"/>
+              <a:rPr lang="en-US"/>
               <a:t>Click to edit Master text styles</a:t>
             </a:r>
           </a:p>
@@ -1573,38 +1576,37 @@
           <a:p>
             <a:pPr lvl="0"/>
             <a:r>
-              <a:rPr lang="en-US" smtClean="0"/>
+              <a:rPr lang="en-US"/>
               <a:t>Click to edit Master text styles</a:t>
             </a:r>
           </a:p>
           <a:p>
             <a:pPr lvl="1"/>
             <a:r>
-              <a:rPr lang="en-US" smtClean="0"/>
+              <a:rPr lang="en-US"/>
               <a:t>Second level</a:t>
             </a:r>
           </a:p>
           <a:p>
             <a:pPr lvl="2"/>
             <a:r>
-              <a:rPr lang="en-US" smtClean="0"/>
+              <a:rPr lang="en-US"/>
               <a:t>Third level</a:t>
             </a:r>
           </a:p>
           <a:p>
             <a:pPr lvl="3"/>
             <a:r>
-              <a:rPr lang="en-US" smtClean="0"/>
+              <a:rPr lang="en-US"/>
               <a:t>Fourth level</a:t>
             </a:r>
           </a:p>
           <a:p>
             <a:pPr lvl="4"/>
             <a:r>
-              <a:rPr lang="en-US" smtClean="0"/>
+              <a:rPr lang="en-US"/>
               <a:t>Fifth level</a:t>
             </a:r>
-            <a:endParaRPr lang="en-US"/>
           </a:p>
         </p:txBody>
       </p:sp>
@@ -1667,7 +1669,7 @@
           <a:p>
             <a:pPr lvl="0"/>
             <a:r>
-              <a:rPr lang="en-US" smtClean="0"/>
+              <a:rPr lang="en-US"/>
               <a:t>Click to edit Master text styles</a:t>
             </a:r>
           </a:p>
@@ -1723,38 +1725,37 @@
           <a:p>
             <a:pPr lvl="0"/>
             <a:r>
-              <a:rPr lang="en-US" smtClean="0"/>
+              <a:rPr lang="en-US"/>
               <a:t>Click to edit Master text styles</a:t>
             </a:r>
           </a:p>
           <a:p>
             <a:pPr lvl="1"/>
             <a:r>
-              <a:rPr lang="en-US" smtClean="0"/>
+              <a:rPr lang="en-US"/>
               <a:t>Second level</a:t>
             </a:r>
           </a:p>
           <a:p>
             <a:pPr lvl="2"/>
             <a:r>
-              <a:rPr lang="en-US" smtClean="0"/>
+              <a:rPr lang="en-US"/>
               <a:t>Third level</a:t>
             </a:r>
           </a:p>
           <a:p>
             <a:pPr lvl="3"/>
             <a:r>
-              <a:rPr lang="en-US" smtClean="0"/>
+              <a:rPr lang="en-US"/>
               <a:t>Fourth level</a:t>
             </a:r>
           </a:p>
           <a:p>
             <a:pPr lvl="4"/>
             <a:r>
-              <a:rPr lang="en-US" smtClean="0"/>
+              <a:rPr lang="en-US"/>
               <a:t>Fifth level</a:t>
             </a:r>
-            <a:endParaRPr lang="en-US"/>
           </a:p>
         </p:txBody>
       </p:sp>
@@ -1775,7 +1776,7 @@
           <a:p>
             <a:fld id="{5BCAD085-E8A6-8845-BD4E-CB4CCA059FC4}" type="datetimeFigureOut">
               <a:rPr lang="en-US" smtClean="0"/>
-              <a:t>1/27/13</a:t>
+              <a:t>9/1/2026</a:t>
             </a:fld>
             <a:endParaRPr lang="en-US"/>
           </a:p>
@@ -1817,7 +1818,7 @@
           <a:p>
             <a:fld id="{C1FF6DA9-008F-8B48-92A6-B652298478BF}" type="slidenum">
               <a:rPr lang="en-US" smtClean="0"/>
-              <a:t>‹#›</a:t>
+              <a:t>‹N›</a:t>
             </a:fld>
             <a:endParaRPr lang="en-US"/>
           </a:p>
@@ -1869,10 +1870,9 @@
           <a:lstStyle/>
           <a:p>
             <a:r>
-              <a:rPr lang="en-US" smtClean="0"/>
+              <a:rPr lang="en-US"/>
               <a:t>Click to edit Master title style</a:t>
             </a:r>
-            <a:endParaRPr lang="en-US"/>
           </a:p>
         </p:txBody>
       </p:sp>
@@ -1893,7 +1893,7 @@
           <a:p>
             <a:fld id="{5BCAD085-E8A6-8845-BD4E-CB4CCA059FC4}" type="datetimeFigureOut">
               <a:rPr lang="en-US" smtClean="0"/>
-              <a:t>1/27/13</a:t>
+              <a:t>9/1/2026</a:t>
             </a:fld>
             <a:endParaRPr lang="en-US"/>
           </a:p>
@@ -1935,7 +1935,7 @@
           <a:p>
             <a:fld id="{C1FF6DA9-008F-8B48-92A6-B652298478BF}" type="slidenum">
               <a:rPr lang="en-US" smtClean="0"/>
-              <a:t>‹#›</a:t>
+              <a:t>‹N›</a:t>
             </a:fld>
             <a:endParaRPr lang="en-US"/>
           </a:p>
@@ -1988,7 +1988,7 @@
           <a:p>
             <a:fld id="{5BCAD085-E8A6-8845-BD4E-CB4CCA059FC4}" type="datetimeFigureOut">
               <a:rPr lang="en-US" smtClean="0"/>
-              <a:t>1/27/13</a:t>
+              <a:t>9/1/2026</a:t>
             </a:fld>
             <a:endParaRPr lang="en-US"/>
           </a:p>
@@ -2030,7 +2030,7 @@
           <a:p>
             <a:fld id="{C1FF6DA9-008F-8B48-92A6-B652298478BF}" type="slidenum">
               <a:rPr lang="en-US" smtClean="0"/>
-              <a:t>‹#›</a:t>
+              <a:t>‹N›</a:t>
             </a:fld>
             <a:endParaRPr lang="en-US"/>
           </a:p>
@@ -2091,10 +2091,9 @@
           </a:lstStyle>
           <a:p>
             <a:r>
-              <a:rPr lang="en-US" smtClean="0"/>
+              <a:rPr lang="en-US"/>
               <a:t>Click to edit Master title style</a:t>
             </a:r>
-            <a:endParaRPr lang="en-US"/>
           </a:p>
         </p:txBody>
       </p:sp>
@@ -2148,38 +2147,37 @@
           <a:p>
             <a:pPr lvl="0"/>
             <a:r>
-              <a:rPr lang="en-US" smtClean="0"/>
+              <a:rPr lang="en-US"/>
               <a:t>Click to edit Master text styles</a:t>
             </a:r>
           </a:p>
           <a:p>
             <a:pPr lvl="1"/>
             <a:r>
-              <a:rPr lang="en-US" smtClean="0"/>
+              <a:rPr lang="en-US"/>
               <a:t>Second level</a:t>
             </a:r>
           </a:p>
           <a:p>
             <a:pPr lvl="2"/>
             <a:r>
-              <a:rPr lang="en-US" smtClean="0"/>
+              <a:rPr lang="en-US"/>
               <a:t>Third level</a:t>
             </a:r>
           </a:p>
           <a:p>
             <a:pPr lvl="3"/>
             <a:r>
-              <a:rPr lang="en-US" smtClean="0"/>
+              <a:rPr lang="en-US"/>
               <a:t>Fourth level</a:t>
             </a:r>
           </a:p>
           <a:p>
             <a:pPr lvl="4"/>
             <a:r>
-              <a:rPr lang="en-US" smtClean="0"/>
+              <a:rPr lang="en-US"/>
               <a:t>Fifth level</a:t>
             </a:r>
-            <a:endParaRPr lang="en-US"/>
           </a:p>
         </p:txBody>
       </p:sp>
@@ -2242,7 +2240,7 @@
           <a:p>
             <a:pPr lvl="0"/>
             <a:r>
-              <a:rPr lang="en-US" smtClean="0"/>
+              <a:rPr lang="en-US"/>
               <a:t>Click to edit Master text styles</a:t>
             </a:r>
           </a:p>
@@ -2265,7 +2263,7 @@
           <a:p>
             <a:fld id="{5BCAD085-E8A6-8845-BD4E-CB4CCA059FC4}" type="datetimeFigureOut">
               <a:rPr lang="en-US" smtClean="0"/>
-              <a:t>1/27/13</a:t>
+              <a:t>9/1/2026</a:t>
             </a:fld>
             <a:endParaRPr lang="en-US"/>
           </a:p>
@@ -2307,7 +2305,7 @@
           <a:p>
             <a:fld id="{C1FF6DA9-008F-8B48-92A6-B652298478BF}" type="slidenum">
               <a:rPr lang="en-US" smtClean="0"/>
-              <a:t>‹#›</a:t>
+              <a:t>‹N›</a:t>
             </a:fld>
             <a:endParaRPr lang="en-US"/>
           </a:p>
@@ -2368,10 +2366,9 @@
           </a:lstStyle>
           <a:p>
             <a:r>
-              <a:rPr lang="en-US" smtClean="0"/>
+              <a:rPr lang="en-US"/>
               <a:t>Click to edit Master title style</a:t>
             </a:r>
-            <a:endParaRPr lang="en-US"/>
           </a:p>
         </p:txBody>
       </p:sp>
@@ -2495,7 +2492,7 @@
           <a:p>
             <a:pPr lvl="0"/>
             <a:r>
-              <a:rPr lang="en-US" smtClean="0"/>
+              <a:rPr lang="en-US"/>
               <a:t>Click to edit Master text styles</a:t>
             </a:r>
           </a:p>
@@ -2518,7 +2515,7 @@
           <a:p>
             <a:fld id="{5BCAD085-E8A6-8845-BD4E-CB4CCA059FC4}" type="datetimeFigureOut">
               <a:rPr lang="en-US" smtClean="0"/>
-              <a:t>1/27/13</a:t>
+              <a:t>9/1/2026</a:t>
             </a:fld>
             <a:endParaRPr lang="en-US"/>
           </a:p>
@@ -2560,7 +2557,7 @@
           <a:p>
             <a:fld id="{C1FF6DA9-008F-8B48-92A6-B652298478BF}" type="slidenum">
               <a:rPr lang="en-US" smtClean="0"/>
-              <a:t>‹#›</a:t>
+              <a:t>‹N›</a:t>
             </a:fld>
             <a:endParaRPr lang="en-US"/>
           </a:p>
@@ -2627,10 +2624,9 @@
           <a:lstStyle/>
           <a:p>
             <a:r>
-              <a:rPr lang="en-US" smtClean="0"/>
+              <a:rPr lang="en-US"/>
               <a:t>Click to edit Master title style</a:t>
             </a:r>
-            <a:endParaRPr lang="en-US"/>
           </a:p>
         </p:txBody>
       </p:sp>
@@ -2661,38 +2657,37 @@
           <a:p>
             <a:pPr lvl="0"/>
             <a:r>
-              <a:rPr lang="en-US" smtClean="0"/>
+              <a:rPr lang="en-US"/>
               <a:t>Click to edit Master text styles</a:t>
             </a:r>
           </a:p>
           <a:p>
             <a:pPr lvl="1"/>
             <a:r>
-              <a:rPr lang="en-US" smtClean="0"/>
+              <a:rPr lang="en-US"/>
               <a:t>Second level</a:t>
             </a:r>
           </a:p>
           <a:p>
             <a:pPr lvl="2"/>
             <a:r>
-              <a:rPr lang="en-US" smtClean="0"/>
+              <a:rPr lang="en-US"/>
               <a:t>Third level</a:t>
             </a:r>
           </a:p>
           <a:p>
             <a:pPr lvl="3"/>
             <a:r>
-              <a:rPr lang="en-US" smtClean="0"/>
+              <a:rPr lang="en-US"/>
               <a:t>Fourth level</a:t>
             </a:r>
           </a:p>
           <a:p>
             <a:pPr lvl="4"/>
             <a:r>
-              <a:rPr lang="en-US" smtClean="0"/>
+              <a:rPr lang="en-US"/>
               <a:t>Fifth level</a:t>
             </a:r>
-            <a:endParaRPr lang="en-US"/>
           </a:p>
         </p:txBody>
       </p:sp>
@@ -2731,7 +2726,7 @@
           <a:p>
             <a:fld id="{5BCAD085-E8A6-8845-BD4E-CB4CCA059FC4}" type="datetimeFigureOut">
               <a:rPr lang="en-US" smtClean="0"/>
-              <a:t>1/27/13</a:t>
+              <a:t>9/1/2026</a:t>
             </a:fld>
             <a:endParaRPr lang="en-US"/>
           </a:p>
@@ -2809,7 +2804,7 @@
           <a:p>
             <a:fld id="{C1FF6DA9-008F-8B48-92A6-B652298478BF}" type="slidenum">
               <a:rPr lang="en-US" smtClean="0"/>
-              <a:t>‹#›</a:t>
+              <a:t>‹N›</a:t>
             </a:fld>
             <a:endParaRPr lang="en-US"/>
           </a:p>
@@ -3090,7 +3085,7 @@
 </file>
 
 <file path=ppt/slides/slide1.xml><?xml version="1.0" encoding="utf-8"?>
-<p:sld xmlns:a="http://schemas.openxmlformats.org/drawingml/2006/main" xmlns:p="http://schemas.openxmlformats.org/presentationml/2006/main" xmlns:r="http://schemas.openxmlformats.org/officeDocument/2006/relationships">
+<p:sld xmlns:a="http://schemas.openxmlformats.org/drawingml/2006/main" xmlns:r="http://schemas.openxmlformats.org/officeDocument/2006/relationships" xmlns:p="http://schemas.openxmlformats.org/presentationml/2006/main">
   <p:cSld>
     <p:spTree>
       <p:nvGrpSpPr>
@@ -3098,7 +3093,14 @@
         <p:cNvGrpSpPr/>
         <p:nvPr/>
       </p:nvGrpSpPr>
-      <p:grpSpPr/>
+      <p:grpSpPr>
+        <a:xfrm>
+          <a:off x="0" y="0"/>
+          <a:ext cx="0" cy="0"/>
+          <a:chOff x="0" y="0"/>
+          <a:chExt cx="0" cy="0"/>
+        </a:xfrm>
+      </p:grpSpPr>
       <p:sp>
         <p:nvSpPr>
           <p:cNvPr id="2" name="Rectangle 1"/>
@@ -3141,6 +3143,7 @@
           <a:lstStyle/>
           <a:p>
             <a:pPr algn="ctr"/>
+            <a:endParaRPr/>
           </a:p>
         </p:txBody>
       </p:sp>
@@ -3191,13 +3194,6 @@
           </a:p>
           <a:p>
             <a:br/>
-            <a:pPr>
-              <a:defRPr sz="1400">
-                <a:solidFill>
-                  <a:srgbClr val="C8D7E6"/>
-                </a:solidFill>
-              </a:defRPr>
-            </a:pPr>
             <a:r>
               <a:t>Course: Data Analytics (and Data Driven Decision) — University of L'Aquila</a:t>
             </a:r>
@@ -3217,7 +3213,7 @@
 </file>
 
 <file path=ppt/slides/slide10.xml><?xml version="1.0" encoding="utf-8"?>
-<p:sld xmlns:a="http://schemas.openxmlformats.org/drawingml/2006/main" xmlns:p="http://schemas.openxmlformats.org/presentationml/2006/main" xmlns:r="http://schemas.openxmlformats.org/officeDocument/2006/relationships">
+<p:sld xmlns:a="http://schemas.openxmlformats.org/drawingml/2006/main" xmlns:r="http://schemas.openxmlformats.org/officeDocument/2006/relationships" xmlns:p="http://schemas.openxmlformats.org/presentationml/2006/main">
   <p:cSld>
     <p:spTree>
       <p:nvGrpSpPr>
@@ -3225,7 +3221,14 @@
         <p:cNvGrpSpPr/>
         <p:nvPr/>
       </p:nvGrpSpPr>
-      <p:grpSpPr/>
+      <p:grpSpPr>
+        <a:xfrm>
+          <a:off x="0" y="0"/>
+          <a:ext cx="0" cy="0"/>
+          <a:chOff x="0" y="0"/>
+          <a:chExt cx="0" cy="0"/>
+        </a:xfrm>
+      </p:grpSpPr>
       <p:sp>
         <p:nvSpPr>
           <p:cNvPr id="2" name="Rectangle 1"/>
@@ -3264,7 +3267,7 @@
           </a:fontRef>
         </p:style>
         <p:txBody>
-          <a:bodyPr rtlCol="0" anchor="ctr" wrap="square" lIns="731520" tIns="137160"/>
+          <a:bodyPr wrap="square" lIns="731520" tIns="137160" rtlCol="0" anchor="ctr"/>
           <a:lstStyle/>
           <a:p>
             <a:pPr algn="ctr">
@@ -3275,6 +3278,7 @@
               </a:defRPr>
             </a:pPr>
             <a:r>
+              <a:rPr dirty="0"/>
               <a:t>PHASE 4: IN-DEPTH MODEL EVALUATION</a:t>
             </a:r>
           </a:p>
@@ -3287,6 +3291,7 @@
               </a:defRPr>
             </a:pPr>
             <a:r>
+              <a:rPr dirty="0"/>
               <a:t>6. Detailed Results: Emissions Modeling &amp; Operational Regimes</a:t>
             </a:r>
           </a:p>
@@ -3330,7 +3335,7 @@
           </a:fontRef>
         </p:style>
         <p:txBody>
-          <a:bodyPr rtlCol="0" anchor="ctr" wrap="square" lIns="228600" tIns="182880"/>
+          <a:bodyPr wrap="square" lIns="228600" tIns="182880" rtlCol="0" anchor="ctr"/>
           <a:lstStyle/>
           <a:p>
             <a:pPr algn="ctr">
@@ -3341,19 +3346,16 @@
               </a:defRPr>
             </a:pPr>
             <a:r>
+              <a:rPr dirty="0"/>
               <a:t>Emissions Modeling &amp; K-Means Clusters</a:t>
             </a:r>
           </a:p>
           <a:p>
-            <a:br/>
-            <a:pPr>
-              <a:defRPr b="1" sz="1100">
-                <a:solidFill>
-                  <a:srgbClr val="296299"/>
-                </a:solidFill>
-              </a:defRPr>
-            </a:pPr>
-            <a:r>
+            <a:br>
+              <a:rPr dirty="0"/>
+            </a:br>
+            <a:r>
+              <a:rPr dirty="0"/>
               <a:t>CO Polynomial Enhancement (Slide 116):</a:t>
             </a:r>
           </a:p>
@@ -3366,23 +3368,23 @@
               </a:defRPr>
             </a:pPr>
             <a:r>
+              <a:rPr dirty="0"/>
               <a:t>• Adding quadratic feature terms ($x \to [x, x^2]$) increases Train R² to 0.6477 (RMSE = 1.36 mg/m³).</a:t>
             </a:r>
-            <a:br/>
-            <a:r>
+            <a:br>
+              <a:rPr dirty="0"/>
+            </a:br>
+            <a:r>
+              <a:rPr dirty="0"/>
               <a:t>• Captures the non-linear inflection below 1070°C where incomplete combustion surges exponentially.</a:t>
             </a:r>
           </a:p>
           <a:p>
-            <a:br/>
-            <a:pPr>
-              <a:defRPr b="1" sz="1100">
-                <a:solidFill>
-                  <a:srgbClr val="296299"/>
-                </a:solidFill>
-              </a:defRPr>
-            </a:pPr>
-            <a:r>
+            <a:br>
+              <a:rPr dirty="0"/>
+            </a:br>
+            <a:r>
+              <a:rPr dirty="0"/>
               <a:t>NOx Domain Shift Analysis (*):</a:t>
             </a:r>
           </a:p>
@@ -3395,19 +3397,16 @@
               </a:defRPr>
             </a:pPr>
             <a:r>
+              <a:rPr dirty="0"/>
               <a:t>• Negative out-of-sample Test R² (-1.0928) reflects a plant hardware/burner recalibration in 2014–15 (baseline NOx dropped from 68.8 to 58.5 mg/m³).</a:t>
             </a:r>
           </a:p>
           <a:p>
-            <a:br/>
-            <a:pPr>
-              <a:defRPr b="1" sz="1100">
-                <a:solidFill>
-                  <a:srgbClr val="296299"/>
-                </a:solidFill>
-              </a:defRPr>
-            </a:pPr>
-            <a:r>
+            <a:br>
+              <a:rPr dirty="0"/>
+            </a:br>
+            <a:r>
+              <a:rPr dirty="0"/>
               <a:t>Operational Regimes Profile (K=3, Silhouette = 0.3023):</a:t>
             </a:r>
           </a:p>
@@ -3420,15 +3419,46 @@
               </a:defRPr>
             </a:pPr>
             <a:r>
-              <a:t>• Peak Load (4,309 hrs): TEY = 158.2 MWh, TIT = 1100°C, CDP = 13.8 mbar $\implies$ CO = 1.00 mg/m³.</a:t>
-            </a:r>
-            <a:br/>
-            <a:r>
-              <a:t>• Nominal Load (7,820 hrs): TEY = 134.5 MWh, TIT = 1091°C, CDP = 12.2 mbar $\implies$ CO = 1.48 mg/m³.</a:t>
-            </a:r>
-            <a:br/>
-            <a:r>
-              <a:t>• Part Load (10,062 hrs): TEY = 122.3 MWh, TIT = 1070°C, CDP = 11.2 mbar $\implies$ CO = 3.30 mg/m³ (3.3x higher!).</a:t>
+              <a:rPr dirty="0"/>
+              <a:t>• Peak Load (4,309 </a:t>
+            </a:r>
+            <a:r>
+              <a:rPr dirty="0" err="1"/>
+              <a:t>hrs</a:t>
+            </a:r>
+            <a:r>
+              <a:rPr dirty="0"/>
+              <a:t>): TEY = 158.2 MWh, TIT = 1100°C, CDP = 13.8 mbar $\implies$ CO = 1.00 mg/m³.</a:t>
+            </a:r>
+            <a:br>
+              <a:rPr dirty="0"/>
+            </a:br>
+            <a:r>
+              <a:rPr dirty="0"/>
+              <a:t>• Nominal Load (7,820 </a:t>
+            </a:r>
+            <a:r>
+              <a:rPr dirty="0" err="1"/>
+              <a:t>hrs</a:t>
+            </a:r>
+            <a:r>
+              <a:rPr dirty="0"/>
+              <a:t>): TEY = 134.5 MWh, TIT = 1091°C, CDP = 12.2 mbar $\implies$ CO = 1.48 mg/m³.</a:t>
+            </a:r>
+            <a:br>
+              <a:rPr dirty="0"/>
+            </a:br>
+            <a:r>
+              <a:rPr dirty="0"/>
+              <a:t>• Part Load (10,062 </a:t>
+            </a:r>
+            <a:r>
+              <a:rPr dirty="0" err="1"/>
+              <a:t>hrs</a:t>
+            </a:r>
+            <a:r>
+              <a:rPr dirty="0"/>
+              <a:t>): TEY = 122.3 MWh, TIT = 1070°C, CDP = 11.2 mbar $\implies$ CO = 3.30 mg/m³ (3.3x higher!).</a:t>
             </a:r>
           </a:p>
         </p:txBody>
@@ -3442,7 +3472,7 @@
 </file>
 
 <file path=ppt/slides/slide11.xml><?xml version="1.0" encoding="utf-8"?>
-<p:sld xmlns:a="http://schemas.openxmlformats.org/drawingml/2006/main" xmlns:p="http://schemas.openxmlformats.org/presentationml/2006/main" xmlns:r="http://schemas.openxmlformats.org/officeDocument/2006/relationships">
+<p:sld xmlns:a="http://schemas.openxmlformats.org/drawingml/2006/main" xmlns:r="http://schemas.openxmlformats.org/officeDocument/2006/relationships" xmlns:p="http://schemas.openxmlformats.org/presentationml/2006/main">
   <p:cSld>
     <p:spTree>
       <p:nvGrpSpPr>
@@ -3450,7 +3480,14 @@
         <p:cNvGrpSpPr/>
         <p:nvPr/>
       </p:nvGrpSpPr>
-      <p:grpSpPr/>
+      <p:grpSpPr>
+        <a:xfrm>
+          <a:off x="0" y="0"/>
+          <a:ext cx="0" cy="0"/>
+          <a:chOff x="0" y="0"/>
+          <a:chExt cx="0" cy="0"/>
+        </a:xfrm>
+      </p:grpSpPr>
       <p:sp>
         <p:nvSpPr>
           <p:cNvPr id="2" name="Rectangle 1"/>
@@ -3489,7 +3526,7 @@
           </a:fontRef>
         </p:style>
         <p:txBody>
-          <a:bodyPr rtlCol="0" anchor="ctr" wrap="square" lIns="731520" tIns="137160"/>
+          <a:bodyPr wrap="square" lIns="731520" tIns="137160" rtlCol="0" anchor="ctr"/>
           <a:lstStyle/>
           <a:p>
             <a:pPr algn="ctr">
@@ -3555,7 +3592,7 @@
           </a:fontRef>
         </p:style>
         <p:txBody>
-          <a:bodyPr rtlCol="0" anchor="ctr" wrap="square" lIns="228600" tIns="182880"/>
+          <a:bodyPr wrap="square" lIns="228600" tIns="182880" rtlCol="0" anchor="ctr"/>
           <a:lstStyle/>
           <a:p>
             <a:pPr algn="ctr">
@@ -3566,27 +3603,30 @@
               </a:defRPr>
             </a:pPr>
             <a:r>
+              <a:rPr dirty="0"/>
               <a:t>1. Methodological Justifications</a:t>
             </a:r>
           </a:p>
           <a:p>
-            <a:br/>
-            <a:pPr>
-              <a:defRPr sz="1050">
-                <a:solidFill>
-                  <a:srgbClr val="212529"/>
-                </a:solidFill>
-              </a:defRPr>
-            </a:pPr>
-            <a:r>
+            <a:br>
+              <a:rPr dirty="0"/>
+            </a:br>
+            <a:r>
+              <a:rPr dirty="0"/>
               <a:t>• Multicollinearity: VIF &gt; 250 proved that raw sensor telemetry is collinear. PCR on 4 orthogonal components captured 90.76% of variance, ensuring parameter stability.</a:t>
             </a:r>
-            <a:br/>
-            <a:r>
+            <a:br>
+              <a:rPr dirty="0"/>
+            </a:br>
+            <a:r>
+              <a:rPr dirty="0"/>
               <a:t>• Non-linear Physics: CO follows non-linear thermal oxidation kinetics; degree-2 polynomial expansion resolved the inflection point.</a:t>
             </a:r>
-            <a:br/>
-            <a:r>
+            <a:br>
+              <a:rPr dirty="0"/>
+            </a:br>
+            <a:r>
+              <a:rPr dirty="0"/>
               <a:t>• Unsupervised Regimes: K-Means (K=3) partitioned turbine operations into distinct thermodynamic states.</a:t>
             </a:r>
           </a:p>
@@ -3630,7 +3670,7 @@
           </a:fontRef>
         </p:style>
         <p:txBody>
-          <a:bodyPr rtlCol="0" anchor="ctr" wrap="square" lIns="228600" tIns="182880"/>
+          <a:bodyPr wrap="square" lIns="228600" tIns="182880" rtlCol="0" anchor="ctr"/>
           <a:lstStyle/>
           <a:p>
             <a:pPr algn="ctr">
@@ -3646,13 +3686,6 @@
           </a:p>
           <a:p>
             <a:br/>
-            <a:pPr>
-              <a:defRPr sz="1050">
-                <a:solidFill>
-                  <a:srgbClr val="212529"/>
-                </a:solidFill>
-              </a:defRPr>
-            </a:pPr>
             <a:r>
               <a:t>• Avoid Low Firing Regimes: Part-load operation below 1070°C firing produces 3.3x higher CO emissions.</a:t>
             </a:r>
@@ -3705,7 +3738,7 @@
           </a:fontRef>
         </p:style>
         <p:txBody>
-          <a:bodyPr rtlCol="0" anchor="ctr" wrap="square" lIns="228600" tIns="182880"/>
+          <a:bodyPr wrap="square" lIns="228600" tIns="182880" rtlCol="0" anchor="ctr"/>
           <a:lstStyle/>
           <a:p>
             <a:pPr algn="ctr">
@@ -3716,27 +3749,30 @@
               </a:defRPr>
             </a:pPr>
             <a:r>
+              <a:rPr dirty="0"/>
               <a:t>3. Digital Twin &amp; Deployment</a:t>
             </a:r>
           </a:p>
           <a:p>
-            <a:br/>
-            <a:pPr>
-              <a:defRPr sz="1050">
-                <a:solidFill>
-                  <a:srgbClr val="212529"/>
-                </a:solidFill>
-              </a:defRPr>
-            </a:pPr>
-            <a:r>
+            <a:br>
+              <a:rPr dirty="0"/>
+            </a:br>
+            <a:r>
+              <a:rPr dirty="0"/>
               <a:t>• Real-Time Monitoring: The lightweight 4-component PCR model can run in real-time on edge turbine PLCs for anomaly detection.</a:t>
             </a:r>
-            <a:br/>
-            <a:r>
+            <a:br>
+              <a:rPr dirty="0"/>
+            </a:br>
+            <a:r>
+              <a:rPr dirty="0"/>
               <a:t>• Sensor Redundancy: High collinearity allows synthetic sensor estimation if a pressure transducer fails in operation.</a:t>
             </a:r>
-            <a:br/>
-            <a:r>
+            <a:br>
+              <a:rPr dirty="0"/>
+            </a:br>
+            <a:r>
+              <a:rPr dirty="0"/>
               <a:t>• Regulatory Compliance: Predictive emission models enable preemptive flue gas compliance adjustments.</a:t>
             </a:r>
           </a:p>
@@ -3751,7 +3787,7 @@
 </file>
 
 <file path=ppt/slides/slide12.xml><?xml version="1.0" encoding="utf-8"?>
-<p:sld xmlns:a="http://schemas.openxmlformats.org/drawingml/2006/main" xmlns:p="http://schemas.openxmlformats.org/presentationml/2006/main" xmlns:r="http://schemas.openxmlformats.org/officeDocument/2006/relationships">
+<p:sld xmlns:a="http://schemas.openxmlformats.org/drawingml/2006/main" xmlns:r="http://schemas.openxmlformats.org/officeDocument/2006/relationships" xmlns:p="http://schemas.openxmlformats.org/presentationml/2006/main">
   <p:cSld>
     <p:spTree>
       <p:nvGrpSpPr>
@@ -3759,7 +3795,14 @@
         <p:cNvGrpSpPr/>
         <p:nvPr/>
       </p:nvGrpSpPr>
-      <p:grpSpPr/>
+      <p:grpSpPr>
+        <a:xfrm>
+          <a:off x="0" y="0"/>
+          <a:ext cx="0" cy="0"/>
+          <a:chOff x="0" y="0"/>
+          <a:chExt cx="0" cy="0"/>
+        </a:xfrm>
+      </p:grpSpPr>
       <p:sp>
         <p:nvSpPr>
           <p:cNvPr id="2" name="Rectangle 1"/>
@@ -3802,6 +3845,7 @@
           <a:lstStyle/>
           <a:p>
             <a:pPr algn="ctr"/>
+            <a:endParaRPr/>
           </a:p>
         </p:txBody>
       </p:sp>
@@ -3850,6 +3894,7 @@
               <a:t>Questions &amp; Technical Discussion</a:t>
             </a:r>
             <a:br/>
+            <a:endParaRPr/>
           </a:p>
           <a:p>
             <a:pPr>
@@ -3882,7 +3927,7 @@
 </file>
 
 <file path=ppt/slides/slide2.xml><?xml version="1.0" encoding="utf-8"?>
-<p:sld xmlns:a="http://schemas.openxmlformats.org/drawingml/2006/main" xmlns:p="http://schemas.openxmlformats.org/presentationml/2006/main" xmlns:r="http://schemas.openxmlformats.org/officeDocument/2006/relationships">
+<p:sld xmlns:a="http://schemas.openxmlformats.org/drawingml/2006/main" xmlns:r="http://schemas.openxmlformats.org/officeDocument/2006/relationships" xmlns:p="http://schemas.openxmlformats.org/presentationml/2006/main">
   <p:cSld>
     <p:spTree>
       <p:nvGrpSpPr>
@@ -3890,7 +3935,14 @@
         <p:cNvGrpSpPr/>
         <p:nvPr/>
       </p:nvGrpSpPr>
-      <p:grpSpPr/>
+      <p:grpSpPr>
+        <a:xfrm>
+          <a:off x="0" y="0"/>
+          <a:ext cx="0" cy="0"/>
+          <a:chOff x="0" y="0"/>
+          <a:chExt cx="0" cy="0"/>
+        </a:xfrm>
+      </p:grpSpPr>
       <p:sp>
         <p:nvSpPr>
           <p:cNvPr id="2" name="Rectangle 1"/>
@@ -3929,7 +3981,7 @@
           </a:fontRef>
         </p:style>
         <p:txBody>
-          <a:bodyPr rtlCol="0" anchor="ctr" wrap="square" lIns="731520" tIns="137160"/>
+          <a:bodyPr wrap="square" lIns="731520" tIns="137160" rtlCol="0" anchor="ctr"/>
           <a:lstStyle/>
           <a:p>
             <a:pPr algn="ctr">
@@ -3995,7 +4047,7 @@
           </a:fontRef>
         </p:style>
         <p:txBody>
-          <a:bodyPr rtlCol="0" anchor="ctr" wrap="square" lIns="182880" tIns="137160"/>
+          <a:bodyPr wrap="square" lIns="182880" tIns="137160" rtlCol="0" anchor="ctr"/>
           <a:lstStyle/>
           <a:p>
             <a:pPr algn="ctr">
@@ -4061,7 +4113,7 @@
           </a:fontRef>
         </p:style>
         <p:txBody>
-          <a:bodyPr rtlCol="0" anchor="ctr" wrap="square" lIns="182880" tIns="137160"/>
+          <a:bodyPr wrap="square" lIns="182880" tIns="137160" rtlCol="0" anchor="ctr"/>
           <a:lstStyle/>
           <a:p>
             <a:pPr algn="ctr">
@@ -4127,7 +4179,7 @@
           </a:fontRef>
         </p:style>
         <p:txBody>
-          <a:bodyPr rtlCol="0" anchor="ctr" wrap="square" lIns="182880" tIns="137160"/>
+          <a:bodyPr wrap="square" lIns="182880" tIns="137160" rtlCol="0" anchor="ctr"/>
           <a:lstStyle/>
           <a:p>
             <a:pPr algn="ctr">
@@ -4193,7 +4245,7 @@
           </a:fontRef>
         </p:style>
         <p:txBody>
-          <a:bodyPr rtlCol="0" anchor="ctr" wrap="square" lIns="182880" tIns="137160"/>
+          <a:bodyPr wrap="square" lIns="182880" tIns="137160" rtlCol="0" anchor="ctr"/>
           <a:lstStyle/>
           <a:p>
             <a:pPr algn="ctr">
@@ -4259,7 +4311,7 @@
           </a:fontRef>
         </p:style>
         <p:txBody>
-          <a:bodyPr rtlCol="0" anchor="ctr" wrap="square" lIns="182880" tIns="137160"/>
+          <a:bodyPr wrap="square" lIns="182880" tIns="137160" rtlCol="0" anchor="ctr"/>
           <a:lstStyle/>
           <a:p>
             <a:pPr algn="ctr">
@@ -4325,7 +4377,7 @@
           </a:fontRef>
         </p:style>
         <p:txBody>
-          <a:bodyPr rtlCol="0" anchor="ctr" wrap="square" lIns="182880" tIns="137160"/>
+          <a:bodyPr wrap="square" lIns="182880" tIns="137160" rtlCol="0" anchor="ctr"/>
           <a:lstStyle/>
           <a:p>
             <a:pPr algn="ctr">
@@ -4391,7 +4443,7 @@
           </a:fontRef>
         </p:style>
         <p:txBody>
-          <a:bodyPr rtlCol="0" anchor="ctr" wrap="square" lIns="182880" tIns="137160"/>
+          <a:bodyPr wrap="square" lIns="182880" tIns="137160" rtlCol="0" anchor="ctr"/>
           <a:lstStyle/>
           <a:p>
             <a:pPr algn="ctr">
@@ -4428,7 +4480,7 @@
 </file>
 
 <file path=ppt/slides/slide3.xml><?xml version="1.0" encoding="utf-8"?>
-<p:sld xmlns:a="http://schemas.openxmlformats.org/drawingml/2006/main" xmlns:p="http://schemas.openxmlformats.org/presentationml/2006/main" xmlns:r="http://schemas.openxmlformats.org/officeDocument/2006/relationships">
+<p:sld xmlns:a="http://schemas.openxmlformats.org/drawingml/2006/main" xmlns:r="http://schemas.openxmlformats.org/officeDocument/2006/relationships" xmlns:p="http://schemas.openxmlformats.org/presentationml/2006/main">
   <p:cSld>
     <p:spTree>
       <p:nvGrpSpPr>
@@ -4436,7 +4488,14 @@
         <p:cNvGrpSpPr/>
         <p:nvPr/>
       </p:nvGrpSpPr>
-      <p:grpSpPr/>
+      <p:grpSpPr>
+        <a:xfrm>
+          <a:off x="0" y="0"/>
+          <a:ext cx="0" cy="0"/>
+          <a:chOff x="0" y="0"/>
+          <a:chExt cx="0" cy="0"/>
+        </a:xfrm>
+      </p:grpSpPr>
       <p:sp>
         <p:nvSpPr>
           <p:cNvPr id="2" name="Rectangle 1"/>
@@ -4475,7 +4534,7 @@
           </a:fontRef>
         </p:style>
         <p:txBody>
-          <a:bodyPr rtlCol="0" anchor="ctr" wrap="square" lIns="731520" tIns="137160"/>
+          <a:bodyPr wrap="square" lIns="731520" tIns="137160" rtlCol="0" anchor="ctr"/>
           <a:lstStyle/>
           <a:p>
             <a:pPr algn="ctr">
@@ -4541,7 +4600,7 @@
           </a:fontRef>
         </p:style>
         <p:txBody>
-          <a:bodyPr rtlCol="0" anchor="ctr" wrap="square" lIns="228600" tIns="228600"/>
+          <a:bodyPr wrap="square" lIns="228600" tIns="228600" rtlCol="0" anchor="ctr"/>
           <a:lstStyle/>
           <a:p>
             <a:pPr algn="ctr">
@@ -4664,10 +4723,34 @@
                 <a:tableStyleId>{5C22544A-7EE6-4342-B048-85BDC9FD1C3A}</a:tableStyleId>
               </a:tblPr>
               <a:tblGrid>
-                <a:gridCol w="1371600"/>
-                <a:gridCol w="1005840"/>
-                <a:gridCol w="914400"/>
-                <a:gridCol w="3474720"/>
+                <a:gridCol w="1371600">
+                  <a:extLst>
+                    <a:ext uri="{9D8B030D-6E8A-4147-A177-3AD203B41FA5}">
+                      <a16:colId xmlns:a16="http://schemas.microsoft.com/office/drawing/2014/main" val="20000"/>
+                    </a:ext>
+                  </a:extLst>
+                </a:gridCol>
+                <a:gridCol w="1005840">
+                  <a:extLst>
+                    <a:ext uri="{9D8B030D-6E8A-4147-A177-3AD203B41FA5}">
+                      <a16:colId xmlns:a16="http://schemas.microsoft.com/office/drawing/2014/main" val="20001"/>
+                    </a:ext>
+                  </a:extLst>
+                </a:gridCol>
+                <a:gridCol w="914400">
+                  <a:extLst>
+                    <a:ext uri="{9D8B030D-6E8A-4147-A177-3AD203B41FA5}">
+                      <a16:colId xmlns:a16="http://schemas.microsoft.com/office/drawing/2014/main" val="20002"/>
+                    </a:ext>
+                  </a:extLst>
+                </a:gridCol>
+                <a:gridCol w="3474720">
+                  <a:extLst>
+                    <a:ext uri="{9D8B030D-6E8A-4147-A177-3AD203B41FA5}">
+                      <a16:colId xmlns:a16="http://schemas.microsoft.com/office/drawing/2014/main" val="20003"/>
+                    </a:ext>
+                  </a:extLst>
+                </a:gridCol>
               </a:tblGrid>
               <a:tr h="419100">
                 <a:tc>
@@ -4676,7 +4759,7 @@
                     <a:lstStyle/>
                     <a:p>
                       <a:pPr>
-                        <a:defRPr b="1" sz="1100">
+                        <a:defRPr sz="1100" b="1">
                           <a:solidFill>
                             <a:srgbClr val="FFFFFF"/>
                           </a:solidFill>
@@ -4699,7 +4782,7 @@
                     <a:lstStyle/>
                     <a:p>
                       <a:pPr>
-                        <a:defRPr b="1" sz="1100">
+                        <a:defRPr sz="1100" b="1">
                           <a:solidFill>
                             <a:srgbClr val="FFFFFF"/>
                           </a:solidFill>
@@ -4722,7 +4805,7 @@
                     <a:lstStyle/>
                     <a:p>
                       <a:pPr>
-                        <a:defRPr b="1" sz="1100">
+                        <a:defRPr sz="1100" b="1">
                           <a:solidFill>
                             <a:srgbClr val="FFFFFF"/>
                           </a:solidFill>
@@ -4745,7 +4828,7 @@
                     <a:lstStyle/>
                     <a:p>
                       <a:pPr>
-                        <a:defRPr b="1" sz="1100">
+                        <a:defRPr sz="1100" b="1">
                           <a:solidFill>
                             <a:srgbClr val="FFFFFF"/>
                           </a:solidFill>
@@ -4762,6 +4845,11 @@
                     </a:solidFill>
                   </a:tcPr>
                 </a:tc>
+                <a:extLst>
+                  <a:ext uri="{0D108BD9-81ED-4DB2-BD59-A6C34878D82A}">
+                    <a16:rowId xmlns:a16="http://schemas.microsoft.com/office/drawing/2014/main" val="10000"/>
+                  </a:ext>
+                </a:extLst>
               </a:tr>
               <a:tr h="419100">
                 <a:tc>
@@ -4856,6 +4944,11 @@
                     </a:solidFill>
                   </a:tcPr>
                 </a:tc>
+                <a:extLst>
+                  <a:ext uri="{0D108BD9-81ED-4DB2-BD59-A6C34878D82A}">
+                    <a16:rowId xmlns:a16="http://schemas.microsoft.com/office/drawing/2014/main" val="10001"/>
+                  </a:ext>
+                </a:extLst>
               </a:tr>
               <a:tr h="419100">
                 <a:tc>
@@ -4950,6 +5043,11 @@
                     </a:solidFill>
                   </a:tcPr>
                 </a:tc>
+                <a:extLst>
+                  <a:ext uri="{0D108BD9-81ED-4DB2-BD59-A6C34878D82A}">
+                    <a16:rowId xmlns:a16="http://schemas.microsoft.com/office/drawing/2014/main" val="10002"/>
+                  </a:ext>
+                </a:extLst>
               </a:tr>
               <a:tr h="419100">
                 <a:tc>
@@ -5044,6 +5142,11 @@
                     </a:solidFill>
                   </a:tcPr>
                 </a:tc>
+                <a:extLst>
+                  <a:ext uri="{0D108BD9-81ED-4DB2-BD59-A6C34878D82A}">
+                    <a16:rowId xmlns:a16="http://schemas.microsoft.com/office/drawing/2014/main" val="10003"/>
+                  </a:ext>
+                </a:extLst>
               </a:tr>
               <a:tr h="419100">
                 <a:tc>
@@ -5138,6 +5241,11 @@
                     </a:solidFill>
                   </a:tcPr>
                 </a:tc>
+                <a:extLst>
+                  <a:ext uri="{0D108BD9-81ED-4DB2-BD59-A6C34878D82A}">
+                    <a16:rowId xmlns:a16="http://schemas.microsoft.com/office/drawing/2014/main" val="10004"/>
+                  </a:ext>
+                </a:extLst>
               </a:tr>
               <a:tr h="419100">
                 <a:tc>
@@ -5232,6 +5340,11 @@
                     </a:solidFill>
                   </a:tcPr>
                 </a:tc>
+                <a:extLst>
+                  <a:ext uri="{0D108BD9-81ED-4DB2-BD59-A6C34878D82A}">
+                    <a16:rowId xmlns:a16="http://schemas.microsoft.com/office/drawing/2014/main" val="10005"/>
+                  </a:ext>
+                </a:extLst>
               </a:tr>
               <a:tr h="419100">
                 <a:tc>
@@ -5326,6 +5439,11 @@
                     </a:solidFill>
                   </a:tcPr>
                 </a:tc>
+                <a:extLst>
+                  <a:ext uri="{0D108BD9-81ED-4DB2-BD59-A6C34878D82A}">
+                    <a16:rowId xmlns:a16="http://schemas.microsoft.com/office/drawing/2014/main" val="10006"/>
+                  </a:ext>
+                </a:extLst>
               </a:tr>
               <a:tr h="419100">
                 <a:tc>
@@ -5420,6 +5538,11 @@
                     </a:solidFill>
                   </a:tcPr>
                 </a:tc>
+                <a:extLst>
+                  <a:ext uri="{0D108BD9-81ED-4DB2-BD59-A6C34878D82A}">
+                    <a16:rowId xmlns:a16="http://schemas.microsoft.com/office/drawing/2014/main" val="10007"/>
+                  </a:ext>
+                </a:extLst>
               </a:tr>
               <a:tr h="419100">
                 <a:tc>
@@ -5514,6 +5637,11 @@
                     </a:solidFill>
                   </a:tcPr>
                 </a:tc>
+                <a:extLst>
+                  <a:ext uri="{0D108BD9-81ED-4DB2-BD59-A6C34878D82A}">
+                    <a16:rowId xmlns:a16="http://schemas.microsoft.com/office/drawing/2014/main" val="10008"/>
+                  </a:ext>
+                </a:extLst>
               </a:tr>
               <a:tr h="419100">
                 <a:tc>
@@ -5608,6 +5736,11 @@
                     </a:solidFill>
                   </a:tcPr>
                 </a:tc>
+                <a:extLst>
+                  <a:ext uri="{0D108BD9-81ED-4DB2-BD59-A6C34878D82A}">
+                    <a16:rowId xmlns:a16="http://schemas.microsoft.com/office/drawing/2014/main" val="10009"/>
+                  </a:ext>
+                </a:extLst>
               </a:tr>
               <a:tr h="419100">
                 <a:tc>
@@ -5702,6 +5835,11 @@
                     </a:solidFill>
                   </a:tcPr>
                 </a:tc>
+                <a:extLst>
+                  <a:ext uri="{0D108BD9-81ED-4DB2-BD59-A6C34878D82A}">
+                    <a16:rowId xmlns:a16="http://schemas.microsoft.com/office/drawing/2014/main" val="10010"/>
+                  </a:ext>
+                </a:extLst>
               </a:tr>
               <a:tr h="419100">
                 <a:tc>
@@ -5796,6 +5934,11 @@
                     </a:solidFill>
                   </a:tcPr>
                 </a:tc>
+                <a:extLst>
+                  <a:ext uri="{0D108BD9-81ED-4DB2-BD59-A6C34878D82A}">
+                    <a16:rowId xmlns:a16="http://schemas.microsoft.com/office/drawing/2014/main" val="10011"/>
+                  </a:ext>
+                </a:extLst>
               </a:tr>
             </a:tbl>
           </a:graphicData>
@@ -5810,7 +5953,7 @@
 </file>
 
 <file path=ppt/slides/slide4.xml><?xml version="1.0" encoding="utf-8"?>
-<p:sld xmlns:a="http://schemas.openxmlformats.org/drawingml/2006/main" xmlns:p="http://schemas.openxmlformats.org/presentationml/2006/main" xmlns:r="http://schemas.openxmlformats.org/officeDocument/2006/relationships">
+<p:sld xmlns:a="http://schemas.openxmlformats.org/drawingml/2006/main" xmlns:r="http://schemas.openxmlformats.org/officeDocument/2006/relationships" xmlns:p="http://schemas.openxmlformats.org/presentationml/2006/main">
   <p:cSld>
     <p:spTree>
       <p:nvGrpSpPr>
@@ -5818,7 +5961,14 @@
         <p:cNvGrpSpPr/>
         <p:nvPr/>
       </p:nvGrpSpPr>
-      <p:grpSpPr/>
+      <p:grpSpPr>
+        <a:xfrm>
+          <a:off x="0" y="0"/>
+          <a:ext cx="0" cy="0"/>
+          <a:chOff x="0" y="0"/>
+          <a:chExt cx="0" cy="0"/>
+        </a:xfrm>
+      </p:grpSpPr>
       <p:sp>
         <p:nvSpPr>
           <p:cNvPr id="2" name="Rectangle 1"/>
@@ -5857,7 +6007,7 @@
           </a:fontRef>
         </p:style>
         <p:txBody>
-          <a:bodyPr rtlCol="0" anchor="ctr" wrap="square" lIns="731520" tIns="137160"/>
+          <a:bodyPr wrap="square" lIns="731520" tIns="137160" rtlCol="0" anchor="ctr"/>
           <a:lstStyle/>
           <a:p>
             <a:pPr algn="ctr">
@@ -5923,7 +6073,7 @@
           </a:fontRef>
         </p:style>
         <p:txBody>
-          <a:bodyPr rtlCol="0" anchor="ctr" wrap="square" lIns="182880" tIns="182880"/>
+          <a:bodyPr wrap="square" lIns="182880" tIns="182880" rtlCol="0" anchor="ctr"/>
           <a:lstStyle/>
           <a:p>
             <a:pPr algn="ctr">
@@ -6025,7 +6175,7 @@
           </a:fontRef>
         </p:style>
         <p:txBody>
-          <a:bodyPr rtlCol="0" anchor="ctr" wrap="square" lIns="182880" tIns="182880"/>
+          <a:bodyPr wrap="square" lIns="182880" tIns="182880" rtlCol="0" anchor="ctr"/>
           <a:lstStyle/>
           <a:p>
             <a:pPr algn="ctr">
@@ -6139,7 +6289,7 @@
           </a:fontRef>
         </p:style>
         <p:txBody>
-          <a:bodyPr rtlCol="0" anchor="ctr" wrap="square" lIns="182880" tIns="182880"/>
+          <a:bodyPr wrap="square" lIns="182880" tIns="182880" rtlCol="0" anchor="ctr"/>
           <a:lstStyle/>
           <a:p>
             <a:pPr algn="ctr">
@@ -6222,12 +6372,48 @@
                 <a:tableStyleId>{5C22544A-7EE6-4342-B048-85BDC9FD1C3A}</a:tableStyleId>
               </a:tblPr>
               <a:tblGrid>
-                <a:gridCol w="1783080"/>
-                <a:gridCol w="1783080"/>
-                <a:gridCol w="1783080"/>
-                <a:gridCol w="1783080"/>
-                <a:gridCol w="1783080"/>
-                <a:gridCol w="1783080"/>
+                <a:gridCol w="1783080">
+                  <a:extLst>
+                    <a:ext uri="{9D8B030D-6E8A-4147-A177-3AD203B41FA5}">
+                      <a16:colId xmlns:a16="http://schemas.microsoft.com/office/drawing/2014/main" val="20000"/>
+                    </a:ext>
+                  </a:extLst>
+                </a:gridCol>
+                <a:gridCol w="1783080">
+                  <a:extLst>
+                    <a:ext uri="{9D8B030D-6E8A-4147-A177-3AD203B41FA5}">
+                      <a16:colId xmlns:a16="http://schemas.microsoft.com/office/drawing/2014/main" val="20001"/>
+                    </a:ext>
+                  </a:extLst>
+                </a:gridCol>
+                <a:gridCol w="1783080">
+                  <a:extLst>
+                    <a:ext uri="{9D8B030D-6E8A-4147-A177-3AD203B41FA5}">
+                      <a16:colId xmlns:a16="http://schemas.microsoft.com/office/drawing/2014/main" val="20002"/>
+                    </a:ext>
+                  </a:extLst>
+                </a:gridCol>
+                <a:gridCol w="1783080">
+                  <a:extLst>
+                    <a:ext uri="{9D8B030D-6E8A-4147-A177-3AD203B41FA5}">
+                      <a16:colId xmlns:a16="http://schemas.microsoft.com/office/drawing/2014/main" val="20003"/>
+                    </a:ext>
+                  </a:extLst>
+                </a:gridCol>
+                <a:gridCol w="1783080">
+                  <a:extLst>
+                    <a:ext uri="{9D8B030D-6E8A-4147-A177-3AD203B41FA5}">
+                      <a16:colId xmlns:a16="http://schemas.microsoft.com/office/drawing/2014/main" val="20004"/>
+                    </a:ext>
+                  </a:extLst>
+                </a:gridCol>
+                <a:gridCol w="1783080">
+                  <a:extLst>
+                    <a:ext uri="{9D8B030D-6E8A-4147-A177-3AD203B41FA5}">
+                      <a16:colId xmlns:a16="http://schemas.microsoft.com/office/drawing/2014/main" val="20005"/>
+                    </a:ext>
+                  </a:extLst>
+                </a:gridCol>
               </a:tblGrid>
               <a:tr h="352697">
                 <a:tc>
@@ -6236,7 +6422,7 @@
                     <a:lstStyle/>
                     <a:p>
                       <a:pPr>
-                        <a:defRPr b="1" sz="1000">
+                        <a:defRPr sz="1000" b="1">
                           <a:solidFill>
                             <a:srgbClr val="FFFFFF"/>
                           </a:solidFill>
@@ -6259,7 +6445,7 @@
                     <a:lstStyle/>
                     <a:p>
                       <a:pPr>
-                        <a:defRPr b="1" sz="1000">
+                        <a:defRPr sz="1000" b="1">
                           <a:solidFill>
                             <a:srgbClr val="FFFFFF"/>
                           </a:solidFill>
@@ -6282,7 +6468,7 @@
                     <a:lstStyle/>
                     <a:p>
                       <a:pPr>
-                        <a:defRPr b="1" sz="1000">
+                        <a:defRPr sz="1000" b="1">
                           <a:solidFill>
                             <a:srgbClr val="FFFFFF"/>
                           </a:solidFill>
@@ -6305,7 +6491,7 @@
                     <a:lstStyle/>
                     <a:p>
                       <a:pPr>
-                        <a:defRPr b="1" sz="1000">
+                        <a:defRPr sz="1000" b="1">
                           <a:solidFill>
                             <a:srgbClr val="FFFFFF"/>
                           </a:solidFill>
@@ -6328,7 +6514,7 @@
                     <a:lstStyle/>
                     <a:p>
                       <a:pPr>
-                        <a:defRPr b="1" sz="1000">
+                        <a:defRPr sz="1000" b="1">
                           <a:solidFill>
                             <a:srgbClr val="FFFFFF"/>
                           </a:solidFill>
@@ -6351,7 +6537,7 @@
                     <a:lstStyle/>
                     <a:p>
                       <a:pPr>
-                        <a:defRPr b="1" sz="1000">
+                        <a:defRPr sz="1000" b="1">
                           <a:solidFill>
                             <a:srgbClr val="FFFFFF"/>
                           </a:solidFill>
@@ -6368,6 +6554,11 @@
                     </a:solidFill>
                   </a:tcPr>
                 </a:tc>
+                <a:extLst>
+                  <a:ext uri="{0D108BD9-81ED-4DB2-BD59-A6C34878D82A}">
+                    <a16:rowId xmlns:a16="http://schemas.microsoft.com/office/drawing/2014/main" val="10000"/>
+                  </a:ext>
+                </a:extLst>
               </a:tr>
               <a:tr h="352697">
                 <a:tc>
@@ -6508,6 +6699,11 @@
                     </a:solidFill>
                   </a:tcPr>
                 </a:tc>
+                <a:extLst>
+                  <a:ext uri="{0D108BD9-81ED-4DB2-BD59-A6C34878D82A}">
+                    <a16:rowId xmlns:a16="http://schemas.microsoft.com/office/drawing/2014/main" val="10001"/>
+                  </a:ext>
+                </a:extLst>
               </a:tr>
               <a:tr h="352697">
                 <a:tc>
@@ -6648,6 +6844,11 @@
                     </a:solidFill>
                   </a:tcPr>
                 </a:tc>
+                <a:extLst>
+                  <a:ext uri="{0D108BD9-81ED-4DB2-BD59-A6C34878D82A}">
+                    <a16:rowId xmlns:a16="http://schemas.microsoft.com/office/drawing/2014/main" val="10002"/>
+                  </a:ext>
+                </a:extLst>
               </a:tr>
               <a:tr h="352697">
                 <a:tc>
@@ -6788,6 +6989,11 @@
                     </a:solidFill>
                   </a:tcPr>
                 </a:tc>
+                <a:extLst>
+                  <a:ext uri="{0D108BD9-81ED-4DB2-BD59-A6C34878D82A}">
+                    <a16:rowId xmlns:a16="http://schemas.microsoft.com/office/drawing/2014/main" val="10003"/>
+                  </a:ext>
+                </a:extLst>
               </a:tr>
               <a:tr h="352697">
                 <a:tc>
@@ -6928,6 +7134,11 @@
                     </a:solidFill>
                   </a:tcPr>
                 </a:tc>
+                <a:extLst>
+                  <a:ext uri="{0D108BD9-81ED-4DB2-BD59-A6C34878D82A}">
+                    <a16:rowId xmlns:a16="http://schemas.microsoft.com/office/drawing/2014/main" val="10004"/>
+                  </a:ext>
+                </a:extLst>
               </a:tr>
               <a:tr h="352697">
                 <a:tc>
@@ -7068,6 +7279,11 @@
                     </a:solidFill>
                   </a:tcPr>
                 </a:tc>
+                <a:extLst>
+                  <a:ext uri="{0D108BD9-81ED-4DB2-BD59-A6C34878D82A}">
+                    <a16:rowId xmlns:a16="http://schemas.microsoft.com/office/drawing/2014/main" val="10005"/>
+                  </a:ext>
+                </a:extLst>
               </a:tr>
               <a:tr h="352698">
                 <a:tc>
@@ -7208,6 +7424,11 @@
                     </a:solidFill>
                   </a:tcPr>
                 </a:tc>
+                <a:extLst>
+                  <a:ext uri="{0D108BD9-81ED-4DB2-BD59-A6C34878D82A}">
+                    <a16:rowId xmlns:a16="http://schemas.microsoft.com/office/drawing/2014/main" val="10006"/>
+                  </a:ext>
+                </a:extLst>
               </a:tr>
             </a:tbl>
           </a:graphicData>
@@ -7222,7 +7443,7 @@
 </file>
 
 <file path=ppt/slides/slide5.xml><?xml version="1.0" encoding="utf-8"?>
-<p:sld xmlns:a="http://schemas.openxmlformats.org/drawingml/2006/main" xmlns:p="http://schemas.openxmlformats.org/presentationml/2006/main" xmlns:r="http://schemas.openxmlformats.org/officeDocument/2006/relationships">
+<p:sld xmlns:a="http://schemas.openxmlformats.org/drawingml/2006/main" xmlns:r="http://schemas.openxmlformats.org/officeDocument/2006/relationships" xmlns:p="http://schemas.openxmlformats.org/presentationml/2006/main">
   <p:cSld>
     <p:spTree>
       <p:nvGrpSpPr>
@@ -7230,7 +7451,14 @@
         <p:cNvGrpSpPr/>
         <p:nvPr/>
       </p:nvGrpSpPr>
-      <p:grpSpPr/>
+      <p:grpSpPr>
+        <a:xfrm>
+          <a:off x="0" y="0"/>
+          <a:ext cx="0" cy="0"/>
+          <a:chOff x="0" y="0"/>
+          <a:chExt cx="0" cy="0"/>
+        </a:xfrm>
+      </p:grpSpPr>
       <p:sp>
         <p:nvSpPr>
           <p:cNvPr id="2" name="Rectangle 1"/>
@@ -7269,7 +7497,7 @@
           </a:fontRef>
         </p:style>
         <p:txBody>
-          <a:bodyPr rtlCol="0" anchor="ctr" wrap="square" lIns="731520" tIns="137160"/>
+          <a:bodyPr wrap="square" lIns="731520" tIns="137160" rtlCol="0" anchor="ctr"/>
           <a:lstStyle/>
           <a:p>
             <a:pPr algn="ctr">
@@ -7335,7 +7563,7 @@
           </a:fontRef>
         </p:style>
         <p:txBody>
-          <a:bodyPr rtlCol="0" anchor="ctr" wrap="square" lIns="228600" tIns="182880"/>
+          <a:bodyPr wrap="square" lIns="228600" tIns="182880" rtlCol="0" anchor="ctr"/>
           <a:lstStyle/>
           <a:p>
             <a:pPr algn="ctr">
@@ -7346,19 +7574,16 @@
               </a:defRPr>
             </a:pPr>
             <a:r>
+              <a:rPr dirty="0"/>
               <a:t>Course Definition &amp; Statistical Synthesis</a:t>
             </a:r>
           </a:p>
           <a:p>
-            <a:br/>
-            <a:pPr>
-              <a:defRPr b="1" sz="1100">
-                <a:solidFill>
-                  <a:srgbClr val="296299"/>
-                </a:solidFill>
-              </a:defRPr>
-            </a:pPr>
-            <a:r>
+            <a:br>
+              <a:rPr dirty="0"/>
+            </a:br>
+            <a:r>
+              <a:rPr dirty="0"/>
               <a:t>Exploratory Analysis (Slide 3 &amp; 10):</a:t>
             </a:r>
           </a:p>
@@ -7371,19 +7596,16 @@
               </a:defRPr>
             </a:pPr>
             <a:r>
+              <a:rPr dirty="0"/>
               <a:t>Unsupervised synthesis of distributions into Size (Mean $\mu$, Median, Mode) and Spread (Variance $\sigma^2$, Std, IQR, Gini $G$, Entropy $H$).</a:t>
             </a:r>
           </a:p>
           <a:p>
-            <a:br/>
-            <a:pPr>
-              <a:defRPr b="1" sz="1100">
-                <a:solidFill>
-                  <a:srgbClr val="296299"/>
-                </a:solidFill>
-              </a:defRPr>
-            </a:pPr>
-            <a:r>
+            <a:br>
+              <a:rPr dirty="0"/>
+            </a:br>
+            <a:r>
+              <a:rPr dirty="0"/>
               <a:t>Size vs Spread Synthesis:</a:t>
             </a:r>
           </a:p>
@@ -7396,23 +7618,23 @@
               </a:defRPr>
             </a:pPr>
             <a:r>
+              <a:rPr dirty="0"/>
               <a:t>• Mean vs Median: CO mean (2.21) &gt;&gt; median (1.52) demonstrates strong positive skew.</a:t>
             </a:r>
-            <a:br/>
-            <a:r>
+            <a:br>
+              <a:rPr dirty="0"/>
+            </a:br>
+            <a:r>
+              <a:rPr dirty="0"/>
               <a:t>• Gini Index: CO exhibits high concentration (G=0.442) due to episodic spikes.</a:t>
             </a:r>
           </a:p>
           <a:p>
-            <a:br/>
-            <a:pPr>
-              <a:defRPr b="1" sz="1100">
-                <a:solidFill>
-                  <a:srgbClr val="296299"/>
-                </a:solidFill>
-              </a:defRPr>
-            </a:pPr>
-            <a:r>
+            <a:br>
+              <a:rPr dirty="0"/>
+            </a:br>
+            <a:r>
+              <a:rPr dirty="0"/>
               <a:t>Key Pearson Correlation ($r_{XY}$) Findings:</a:t>
             </a:r>
           </a:p>
@@ -7425,16 +7647,28 @@
               </a:defRPr>
             </a:pPr>
             <a:r>
+              <a:rPr dirty="0"/>
               <a:t>• Compressor &amp; Energy Coupling: CDP &amp; TEY ($r = 0.99$), GTEP &amp; TEY ($r = 0.98$) indicate strong collinearity in operating load.</a:t>
             </a:r>
-            <a:br/>
-            <a:r>
+            <a:br>
+              <a:rPr dirty="0"/>
+            </a:br>
+            <a:r>
+              <a:rPr dirty="0"/>
               <a:t>• Environmental Cooling Effect: Ambient Temp AT vs TEY ($r = -0.58$) due to reduced air density at higher temperatures.</a:t>
             </a:r>
-            <a:br/>
-            <a:r>
-              <a:t>• Combustion Trade-off: CO vs NOx ($r = -0.37$) reflects the physical inverse relationship between complete oxidation and thermal NOx.</a:t>
-            </a:r>
+            <a:br>
+              <a:rPr dirty="0"/>
+            </a:br>
+            <a:r>
+              <a:rPr dirty="0"/>
+              <a:t>• </a:t>
+            </a:r>
+            <a:r>
+              <a:rPr lang="it-IT" dirty="0"/>
+              <a:t>MODIFICARE CO E NOX</a:t>
+            </a:r>
+            <a:endParaRPr dirty="0"/>
           </a:p>
         </p:txBody>
       </p:sp>
@@ -7471,7 +7705,7 @@
 </file>
 
 <file path=ppt/slides/slide6.xml><?xml version="1.0" encoding="utf-8"?>
-<p:sld xmlns:a="http://schemas.openxmlformats.org/drawingml/2006/main" xmlns:p="http://schemas.openxmlformats.org/presentationml/2006/main" xmlns:r="http://schemas.openxmlformats.org/officeDocument/2006/relationships">
+<p:sld xmlns:a="http://schemas.openxmlformats.org/drawingml/2006/main" xmlns:r="http://schemas.openxmlformats.org/officeDocument/2006/relationships" xmlns:p="http://schemas.openxmlformats.org/presentationml/2006/main">
   <p:cSld>
     <p:spTree>
       <p:nvGrpSpPr>
@@ -7479,7 +7713,14 @@
         <p:cNvGrpSpPr/>
         <p:nvPr/>
       </p:nvGrpSpPr>
-      <p:grpSpPr/>
+      <p:grpSpPr>
+        <a:xfrm>
+          <a:off x="0" y="0"/>
+          <a:ext cx="0" cy="0"/>
+          <a:chOff x="0" y="0"/>
+          <a:chExt cx="0" cy="0"/>
+        </a:xfrm>
+      </p:grpSpPr>
       <p:sp>
         <p:nvSpPr>
           <p:cNvPr id="2" name="Rectangle 1"/>
@@ -7518,7 +7759,7 @@
           </a:fontRef>
         </p:style>
         <p:txBody>
-          <a:bodyPr rtlCol="0" anchor="ctr" wrap="square" lIns="731520" tIns="137160"/>
+          <a:bodyPr wrap="square" lIns="731520" tIns="137160" rtlCol="0" anchor="ctr"/>
           <a:lstStyle/>
           <a:p>
             <a:pPr algn="ctr">
@@ -7584,7 +7825,7 @@
           </a:fontRef>
         </p:style>
         <p:txBody>
-          <a:bodyPr rtlCol="0" anchor="ctr" wrap="square" lIns="228600" tIns="182880"/>
+          <a:bodyPr wrap="square" lIns="228600" tIns="182880" rtlCol="0" anchor="ctr"/>
           <a:lstStyle/>
           <a:p>
             <a:pPr algn="ctr">
@@ -7595,19 +7836,16 @@
               </a:defRPr>
             </a:pPr>
             <a:r>
+              <a:rPr dirty="0"/>
               <a:t>PCA as an Exploratory Technique (Slide 70)</a:t>
             </a:r>
           </a:p>
           <a:p>
-            <a:br/>
-            <a:pPr>
-              <a:defRPr b="1" sz="1100">
-                <a:solidFill>
-                  <a:srgbClr val="296299"/>
-                </a:solidFill>
-              </a:defRPr>
-            </a:pPr>
-            <a:r>
+            <a:br>
+              <a:rPr dirty="0"/>
+            </a:br>
+            <a:r>
+              <a:rPr dirty="0"/>
               <a:t>Course Formulation (Slide 75):</a:t>
             </a:r>
           </a:p>
@@ -7620,23 +7858,71 @@
               </a:defRPr>
             </a:pPr>
             <a:r>
-              <a:t>Eigen-decomposition of Covariance Matrix $C v_i = \lambda_i v_i$.</a:t>
-            </a:r>
-            <a:br/>
-            <a:r>
-              <a:t>Proportion of Variance Explained: $\text{PVE}_i = \lambda_i / \sum \lambda_j$.</a:t>
-            </a:r>
-          </a:p>
-          <a:p>
-            <a:br/>
-            <a:pPr>
-              <a:defRPr b="1" sz="1100">
-                <a:solidFill>
-                  <a:srgbClr val="296299"/>
-                </a:solidFill>
-              </a:defRPr>
-            </a:pPr>
-            <a:r>
+              <a:rPr dirty="0"/>
+              <a:t>Eigen-decomposition of Covariance Matrix $C </a:t>
+            </a:r>
+            <a:r>
+              <a:rPr dirty="0" err="1"/>
+              <a:t>v_i</a:t>
+            </a:r>
+            <a:r>
+              <a:rPr dirty="0"/>
+              <a:t> = \</a:t>
+            </a:r>
+            <a:r>
+              <a:rPr dirty="0" err="1"/>
+              <a:t>lambda_i</a:t>
+            </a:r>
+            <a:r>
+              <a:rPr dirty="0"/>
+              <a:t> </a:t>
+            </a:r>
+            <a:r>
+              <a:rPr dirty="0" err="1"/>
+              <a:t>v_i</a:t>
+            </a:r>
+            <a:r>
+              <a:rPr dirty="0"/>
+              <a:t>$.</a:t>
+            </a:r>
+            <a:br>
+              <a:rPr dirty="0"/>
+            </a:br>
+            <a:r>
+              <a:rPr dirty="0"/>
+              <a:t>Proportion of Variance Explained: $\text{PVE}_</a:t>
+            </a:r>
+            <a:r>
+              <a:rPr dirty="0" err="1"/>
+              <a:t>i</a:t>
+            </a:r>
+            <a:r>
+              <a:rPr dirty="0"/>
+              <a:t> = \</a:t>
+            </a:r>
+            <a:r>
+              <a:rPr dirty="0" err="1"/>
+              <a:t>lambda_i</a:t>
+            </a:r>
+            <a:r>
+              <a:rPr dirty="0"/>
+              <a:t> / \sum \</a:t>
+            </a:r>
+            <a:r>
+              <a:rPr dirty="0" err="1"/>
+              <a:t>lambda_j</a:t>
+            </a:r>
+            <a:r>
+              <a:rPr dirty="0"/>
+              <a:t>$.</a:t>
+            </a:r>
+          </a:p>
+          <a:p>
+            <a:br>
+              <a:rPr dirty="0"/>
+            </a:br>
+            <a:r>
+              <a:rPr dirty="0"/>
               <a:t>Dimensionality Reduction Results:</a:t>
             </a:r>
           </a:p>
@@ -7649,31 +7935,37 @@
               </a:defRPr>
             </a:pPr>
             <a:r>
+              <a:rPr dirty="0"/>
               <a:t>• PC1 (48.28%): Captures general turbine thermodynamic load (high loadings for CDP, TEY, GTEP, TIT).</a:t>
             </a:r>
-            <a:br/>
-            <a:r>
+            <a:br>
+              <a:rPr dirty="0"/>
+            </a:br>
+            <a:r>
+              <a:rPr dirty="0"/>
               <a:t>• PC2 (20.48%): Captures ambient temperature (AT) and the inverse CO vs NOx combustion trade-off.</a:t>
             </a:r>
-            <a:br/>
-            <a:r>
+            <a:br>
+              <a:rPr dirty="0"/>
+            </a:br>
+            <a:r>
+              <a:rPr dirty="0"/>
               <a:t>• First 2 PCs capture 68.76% of total system variance.</a:t>
             </a:r>
-            <a:br/>
-            <a:r>
+            <a:br>
+              <a:rPr dirty="0"/>
+            </a:br>
+            <a:r>
+              <a:rPr dirty="0"/>
               <a:t>• First 5 PCs capture 92.02% (Scree plot elbow at $p=5$).</a:t>
             </a:r>
           </a:p>
           <a:p>
-            <a:br/>
-            <a:pPr>
-              <a:defRPr b="1" sz="1100">
-                <a:solidFill>
-                  <a:srgbClr val="296299"/>
-                </a:solidFill>
-              </a:defRPr>
-            </a:pPr>
-            <a:r>
+            <a:br>
+              <a:rPr dirty="0"/>
+            </a:br>
+            <a:r>
+              <a:rPr dirty="0"/>
               <a:t>Industrial Takeaway:</a:t>
             </a:r>
           </a:p>
@@ -7686,6 +7978,7 @@
               </a:defRPr>
             </a:pPr>
             <a:r>
+              <a:rPr dirty="0"/>
               <a:t>The 11 physical sensors effectively lie on a low-dimensional manifold governed by ambient weather and power dispatch.</a:t>
             </a:r>
           </a:p>
@@ -7724,7 +8017,1053 @@
 </file>
 
 <file path=ppt/slides/slide7.xml><?xml version="1.0" encoding="utf-8"?>
-<p:sld xmlns:a="http://schemas.openxmlformats.org/drawingml/2006/main" xmlns:p="http://schemas.openxmlformats.org/presentationml/2006/main" xmlns:r="http://schemas.openxmlformats.org/officeDocument/2006/relationships">
+<p:sld xmlns:a="http://schemas.openxmlformats.org/drawingml/2006/main" xmlns:r="http://schemas.openxmlformats.org/officeDocument/2006/relationships" xmlns:p="http://schemas.openxmlformats.org/presentationml/2006/main">
+  <p:cSld>
+    <p:spTree>
+      <p:nvGrpSpPr>
+        <p:cNvPr id="1" name="">
+          <a:extLst>
+            <a:ext uri="{FF2B5EF4-FFF2-40B4-BE49-F238E27FC236}">
+              <a16:creationId xmlns:a16="http://schemas.microsoft.com/office/drawing/2014/main" id="{1B0E8DA4-359D-9149-0802-E1DE3F1C02BF}"/>
+            </a:ext>
+          </a:extLst>
+        </p:cNvPr>
+        <p:cNvGrpSpPr/>
+        <p:nvPr/>
+      </p:nvGrpSpPr>
+      <p:grpSpPr>
+        <a:xfrm>
+          <a:off x="0" y="0"/>
+          <a:ext cx="0" cy="0"/>
+          <a:chOff x="0" y="0"/>
+          <a:chExt cx="0" cy="0"/>
+        </a:xfrm>
+      </p:grpSpPr>
+      <p:sp>
+        <p:nvSpPr>
+          <p:cNvPr id="2" name="Rectangle 1">
+            <a:extLst>
+              <a:ext uri="{FF2B5EF4-FFF2-40B4-BE49-F238E27FC236}">
+                <a16:creationId xmlns:a16="http://schemas.microsoft.com/office/drawing/2014/main" id="{CDA5EA26-EB5A-E892-6B1A-F5B268D71490}"/>
+              </a:ext>
+            </a:extLst>
+          </p:cNvPr>
+          <p:cNvSpPr/>
+          <p:nvPr/>
+        </p:nvSpPr>
+        <p:spPr>
+          <a:xfrm>
+            <a:off x="0" y="0"/>
+            <a:ext cx="12191695" cy="1097280"/>
+          </a:xfrm>
+          <a:prstGeom prst="rect">
+            <a:avLst/>
+          </a:prstGeom>
+          <a:solidFill>
+            <a:srgbClr val="102542"/>
+          </a:solidFill>
+          <a:ln>
+            <a:solidFill>
+              <a:srgbClr val="102542"/>
+            </a:solidFill>
+          </a:ln>
+        </p:spPr>
+        <p:style>
+          <a:lnRef idx="1">
+            <a:schemeClr val="accent1"/>
+          </a:lnRef>
+          <a:fillRef idx="3">
+            <a:schemeClr val="accent1"/>
+          </a:fillRef>
+          <a:effectRef idx="2">
+            <a:schemeClr val="accent1"/>
+          </a:effectRef>
+          <a:fontRef idx="minor">
+            <a:schemeClr val="lt1"/>
+          </a:fontRef>
+        </p:style>
+        <p:txBody>
+          <a:bodyPr wrap="square" lIns="731520" tIns="137160" rtlCol="0" anchor="ctr"/>
+          <a:lstStyle/>
+          <a:p>
+            <a:pPr algn="ctr">
+              <a:defRPr sz="1100" b="1">
+                <a:solidFill>
+                  <a:srgbClr val="B4D7EB"/>
+                </a:solidFill>
+              </a:defRPr>
+            </a:pPr>
+            <a:r>
+              <a:rPr dirty="0"/>
+              <a:t>PHASE 3: METHODOLOGICAL FRAMEWORK</a:t>
+            </a:r>
+          </a:p>
+          <a:p>
+            <a:pPr>
+              <a:defRPr sz="2200" b="1">
+                <a:solidFill>
+                  <a:srgbClr val="FFFFFF"/>
+                </a:solidFill>
+              </a:defRPr>
+            </a:pPr>
+            <a:r>
+              <a:rPr dirty="0"/>
+              <a:t>4. Main Analysis: Objectives &amp; Methodological Framework</a:t>
+            </a:r>
+          </a:p>
+        </p:txBody>
+      </p:sp>
+      <p:sp>
+        <p:nvSpPr>
+          <p:cNvPr id="3" name="Rounded Rectangle 2">
+            <a:extLst>
+              <a:ext uri="{FF2B5EF4-FFF2-40B4-BE49-F238E27FC236}">
+                <a16:creationId xmlns:a16="http://schemas.microsoft.com/office/drawing/2014/main" id="{E8699CF3-F6EB-D0F8-2D7A-707162BC726D}"/>
+              </a:ext>
+            </a:extLst>
+          </p:cNvPr>
+          <p:cNvSpPr/>
+          <p:nvPr/>
+        </p:nvSpPr>
+        <p:spPr>
+          <a:xfrm>
+            <a:off x="731520" y="1371600"/>
+            <a:ext cx="3383280" cy="2926080"/>
+          </a:xfrm>
+          <a:prstGeom prst="roundRect">
+            <a:avLst/>
+          </a:prstGeom>
+          <a:solidFill>
+            <a:srgbClr val="F8F9FA"/>
+          </a:solidFill>
+          <a:ln>
+            <a:solidFill>
+              <a:srgbClr val="DCE1E6"/>
+            </a:solidFill>
+          </a:ln>
+        </p:spPr>
+        <p:style>
+          <a:lnRef idx="1">
+            <a:schemeClr val="accent1"/>
+          </a:lnRef>
+          <a:fillRef idx="3">
+            <a:schemeClr val="accent1"/>
+          </a:fillRef>
+          <a:effectRef idx="2">
+            <a:schemeClr val="accent1"/>
+          </a:effectRef>
+          <a:fontRef idx="minor">
+            <a:schemeClr val="lt1"/>
+          </a:fontRef>
+        </p:style>
+        <p:txBody>
+          <a:bodyPr wrap="square" lIns="182880" tIns="182880" rtlCol="0" anchor="ctr"/>
+          <a:lstStyle/>
+          <a:p>
+            <a:pPr algn="ctr">
+              <a:defRPr sz="1300" b="1">
+                <a:solidFill>
+                  <a:srgbClr val="102542"/>
+                </a:solidFill>
+              </a:defRPr>
+            </a:pPr>
+            <a:r>
+              <a:t>Objective 1: Energy Yield (TEY) &amp; PCR</a:t>
+            </a:r>
+          </a:p>
+          <a:p>
+            <a:pPr>
+              <a:defRPr sz="1000">
+                <a:solidFill>
+                  <a:srgbClr val="212529"/>
+                </a:solidFill>
+              </a:defRPr>
+            </a:pPr>
+            <a:r>
+              <a:t>• Predict net turbine energy yield from 8 sensor telemetry features.</a:t>
+            </a:r>
+            <a:br/>
+            <a:r>
+              <a:t>• Problem: Extreme Multicollinearity (VIF &gt; 250 for CDP, TIT, GTEP, Slide 115).</a:t>
+            </a:r>
+            <a:br/>
+            <a:r>
+              <a:t>• Method: Principal Component Regression (PCR, Slides 70, 106) on 4 feature PCs ($Z = X_{\text{std}} V_4$, 90.76% PVE) to eliminate variance inflation and ensure numerical stability.</a:t>
+            </a:r>
+          </a:p>
+        </p:txBody>
+      </p:sp>
+      <p:sp>
+        <p:nvSpPr>
+          <p:cNvPr id="4" name="Rounded Rectangle 3">
+            <a:extLst>
+              <a:ext uri="{FF2B5EF4-FFF2-40B4-BE49-F238E27FC236}">
+                <a16:creationId xmlns:a16="http://schemas.microsoft.com/office/drawing/2014/main" id="{ACE8DD28-F92D-9798-FCF2-06C270AA01CF}"/>
+              </a:ext>
+            </a:extLst>
+          </p:cNvPr>
+          <p:cNvSpPr/>
+          <p:nvPr/>
+        </p:nvSpPr>
+        <p:spPr>
+          <a:xfrm>
+            <a:off x="4389120" y="1371600"/>
+            <a:ext cx="3383280" cy="2926080"/>
+          </a:xfrm>
+          <a:prstGeom prst="roundRect">
+            <a:avLst/>
+          </a:prstGeom>
+          <a:solidFill>
+            <a:srgbClr val="F8F9FA"/>
+          </a:solidFill>
+          <a:ln>
+            <a:solidFill>
+              <a:srgbClr val="DCE1E6"/>
+            </a:solidFill>
+          </a:ln>
+        </p:spPr>
+        <p:style>
+          <a:lnRef idx="1">
+            <a:schemeClr val="accent1"/>
+          </a:lnRef>
+          <a:fillRef idx="3">
+            <a:schemeClr val="accent1"/>
+          </a:fillRef>
+          <a:effectRef idx="2">
+            <a:schemeClr val="accent1"/>
+          </a:effectRef>
+          <a:fontRef idx="minor">
+            <a:schemeClr val="lt1"/>
+          </a:fontRef>
+        </p:style>
+        <p:txBody>
+          <a:bodyPr wrap="square" lIns="182880" tIns="182880" rtlCol="0" anchor="ctr"/>
+          <a:lstStyle/>
+          <a:p>
+            <a:pPr algn="ctr">
+              <a:defRPr sz="1300" b="1">
+                <a:solidFill>
+                  <a:srgbClr val="102542"/>
+                </a:solidFill>
+              </a:defRPr>
+            </a:pPr>
+            <a:r>
+              <a:rPr dirty="0"/>
+              <a:t>Objective 2: Emissions Modeling (CO &amp; NOx)</a:t>
+            </a:r>
+          </a:p>
+          <a:p>
+            <a:pPr>
+              <a:defRPr sz="1000">
+                <a:solidFill>
+                  <a:srgbClr val="212529"/>
+                </a:solidFill>
+              </a:defRPr>
+            </a:pPr>
+            <a:r>
+              <a:rPr dirty="0"/>
+              <a:t>• Quantify pollutant generation as a function of firing state.</a:t>
+            </a:r>
+            <a:br>
+              <a:rPr dirty="0"/>
+            </a:br>
+            <a:r>
+              <a:rPr dirty="0"/>
+              <a:t>• Method: Polynomial Regression (Slide 116 &amp; Ex 4.1) for CO to capture steep non-linear spikes during low-load/startup regimes ($x \to [x, x^2]$).</a:t>
+            </a:r>
+            <a:br>
+              <a:rPr dirty="0"/>
+            </a:br>
+            <a:r>
+              <a:rPr dirty="0"/>
+              <a:t>• Multivariate OLS for NOx tracking thermal oxidation.</a:t>
+            </a:r>
+          </a:p>
+        </p:txBody>
+      </p:sp>
+      <p:sp>
+        <p:nvSpPr>
+          <p:cNvPr id="5" name="Rounded Rectangle 4">
+            <a:extLst>
+              <a:ext uri="{FF2B5EF4-FFF2-40B4-BE49-F238E27FC236}">
+                <a16:creationId xmlns:a16="http://schemas.microsoft.com/office/drawing/2014/main" id="{013660D8-39BD-5869-BE54-BCEF7B34FA43}"/>
+              </a:ext>
+            </a:extLst>
+          </p:cNvPr>
+          <p:cNvSpPr/>
+          <p:nvPr/>
+        </p:nvSpPr>
+        <p:spPr>
+          <a:xfrm>
+            <a:off x="8046720" y="1371600"/>
+            <a:ext cx="3383280" cy="2926080"/>
+          </a:xfrm>
+          <a:prstGeom prst="roundRect">
+            <a:avLst/>
+          </a:prstGeom>
+          <a:solidFill>
+            <a:srgbClr val="F8F9FA"/>
+          </a:solidFill>
+          <a:ln>
+            <a:solidFill>
+              <a:srgbClr val="DCE1E6"/>
+            </a:solidFill>
+          </a:ln>
+        </p:spPr>
+        <p:style>
+          <a:lnRef idx="1">
+            <a:schemeClr val="accent1"/>
+          </a:lnRef>
+          <a:fillRef idx="3">
+            <a:schemeClr val="accent1"/>
+          </a:fillRef>
+          <a:effectRef idx="2">
+            <a:schemeClr val="accent1"/>
+          </a:effectRef>
+          <a:fontRef idx="minor">
+            <a:schemeClr val="lt1"/>
+          </a:fontRef>
+        </p:style>
+        <p:txBody>
+          <a:bodyPr wrap="square" lIns="182880" tIns="182880" rtlCol="0" anchor="ctr"/>
+          <a:lstStyle/>
+          <a:p>
+            <a:pPr algn="ctr">
+              <a:defRPr sz="1300" b="1">
+                <a:solidFill>
+                  <a:srgbClr val="102542"/>
+                </a:solidFill>
+              </a:defRPr>
+            </a:pPr>
+            <a:r>
+              <a:t>Objective 3: Operational Regimes (K-Means)</a:t>
+            </a:r>
+          </a:p>
+          <a:p>
+            <a:pPr>
+              <a:defRPr sz="1000">
+                <a:solidFill>
+                  <a:srgbClr val="212529"/>
+                </a:solidFill>
+              </a:defRPr>
+            </a:pPr>
+            <a:r>
+              <a:t>• Discover discrete turbine operational regimes (Unsupervised).</a:t>
+            </a:r>
+            <a:br/>
+            <a:r>
+              <a:t>• Method: K-Means Clustering (Slides 90-91) with Silhouette validation (Slide 94, Ex 3.1): $\text{SIL} = \frac{1}{m}\sum \frac{b_i - a_i}{\max(a_i, b_i)}$.</a:t>
+            </a:r>
+            <a:br/>
+            <a:r>
+              <a:t>• Identifies Base-load, Peak-load, and Low-load emission profiles.</a:t>
+            </a:r>
+          </a:p>
+        </p:txBody>
+      </p:sp>
+      <p:sp>
+        <p:nvSpPr>
+          <p:cNvPr id="6" name="Rounded Rectangle 5">
+            <a:extLst>
+              <a:ext uri="{FF2B5EF4-FFF2-40B4-BE49-F238E27FC236}">
+                <a16:creationId xmlns:a16="http://schemas.microsoft.com/office/drawing/2014/main" id="{E4F6713E-45BC-B159-1E64-2D59794BA24F}"/>
+              </a:ext>
+            </a:extLst>
+          </p:cNvPr>
+          <p:cNvSpPr/>
+          <p:nvPr/>
+        </p:nvSpPr>
+        <p:spPr>
+          <a:xfrm>
+            <a:off x="731520" y="4480560"/>
+            <a:ext cx="10698480" cy="1920240"/>
+          </a:xfrm>
+          <a:prstGeom prst="roundRect">
+            <a:avLst/>
+          </a:prstGeom>
+          <a:solidFill>
+            <a:srgbClr val="F8F9FA"/>
+          </a:solidFill>
+          <a:ln>
+            <a:solidFill>
+              <a:srgbClr val="DCE1E6"/>
+            </a:solidFill>
+          </a:ln>
+        </p:spPr>
+        <p:style>
+          <a:lnRef idx="1">
+            <a:schemeClr val="accent1"/>
+          </a:lnRef>
+          <a:fillRef idx="3">
+            <a:schemeClr val="accent1"/>
+          </a:fillRef>
+          <a:effectRef idx="2">
+            <a:schemeClr val="accent1"/>
+          </a:effectRef>
+          <a:fontRef idx="minor">
+            <a:schemeClr val="lt1"/>
+          </a:fontRef>
+        </p:style>
+        <p:txBody>
+          <a:bodyPr wrap="square" lIns="228600" tIns="137160" rtlCol="0" anchor="ctr"/>
+          <a:lstStyle/>
+          <a:p>
+            <a:pPr algn="ctr">
+              <a:defRPr sz="1300" b="1">
+                <a:solidFill>
+                  <a:srgbClr val="102542"/>
+                </a:solidFill>
+              </a:defRPr>
+            </a:pPr>
+            <a:r>
+              <a:t>Mathematical Formulations &amp; Accuracy Metrics (Course Standards)</a:t>
+            </a:r>
+          </a:p>
+          <a:p>
+            <a:pPr>
+              <a:defRPr sz="1050">
+                <a:solidFill>
+                  <a:srgbClr val="212529"/>
+                </a:solidFill>
+              </a:defRPr>
+            </a:pPr>
+            <a:r>
+              <a:t>• Ordinary Least Squares: $\hat{\beta} = (X^T X)^{-1} X^T y$ (Slide 106, computed via `np.linalg.lstsq` for numerical stability)</a:t>
+            </a:r>
+            <a:br/>
+            <a:r>
+              <a:t>• Principal Component Regression: $\hat{\beta}_{PCR} = (Z^T Z)^{-1} Z^T y$, where $Z = X_{\text{std}} V_4$ (4 PCs capturing 90.76% PVE)</a:t>
+            </a:r>
+            <a:br/>
+            <a:r>
+              <a:t>• Multicollinearity VIF: $\text{VIF}(\hat{\beta}_j) = \frac{1}{1 - R^2_{x_j|x_{-j}}}$ (Slide 115) | Silhouette Quality: $\text{SIL}_i = \frac{b_i - a_i}{\max(a_i, b_i)}$ (Slide 94)</a:t>
+            </a:r>
+          </a:p>
+        </p:txBody>
+      </p:sp>
+      <p:sp>
+        <p:nvSpPr>
+          <p:cNvPr id="7" name="CasellaDiTesto 6">
+            <a:extLst>
+              <a:ext uri="{FF2B5EF4-FFF2-40B4-BE49-F238E27FC236}">
+                <a16:creationId xmlns:a16="http://schemas.microsoft.com/office/drawing/2014/main" id="{660EF876-BA6F-5054-1E79-2CDFD2C78FC4}"/>
+              </a:ext>
+            </a:extLst>
+          </p:cNvPr>
+          <p:cNvSpPr txBox="1"/>
+          <p:nvPr/>
+        </p:nvSpPr>
+        <p:spPr>
+          <a:xfrm>
+            <a:off x="722179" y="1557756"/>
+            <a:ext cx="5358581" cy="4154984"/>
+          </a:xfrm>
+          <a:prstGeom prst="rect">
+            <a:avLst/>
+          </a:prstGeom>
+          <a:noFill/>
+        </p:spPr>
+        <p:txBody>
+          <a:bodyPr wrap="square" rtlCol="0">
+            <a:spAutoFit/>
+          </a:bodyPr>
+          <a:lstStyle/>
+          <a:p>
+            <a:r>
+              <a:rPr lang="it-IT" sz="1200" dirty="0"/>
+              <a:t> • TEY </a:t>
+            </a:r>
+            <a:r>
+              <a:rPr lang="it-IT" sz="1200" dirty="0" err="1"/>
+              <a:t>implies</a:t>
+            </a:r>
+            <a:r>
+              <a:rPr lang="it-IT" sz="1200" dirty="0"/>
+              <a:t> PCR (4 </a:t>
+            </a:r>
+            <a:r>
+              <a:rPr lang="it-IT" sz="1200" dirty="0" err="1"/>
+              <a:t>PCs</a:t>
+            </a:r>
+            <a:r>
+              <a:rPr lang="it-IT" sz="1200" dirty="0"/>
+              <a:t>, 90.8% PVE):</a:t>
+            </a:r>
+          </a:p>
+          <a:p>
+            <a:r>
+              <a:rPr lang="it-IT" sz="1200" dirty="0"/>
+              <a:t>      • </a:t>
+            </a:r>
+            <a:r>
+              <a:rPr lang="it-IT" sz="1200" dirty="0" err="1"/>
+              <a:t>Motivation</a:t>
+            </a:r>
+            <a:r>
+              <a:rPr lang="it-IT" sz="1200" dirty="0"/>
+              <a:t>: </a:t>
+            </a:r>
+            <a:r>
+              <a:rPr lang="it-IT" sz="1200" dirty="0" err="1"/>
+              <a:t>Resolves</a:t>
+            </a:r>
+            <a:r>
+              <a:rPr lang="it-IT" sz="1200" dirty="0"/>
+              <a:t> severe </a:t>
+            </a:r>
+            <a:r>
+              <a:rPr lang="it-IT" sz="1200" dirty="0" err="1"/>
+              <a:t>multicollinearity</a:t>
+            </a:r>
+            <a:r>
+              <a:rPr lang="it-IT" sz="1200" dirty="0"/>
+              <a:t> (VIF &gt; 250 for CDP, TIT, GTEP). </a:t>
+            </a:r>
+            <a:r>
+              <a:rPr lang="it-IT" sz="1200" dirty="0" err="1"/>
+              <a:t>Projecting</a:t>
+            </a:r>
+            <a:r>
+              <a:rPr lang="it-IT" sz="1200" dirty="0"/>
+              <a:t> 8 </a:t>
+            </a:r>
+            <a:r>
+              <a:rPr lang="it-IT" sz="1200" dirty="0" err="1"/>
+              <a:t>correlated</a:t>
+            </a:r>
+            <a:r>
+              <a:rPr lang="it-IT" sz="1200" dirty="0"/>
+              <a:t> features </a:t>
+            </a:r>
+            <a:r>
+              <a:rPr lang="it-IT" sz="1200" dirty="0" err="1"/>
+              <a:t>onto</a:t>
+            </a:r>
+            <a:r>
+              <a:rPr lang="it-IT" sz="1200" dirty="0"/>
+              <a:t> 4 </a:t>
+            </a:r>
+            <a:r>
+              <a:rPr lang="it-IT" sz="1200" dirty="0" err="1"/>
+              <a:t>orthogonal</a:t>
+            </a:r>
+            <a:r>
+              <a:rPr lang="it-IT" sz="1200" dirty="0"/>
+              <a:t> </a:t>
+            </a:r>
+            <a:r>
+              <a:rPr lang="it-IT" sz="1200" dirty="0" err="1"/>
+              <a:t>components</a:t>
+            </a:r>
+            <a:endParaRPr lang="it-IT" sz="1200" dirty="0"/>
+          </a:p>
+          <a:p>
+            <a:r>
+              <a:rPr lang="it-IT" sz="1200" dirty="0"/>
+              <a:t>      </a:t>
+            </a:r>
+            <a:r>
+              <a:rPr lang="it-IT" sz="1200" dirty="0" err="1"/>
+              <a:t>eliminates</a:t>
+            </a:r>
+            <a:r>
+              <a:rPr lang="it-IT" sz="1200" dirty="0"/>
+              <a:t> </a:t>
+            </a:r>
+            <a:r>
+              <a:rPr lang="it-IT" sz="1200" dirty="0" err="1"/>
+              <a:t>coefficient</a:t>
+            </a:r>
+            <a:r>
+              <a:rPr lang="it-IT" sz="1200" dirty="0"/>
+              <a:t> </a:t>
+            </a:r>
+            <a:r>
+              <a:rPr lang="it-IT" sz="1200" dirty="0" err="1"/>
+              <a:t>variance</a:t>
+            </a:r>
+            <a:r>
+              <a:rPr lang="it-IT" sz="1200" dirty="0"/>
+              <a:t> </a:t>
+            </a:r>
+            <a:r>
+              <a:rPr lang="it-IT" sz="1200" dirty="0" err="1"/>
+              <a:t>inflation</a:t>
+            </a:r>
+            <a:r>
+              <a:rPr lang="it-IT" sz="1200" dirty="0"/>
+              <a:t> and </a:t>
+            </a:r>
+            <a:r>
+              <a:rPr lang="it-IT" sz="1200" dirty="0" err="1"/>
+              <a:t>guarantees</a:t>
+            </a:r>
+            <a:r>
+              <a:rPr lang="it-IT" sz="1200" dirty="0"/>
+              <a:t> </a:t>
+            </a:r>
+            <a:r>
+              <a:rPr lang="it-IT" sz="1200" dirty="0" err="1"/>
+              <a:t>numerical</a:t>
+            </a:r>
+            <a:r>
+              <a:rPr lang="it-IT" sz="1200" dirty="0"/>
+              <a:t> </a:t>
+            </a:r>
+            <a:r>
+              <a:rPr lang="it-IT" sz="1200" dirty="0" err="1"/>
+              <a:t>stability</a:t>
+            </a:r>
+            <a:r>
+              <a:rPr lang="it-IT" sz="1200" dirty="0"/>
+              <a:t>.</a:t>
+            </a:r>
+          </a:p>
+          <a:p>
+            <a:r>
+              <a:rPr lang="it-IT" sz="1200" dirty="0"/>
+              <a:t>  • CO </a:t>
+            </a:r>
+            <a:r>
+              <a:rPr lang="it-IT" sz="1200" dirty="0" err="1"/>
+              <a:t>implies</a:t>
+            </a:r>
+            <a:r>
+              <a:rPr lang="it-IT" sz="1200" dirty="0"/>
+              <a:t> Degree-2 </a:t>
+            </a:r>
+            <a:r>
+              <a:rPr lang="it-IT" sz="1200" dirty="0" err="1"/>
+              <a:t>Polynomial</a:t>
+            </a:r>
+            <a:r>
+              <a:rPr lang="it-IT" sz="1200" dirty="0"/>
+              <a:t> </a:t>
+            </a:r>
+            <a:r>
+              <a:rPr lang="it-IT" sz="1200" dirty="0" err="1"/>
+              <a:t>Regression</a:t>
+            </a:r>
+            <a:r>
+              <a:rPr lang="it-IT" sz="1200" dirty="0"/>
+              <a:t> (x → [x,x²]):</a:t>
+            </a:r>
+          </a:p>
+          <a:p>
+            <a:r>
+              <a:rPr lang="it-IT" sz="1200" dirty="0"/>
+              <a:t>      • </a:t>
+            </a:r>
+            <a:r>
+              <a:rPr lang="it-IT" sz="1200" dirty="0" err="1"/>
+              <a:t>Motivation</a:t>
+            </a:r>
+            <a:r>
+              <a:rPr lang="it-IT" sz="1200" dirty="0"/>
+              <a:t>: </a:t>
+            </a:r>
+            <a:r>
+              <a:rPr lang="it-IT" sz="1200" dirty="0" err="1"/>
+              <a:t>Captures</a:t>
+            </a:r>
+            <a:r>
+              <a:rPr lang="it-IT" sz="1200" dirty="0"/>
+              <a:t> the non-linear, </a:t>
+            </a:r>
+            <a:r>
+              <a:rPr lang="it-IT" sz="1200" dirty="0" err="1"/>
+              <a:t>exponential</a:t>
+            </a:r>
+            <a:r>
+              <a:rPr lang="it-IT" sz="1200" dirty="0"/>
+              <a:t> </a:t>
+            </a:r>
+            <a:r>
+              <a:rPr lang="it-IT" sz="1200" dirty="0" err="1"/>
+              <a:t>emission</a:t>
+            </a:r>
+            <a:r>
+              <a:rPr lang="it-IT" sz="1200" dirty="0"/>
+              <a:t> surge </a:t>
+            </a:r>
+            <a:r>
+              <a:rPr lang="it-IT" sz="1200" dirty="0" err="1"/>
+              <a:t>during</a:t>
+            </a:r>
+            <a:r>
+              <a:rPr lang="it-IT" sz="1200" dirty="0"/>
+              <a:t> low-load/startup </a:t>
+            </a:r>
+            <a:r>
+              <a:rPr lang="it-IT" sz="1200" dirty="0" err="1"/>
+              <a:t>firing</a:t>
+            </a:r>
+            <a:r>
+              <a:rPr lang="it-IT" sz="1200" dirty="0"/>
+              <a:t> (</a:t>
+            </a:r>
+          </a:p>
+          <a:p>
+            <a:endParaRPr lang="it-IT" sz="1200" dirty="0"/>
+          </a:p>
+          <a:p>
+            <a:endParaRPr lang="it-IT" sz="1200" dirty="0"/>
+          </a:p>
+          <a:p>
+            <a:r>
+              <a:rPr lang="it-IT" sz="1200" dirty="0"/>
+              <a:t>         ∘</a:t>
+            </a:r>
+          </a:p>
+          <a:p>
+            <a:r>
+              <a:rPr lang="it-IT" sz="1200" dirty="0"/>
+              <a:t>    &lt;1070  C</a:t>
+            </a:r>
+          </a:p>
+          <a:p>
+            <a:endParaRPr lang="it-IT" sz="1200" dirty="0"/>
+          </a:p>
+          <a:p>
+            <a:r>
+              <a:rPr lang="it-IT" sz="1200" dirty="0"/>
+              <a:t>  ) </a:t>
+            </a:r>
+            <a:r>
+              <a:rPr lang="it-IT" sz="1200" dirty="0" err="1"/>
+              <a:t>while</a:t>
+            </a:r>
+            <a:r>
+              <a:rPr lang="it-IT" sz="1200" dirty="0"/>
+              <a:t> </a:t>
+            </a:r>
+            <a:r>
+              <a:rPr lang="it-IT" sz="1200" dirty="0" err="1"/>
+              <a:t>maintaining</a:t>
+            </a:r>
+            <a:r>
+              <a:rPr lang="it-IT" sz="1200" dirty="0"/>
+              <a:t> a </a:t>
+            </a:r>
+            <a:r>
+              <a:rPr lang="it-IT" sz="1200" dirty="0" err="1"/>
+              <a:t>closed</a:t>
+            </a:r>
+            <a:r>
+              <a:rPr lang="it-IT" sz="1200" dirty="0"/>
+              <a:t>-form, </a:t>
+            </a:r>
+            <a:r>
+              <a:rPr lang="it-IT" sz="1200" dirty="0" err="1"/>
+              <a:t>interpretable</a:t>
+            </a:r>
+            <a:r>
+              <a:rPr lang="it-IT" sz="1200" dirty="0"/>
+              <a:t> linear </a:t>
+            </a:r>
+            <a:r>
+              <a:rPr lang="it-IT" sz="1200" dirty="0" err="1"/>
+              <a:t>optimization</a:t>
+            </a:r>
+            <a:r>
+              <a:rPr lang="it-IT" sz="1200" dirty="0"/>
+              <a:t>.</a:t>
+            </a:r>
+          </a:p>
+          <a:p>
+            <a:endParaRPr lang="it-IT" sz="1200" dirty="0"/>
+          </a:p>
+          <a:p>
+            <a:r>
+              <a:rPr lang="it-IT" sz="1200" dirty="0"/>
+              <a:t>  • NOₓ </a:t>
+            </a:r>
+            <a:r>
+              <a:rPr lang="it-IT" sz="1200" dirty="0" err="1"/>
+              <a:t>implies</a:t>
+            </a:r>
+            <a:r>
+              <a:rPr lang="it-IT" sz="1200" dirty="0"/>
+              <a:t> Multivariate Linear OLS:</a:t>
+            </a:r>
+          </a:p>
+          <a:p>
+            <a:r>
+              <a:rPr lang="it-IT" sz="1200" dirty="0"/>
+              <a:t>      • </a:t>
+            </a:r>
+            <a:r>
+              <a:rPr lang="it-IT" sz="1200" dirty="0" err="1"/>
+              <a:t>Motivation</a:t>
+            </a:r>
+            <a:r>
+              <a:rPr lang="it-IT" sz="1200" dirty="0"/>
+              <a:t>: </a:t>
+            </a:r>
+            <a:r>
+              <a:rPr lang="it-IT" sz="1200" dirty="0" err="1"/>
+              <a:t>Captures</a:t>
+            </a:r>
+            <a:r>
+              <a:rPr lang="it-IT" sz="1200" dirty="0"/>
+              <a:t> </a:t>
+            </a:r>
+            <a:r>
+              <a:rPr lang="it-IT" sz="1200" dirty="0" err="1"/>
+              <a:t>monotonic</a:t>
+            </a:r>
+            <a:r>
+              <a:rPr lang="it-IT" sz="1200" dirty="0"/>
+              <a:t> </a:t>
+            </a:r>
+            <a:r>
+              <a:rPr lang="it-IT" sz="1200" dirty="0" err="1"/>
+              <a:t>atmospheric</a:t>
+            </a:r>
+            <a:r>
+              <a:rPr lang="it-IT" sz="1200" dirty="0"/>
+              <a:t> </a:t>
+            </a:r>
+            <a:r>
+              <a:rPr lang="it-IT" sz="1200" dirty="0" err="1"/>
+              <a:t>dependencies</a:t>
+            </a:r>
+            <a:r>
+              <a:rPr lang="it-IT" sz="1200" dirty="0"/>
+              <a:t> (AT,AH) </a:t>
+            </a:r>
+            <a:r>
+              <a:rPr lang="it-IT" sz="1200" dirty="0" err="1"/>
+              <a:t>without</a:t>
+            </a:r>
+            <a:r>
+              <a:rPr lang="it-IT" sz="1200" dirty="0"/>
+              <a:t> </a:t>
+            </a:r>
+            <a:r>
+              <a:rPr lang="it-IT" sz="1200" dirty="0" err="1"/>
+              <a:t>overfitting</a:t>
+            </a:r>
+            <a:r>
+              <a:rPr lang="it-IT" sz="1200" dirty="0"/>
+              <a:t>, </a:t>
+            </a:r>
+            <a:r>
+              <a:rPr lang="it-IT" sz="1200" dirty="0" err="1"/>
+              <a:t>providing</a:t>
+            </a:r>
+            <a:r>
+              <a:rPr lang="it-IT" sz="1200" dirty="0"/>
+              <a:t> a </a:t>
+            </a:r>
+            <a:r>
+              <a:rPr lang="it-IT" sz="1200" dirty="0" err="1"/>
+              <a:t>clean</a:t>
+            </a:r>
+            <a:r>
+              <a:rPr lang="it-IT" sz="1200" dirty="0"/>
+              <a:t> baseline to </a:t>
+            </a:r>
+            <a:r>
+              <a:rPr lang="it-IT" sz="1200" dirty="0" err="1"/>
+              <a:t>detect</a:t>
+            </a:r>
+            <a:r>
+              <a:rPr lang="it-IT" sz="1200" dirty="0"/>
+              <a:t> </a:t>
+            </a:r>
+            <a:r>
+              <a:rPr lang="it-IT" sz="1200" dirty="0" err="1"/>
+              <a:t>plant</a:t>
+            </a:r>
+            <a:r>
+              <a:rPr lang="it-IT" sz="1200" dirty="0"/>
+              <a:t> </a:t>
+            </a:r>
+            <a:r>
+              <a:rPr lang="it-IT" sz="1200" dirty="0" err="1"/>
+              <a:t>maintenance</a:t>
+            </a:r>
+            <a:r>
+              <a:rPr lang="it-IT" sz="1200" dirty="0"/>
+              <a:t> domain</a:t>
+            </a:r>
+          </a:p>
+          <a:p>
+            <a:r>
+              <a:rPr lang="it-IT" sz="1200" dirty="0"/>
+              <a:t>      shifts.</a:t>
+            </a:r>
+          </a:p>
+          <a:p>
+            <a:r>
+              <a:rPr lang="it-IT" sz="1200" dirty="0"/>
+              <a:t>  • </a:t>
+            </a:r>
+            <a:r>
+              <a:rPr lang="it-IT" sz="1200" dirty="0" err="1"/>
+              <a:t>Operational</a:t>
+            </a:r>
+            <a:r>
+              <a:rPr lang="it-IT" sz="1200" dirty="0"/>
+              <a:t> </a:t>
+            </a:r>
+            <a:r>
+              <a:rPr lang="it-IT" sz="1200" dirty="0" err="1"/>
+              <a:t>Regimes</a:t>
+            </a:r>
+            <a:r>
+              <a:rPr lang="it-IT" sz="1200" dirty="0"/>
+              <a:t> </a:t>
+            </a:r>
+            <a:r>
+              <a:rPr lang="it-IT" sz="1200" dirty="0" err="1"/>
+              <a:t>implies</a:t>
+            </a:r>
+            <a:r>
+              <a:rPr lang="it-IT" sz="1200" dirty="0"/>
+              <a:t> K-Means Clustering (K = 3):</a:t>
+            </a:r>
+          </a:p>
+          <a:p>
+            <a:r>
+              <a:rPr lang="it-IT" sz="1200" dirty="0"/>
+              <a:t>      • </a:t>
+            </a:r>
+            <a:r>
+              <a:rPr lang="it-IT" sz="1200" dirty="0" err="1"/>
+              <a:t>Motivation</a:t>
+            </a:r>
+            <a:r>
+              <a:rPr lang="it-IT" sz="1200" dirty="0"/>
+              <a:t>: </a:t>
+            </a:r>
+            <a:r>
+              <a:rPr lang="it-IT" sz="1200" dirty="0" err="1"/>
+              <a:t>Unsupervised</a:t>
+            </a:r>
+            <a:r>
+              <a:rPr lang="it-IT" sz="1200" dirty="0"/>
+              <a:t> </a:t>
+            </a:r>
+            <a:r>
+              <a:rPr lang="it-IT" sz="1200" dirty="0" err="1"/>
+              <a:t>partitioning</a:t>
+            </a:r>
+            <a:r>
+              <a:rPr lang="it-IT" sz="1200" dirty="0"/>
+              <a:t> of </a:t>
+            </a:r>
+            <a:r>
+              <a:rPr lang="it-IT" sz="1200" dirty="0" err="1"/>
+              <a:t>continuous</a:t>
+            </a:r>
+            <a:r>
+              <a:rPr lang="it-IT" sz="1200" dirty="0"/>
+              <a:t> </a:t>
+            </a:r>
+            <a:r>
+              <a:rPr lang="it-IT" sz="1200" dirty="0" err="1"/>
+              <a:t>telemetry</a:t>
+            </a:r>
+            <a:r>
+              <a:rPr lang="it-IT" sz="1200" dirty="0"/>
+              <a:t> </a:t>
+            </a:r>
+            <a:r>
+              <a:rPr lang="it-IT" sz="1200" dirty="0" err="1"/>
+              <a:t>into</a:t>
+            </a:r>
+            <a:r>
+              <a:rPr lang="it-IT" sz="1200" dirty="0"/>
+              <a:t> 3 </a:t>
+            </a:r>
+            <a:r>
+              <a:rPr lang="it-IT" sz="1200" dirty="0" err="1"/>
+              <a:t>canonical</a:t>
+            </a:r>
+            <a:r>
+              <a:rPr lang="it-IT" sz="1200" dirty="0"/>
+              <a:t> </a:t>
+            </a:r>
+            <a:r>
+              <a:rPr lang="it-IT" sz="1200" dirty="0" err="1"/>
+              <a:t>dispatch</a:t>
+            </a:r>
+            <a:r>
+              <a:rPr lang="it-IT" sz="1200" dirty="0"/>
+              <a:t> </a:t>
+            </a:r>
+            <a:r>
+              <a:rPr lang="it-IT" sz="1200" dirty="0" err="1"/>
+              <a:t>states</a:t>
+            </a:r>
+            <a:r>
+              <a:rPr lang="it-IT" sz="1200" dirty="0"/>
+              <a:t> (Peak Load, </a:t>
+            </a:r>
+            <a:r>
+              <a:rPr lang="it-IT" sz="1200" dirty="0" err="1"/>
+              <a:t>Baseload</a:t>
+            </a:r>
+            <a:r>
+              <a:rPr lang="it-IT" sz="1200" dirty="0"/>
+              <a:t>, Part-Load) to isolate the 3.3</a:t>
+            </a:r>
+          </a:p>
+          <a:p>
+            <a:r>
+              <a:rPr lang="it-IT" sz="1200" dirty="0"/>
+              <a:t>      × CO surge.</a:t>
+            </a:r>
+          </a:p>
+        </p:txBody>
+      </p:sp>
+      <p:pic>
+        <p:nvPicPr>
+          <p:cNvPr id="9" name="Immagine 8">
+            <a:extLst>
+              <a:ext uri="{FF2B5EF4-FFF2-40B4-BE49-F238E27FC236}">
+                <a16:creationId xmlns:a16="http://schemas.microsoft.com/office/drawing/2014/main" id="{45A3A363-704F-84FE-E9AB-BC7C589302F1}"/>
+              </a:ext>
+            </a:extLst>
+          </p:cNvPr>
+          <p:cNvPicPr>
+            <a:picLocks noChangeAspect="1"/>
+          </p:cNvPicPr>
+          <p:nvPr/>
+        </p:nvPicPr>
+        <p:blipFill>
+          <a:blip r:embed="rId2"/>
+          <a:stretch>
+            <a:fillRect/>
+          </a:stretch>
+        </p:blipFill>
+        <p:spPr>
+          <a:xfrm>
+            <a:off x="6133617" y="2377440"/>
+            <a:ext cx="5570703" cy="2644369"/>
+          </a:xfrm>
+          <a:prstGeom prst="rect">
+            <a:avLst/>
+          </a:prstGeom>
+        </p:spPr>
+      </p:pic>
+    </p:spTree>
+    <p:extLst>
+      <p:ext uri="{BB962C8B-B14F-4D97-AF65-F5344CB8AC3E}">
+        <p14:creationId xmlns:p14="http://schemas.microsoft.com/office/powerpoint/2010/main" val="192430171"/>
+      </p:ext>
+    </p:extLst>
+  </p:cSld>
+  <p:clrMapOvr>
+    <a:masterClrMapping/>
+  </p:clrMapOvr>
+</p:sld>
+</file>
+
+<file path=ppt/slides/slide8.xml><?xml version="1.0" encoding="utf-8"?>
+<p:sld xmlns:a="http://schemas.openxmlformats.org/drawingml/2006/main" xmlns:r="http://schemas.openxmlformats.org/officeDocument/2006/relationships" xmlns:p="http://schemas.openxmlformats.org/presentationml/2006/main">
   <p:cSld>
     <p:spTree>
       <p:nvGrpSpPr>
@@ -7732,7 +9071,14 @@
         <p:cNvGrpSpPr/>
         <p:nvPr/>
       </p:nvGrpSpPr>
-      <p:grpSpPr/>
+      <p:grpSpPr>
+        <a:xfrm>
+          <a:off x="0" y="0"/>
+          <a:ext cx="0" cy="0"/>
+          <a:chOff x="0" y="0"/>
+          <a:chExt cx="0" cy="0"/>
+        </a:xfrm>
+      </p:grpSpPr>
       <p:sp>
         <p:nvSpPr>
           <p:cNvPr id="2" name="Rectangle 1"/>
@@ -7771,387 +9117,7 @@
           </a:fontRef>
         </p:style>
         <p:txBody>
-          <a:bodyPr rtlCol="0" anchor="ctr" wrap="square" lIns="731520" tIns="137160"/>
-          <a:lstStyle/>
-          <a:p>
-            <a:pPr algn="ctr">
-              <a:defRPr sz="1100" b="1">
-                <a:solidFill>
-                  <a:srgbClr val="B4D7EB"/>
-                </a:solidFill>
-              </a:defRPr>
-            </a:pPr>
-            <a:r>
-              <a:t>PHASE 3: METHODOLOGICAL FRAMEWORK</a:t>
-            </a:r>
-          </a:p>
-          <a:p>
-            <a:pPr>
-              <a:defRPr sz="2200" b="1">
-                <a:solidFill>
-                  <a:srgbClr val="FFFFFF"/>
-                </a:solidFill>
-              </a:defRPr>
-            </a:pPr>
-            <a:r>
-              <a:t>4. Main Analysis: Objectives &amp; Methodological Framework</a:t>
-            </a:r>
-          </a:p>
-        </p:txBody>
-      </p:sp>
-      <p:sp>
-        <p:nvSpPr>
-          <p:cNvPr id="3" name="Rounded Rectangle 2"/>
-          <p:cNvSpPr/>
-          <p:nvPr/>
-        </p:nvSpPr>
-        <p:spPr>
-          <a:xfrm>
-            <a:off x="731520" y="1371600"/>
-            <a:ext cx="3383280" cy="2926080"/>
-          </a:xfrm>
-          <a:prstGeom prst="roundRect">
-            <a:avLst/>
-          </a:prstGeom>
-          <a:solidFill>
-            <a:srgbClr val="F8F9FA"/>
-          </a:solidFill>
-          <a:ln>
-            <a:solidFill>
-              <a:srgbClr val="DCE1E6"/>
-            </a:solidFill>
-          </a:ln>
-        </p:spPr>
-        <p:style>
-          <a:lnRef idx="1">
-            <a:schemeClr val="accent1"/>
-          </a:lnRef>
-          <a:fillRef idx="3">
-            <a:schemeClr val="accent1"/>
-          </a:fillRef>
-          <a:effectRef idx="2">
-            <a:schemeClr val="accent1"/>
-          </a:effectRef>
-          <a:fontRef idx="minor">
-            <a:schemeClr val="lt1"/>
-          </a:fontRef>
-        </p:style>
-        <p:txBody>
-          <a:bodyPr rtlCol="0" anchor="ctr" wrap="square" lIns="182880" tIns="182880"/>
-          <a:lstStyle/>
-          <a:p>
-            <a:pPr algn="ctr">
-              <a:defRPr sz="1300" b="1">
-                <a:solidFill>
-                  <a:srgbClr val="102542"/>
-                </a:solidFill>
-              </a:defRPr>
-            </a:pPr>
-            <a:r>
-              <a:t>Objective 1: Energy Yield (TEY) &amp; PCR</a:t>
-            </a:r>
-          </a:p>
-          <a:p>
-            <a:pPr>
-              <a:defRPr sz="1000">
-                <a:solidFill>
-                  <a:srgbClr val="212529"/>
-                </a:solidFill>
-              </a:defRPr>
-            </a:pPr>
-            <a:r>
-              <a:t>• Predict net turbine energy yield from 8 sensor telemetry features.</a:t>
-            </a:r>
-            <a:br/>
-            <a:r>
-              <a:t>• Problem: Extreme Multicollinearity (VIF &gt; 250 for CDP, TIT, GTEP, Slide 115).</a:t>
-            </a:r>
-            <a:br/>
-            <a:r>
-              <a:t>• Method: Principal Component Regression (PCR, Slides 70, 106) on 4 feature PCs ($Z = X_{\text{std}} V_4$, 90.76% PVE) to eliminate variance inflation and ensure numerical stability.</a:t>
-            </a:r>
-          </a:p>
-        </p:txBody>
-      </p:sp>
-      <p:sp>
-        <p:nvSpPr>
-          <p:cNvPr id="4" name="Rounded Rectangle 3"/>
-          <p:cNvSpPr/>
-          <p:nvPr/>
-        </p:nvSpPr>
-        <p:spPr>
-          <a:xfrm>
-            <a:off x="4389120" y="1371600"/>
-            <a:ext cx="3383280" cy="2926080"/>
-          </a:xfrm>
-          <a:prstGeom prst="roundRect">
-            <a:avLst/>
-          </a:prstGeom>
-          <a:solidFill>
-            <a:srgbClr val="F8F9FA"/>
-          </a:solidFill>
-          <a:ln>
-            <a:solidFill>
-              <a:srgbClr val="DCE1E6"/>
-            </a:solidFill>
-          </a:ln>
-        </p:spPr>
-        <p:style>
-          <a:lnRef idx="1">
-            <a:schemeClr val="accent1"/>
-          </a:lnRef>
-          <a:fillRef idx="3">
-            <a:schemeClr val="accent1"/>
-          </a:fillRef>
-          <a:effectRef idx="2">
-            <a:schemeClr val="accent1"/>
-          </a:effectRef>
-          <a:fontRef idx="minor">
-            <a:schemeClr val="lt1"/>
-          </a:fontRef>
-        </p:style>
-        <p:txBody>
-          <a:bodyPr rtlCol="0" anchor="ctr" wrap="square" lIns="182880" tIns="182880"/>
-          <a:lstStyle/>
-          <a:p>
-            <a:pPr algn="ctr">
-              <a:defRPr sz="1300" b="1">
-                <a:solidFill>
-                  <a:srgbClr val="102542"/>
-                </a:solidFill>
-              </a:defRPr>
-            </a:pPr>
-            <a:r>
-              <a:t>Objective 2: Emissions Modeling (CO &amp; NOx)</a:t>
-            </a:r>
-          </a:p>
-          <a:p>
-            <a:pPr>
-              <a:defRPr sz="1000">
-                <a:solidFill>
-                  <a:srgbClr val="212529"/>
-                </a:solidFill>
-              </a:defRPr>
-            </a:pPr>
-            <a:r>
-              <a:t>• Quantify pollutant generation as a function of firing state.</a:t>
-            </a:r>
-            <a:br/>
-            <a:r>
-              <a:t>• Method: Polynomial Regression (Slide 116 &amp; Ex 4.1) for CO to capture steep non-linear spikes during low-load/startup regimes ($x \to [x, x^2]$).</a:t>
-            </a:r>
-            <a:br/>
-            <a:r>
-              <a:t>• Multivariate OLS for NOx tracking thermal oxidation.</a:t>
-            </a:r>
-          </a:p>
-        </p:txBody>
-      </p:sp>
-      <p:sp>
-        <p:nvSpPr>
-          <p:cNvPr id="5" name="Rounded Rectangle 4"/>
-          <p:cNvSpPr/>
-          <p:nvPr/>
-        </p:nvSpPr>
-        <p:spPr>
-          <a:xfrm>
-            <a:off x="8046720" y="1371600"/>
-            <a:ext cx="3383280" cy="2926080"/>
-          </a:xfrm>
-          <a:prstGeom prst="roundRect">
-            <a:avLst/>
-          </a:prstGeom>
-          <a:solidFill>
-            <a:srgbClr val="F8F9FA"/>
-          </a:solidFill>
-          <a:ln>
-            <a:solidFill>
-              <a:srgbClr val="DCE1E6"/>
-            </a:solidFill>
-          </a:ln>
-        </p:spPr>
-        <p:style>
-          <a:lnRef idx="1">
-            <a:schemeClr val="accent1"/>
-          </a:lnRef>
-          <a:fillRef idx="3">
-            <a:schemeClr val="accent1"/>
-          </a:fillRef>
-          <a:effectRef idx="2">
-            <a:schemeClr val="accent1"/>
-          </a:effectRef>
-          <a:fontRef idx="minor">
-            <a:schemeClr val="lt1"/>
-          </a:fontRef>
-        </p:style>
-        <p:txBody>
-          <a:bodyPr rtlCol="0" anchor="ctr" wrap="square" lIns="182880" tIns="182880"/>
-          <a:lstStyle/>
-          <a:p>
-            <a:pPr algn="ctr">
-              <a:defRPr sz="1300" b="1">
-                <a:solidFill>
-                  <a:srgbClr val="102542"/>
-                </a:solidFill>
-              </a:defRPr>
-            </a:pPr>
-            <a:r>
-              <a:t>Objective 3: Operational Regimes (K-Means)</a:t>
-            </a:r>
-          </a:p>
-          <a:p>
-            <a:pPr>
-              <a:defRPr sz="1000">
-                <a:solidFill>
-                  <a:srgbClr val="212529"/>
-                </a:solidFill>
-              </a:defRPr>
-            </a:pPr>
-            <a:r>
-              <a:t>• Discover discrete turbine operational regimes (Unsupervised).</a:t>
-            </a:r>
-            <a:br/>
-            <a:r>
-              <a:t>• Method: K-Means Clustering (Slides 90-91) with Silhouette validation (Slide 94, Ex 3.1): $\text{SIL} = \frac{1}{m}\sum \frac{b_i - a_i}{\max(a_i, b_i)}$.</a:t>
-            </a:r>
-            <a:br/>
-            <a:r>
-              <a:t>• Identifies Base-load, Peak-load, and Low-load emission profiles.</a:t>
-            </a:r>
-          </a:p>
-        </p:txBody>
-      </p:sp>
-      <p:sp>
-        <p:nvSpPr>
-          <p:cNvPr id="6" name="Rounded Rectangle 5"/>
-          <p:cNvSpPr/>
-          <p:nvPr/>
-        </p:nvSpPr>
-        <p:spPr>
-          <a:xfrm>
-            <a:off x="731520" y="4480560"/>
-            <a:ext cx="10698480" cy="1920240"/>
-          </a:xfrm>
-          <a:prstGeom prst="roundRect">
-            <a:avLst/>
-          </a:prstGeom>
-          <a:solidFill>
-            <a:srgbClr val="F8F9FA"/>
-          </a:solidFill>
-          <a:ln>
-            <a:solidFill>
-              <a:srgbClr val="DCE1E6"/>
-            </a:solidFill>
-          </a:ln>
-        </p:spPr>
-        <p:style>
-          <a:lnRef idx="1">
-            <a:schemeClr val="accent1"/>
-          </a:lnRef>
-          <a:fillRef idx="3">
-            <a:schemeClr val="accent1"/>
-          </a:fillRef>
-          <a:effectRef idx="2">
-            <a:schemeClr val="accent1"/>
-          </a:effectRef>
-          <a:fontRef idx="minor">
-            <a:schemeClr val="lt1"/>
-          </a:fontRef>
-        </p:style>
-        <p:txBody>
-          <a:bodyPr rtlCol="0" anchor="ctr" wrap="square" lIns="228600" tIns="137160"/>
-          <a:lstStyle/>
-          <a:p>
-            <a:pPr algn="ctr">
-              <a:defRPr sz="1300" b="1">
-                <a:solidFill>
-                  <a:srgbClr val="102542"/>
-                </a:solidFill>
-              </a:defRPr>
-            </a:pPr>
-            <a:r>
-              <a:t>Mathematical Formulations &amp; Accuracy Metrics (Course Standards)</a:t>
-            </a:r>
-          </a:p>
-          <a:p>
-            <a:pPr>
-              <a:defRPr sz="1050">
-                <a:solidFill>
-                  <a:srgbClr val="212529"/>
-                </a:solidFill>
-              </a:defRPr>
-            </a:pPr>
-            <a:r>
-              <a:t>• Ordinary Least Squares: $\hat{\beta} = (X^T X)^{-1} X^T y$ (Slide 106, computed via `np.linalg.lstsq` for numerical stability)</a:t>
-            </a:r>
-            <a:br/>
-            <a:r>
-              <a:t>• Principal Component Regression: $\hat{\beta}_{PCR} = (Z^T Z)^{-1} Z^T y$, where $Z = X_{\text{std}} V_4$ (4 PCs capturing 90.76% PVE)</a:t>
-            </a:r>
-            <a:br/>
-            <a:r>
-              <a:t>• Multicollinearity VIF: $\text{VIF}(\hat{\beta}_j) = \frac{1}{1 - R^2_{x_j|x_{-j}}}$ (Slide 115) | Silhouette Quality: $\text{SIL}_i = \frac{b_i - a_i}{\max(a_i, b_i)}$ (Slide 94)</a:t>
-            </a:r>
-          </a:p>
-        </p:txBody>
-      </p:sp>
-    </p:spTree>
-  </p:cSld>
-  <p:clrMapOvr>
-    <a:masterClrMapping/>
-  </p:clrMapOvr>
-</p:sld>
-</file>
-
-<file path=ppt/slides/slide8.xml><?xml version="1.0" encoding="utf-8"?>
-<p:sld xmlns:a="http://schemas.openxmlformats.org/drawingml/2006/main" xmlns:p="http://schemas.openxmlformats.org/presentationml/2006/main" xmlns:r="http://schemas.openxmlformats.org/officeDocument/2006/relationships">
-  <p:cSld>
-    <p:spTree>
-      <p:nvGrpSpPr>
-        <p:cNvPr id="1" name=""/>
-        <p:cNvGrpSpPr/>
-        <p:nvPr/>
-      </p:nvGrpSpPr>
-      <p:grpSpPr/>
-      <p:sp>
-        <p:nvSpPr>
-          <p:cNvPr id="2" name="Rectangle 1"/>
-          <p:cNvSpPr/>
-          <p:nvPr/>
-        </p:nvSpPr>
-        <p:spPr>
-          <a:xfrm>
-            <a:off x="0" y="0"/>
-            <a:ext cx="12191695" cy="1097280"/>
-          </a:xfrm>
-          <a:prstGeom prst="rect">
-            <a:avLst/>
-          </a:prstGeom>
-          <a:solidFill>
-            <a:srgbClr val="102542"/>
-          </a:solidFill>
-          <a:ln>
-            <a:solidFill>
-              <a:srgbClr val="102542"/>
-            </a:solidFill>
-          </a:ln>
-        </p:spPr>
-        <p:style>
-          <a:lnRef idx="1">
-            <a:schemeClr val="accent1"/>
-          </a:lnRef>
-          <a:fillRef idx="3">
-            <a:schemeClr val="accent1"/>
-          </a:fillRef>
-          <a:effectRef idx="2">
-            <a:schemeClr val="accent1"/>
-          </a:effectRef>
-          <a:fontRef idx="minor">
-            <a:schemeClr val="lt1"/>
-          </a:fontRef>
-        </p:style>
-        <p:txBody>
-          <a:bodyPr rtlCol="0" anchor="ctr" wrap="square" lIns="731520" tIns="137160"/>
+          <a:bodyPr wrap="square" lIns="731520" tIns="137160" rtlCol="0" anchor="ctr"/>
           <a:lstStyle/>
           <a:p>
             <a:pPr algn="ctr">
@@ -8217,7 +9183,7 @@
           </a:fontRef>
         </p:style>
         <p:txBody>
-          <a:bodyPr rtlCol="0" anchor="ctr" wrap="square" lIns="137160" tIns="109728"/>
+          <a:bodyPr wrap="square" lIns="137160" tIns="109728" rtlCol="0" anchor="ctr"/>
           <a:lstStyle/>
           <a:p>
             <a:pPr algn="ctr">
@@ -8228,6 +9194,7 @@
               </a:defRPr>
             </a:pPr>
             <a:r>
+              <a:rPr dirty="0"/>
               <a:t>0.9501</a:t>
             </a:r>
           </a:p>
@@ -8240,6 +9207,7 @@
               </a:defRPr>
             </a:pPr>
             <a:r>
+              <a:rPr dirty="0"/>
               <a:t>Best TEY Test R² (OLS)</a:t>
             </a:r>
           </a:p>
@@ -8252,6 +9220,7 @@
               </a:defRPr>
             </a:pPr>
             <a:r>
+              <a:rPr dirty="0"/>
               <a:t>Full 8-feature multivariate model</a:t>
             </a:r>
           </a:p>
@@ -8295,7 +9264,7 @@
           </a:fontRef>
         </p:style>
         <p:txBody>
-          <a:bodyPr rtlCol="0" anchor="ctr" wrap="square" lIns="137160" tIns="109728"/>
+          <a:bodyPr wrap="square" lIns="137160" tIns="109728" rtlCol="0" anchor="ctr"/>
           <a:lstStyle/>
           <a:p>
             <a:pPr algn="ctr">
@@ -8373,7 +9342,7 @@
           </a:fontRef>
         </p:style>
         <p:txBody>
-          <a:bodyPr rtlCol="0" anchor="ctr" wrap="square" lIns="137160" tIns="109728"/>
+          <a:bodyPr wrap="square" lIns="137160" tIns="109728" rtlCol="0" anchor="ctr"/>
           <a:lstStyle/>
           <a:p>
             <a:pPr algn="ctr">
@@ -8451,7 +9420,7 @@
           </a:fontRef>
         </p:style>
         <p:txBody>
-          <a:bodyPr rtlCol="0" anchor="ctr" wrap="square" lIns="137160" tIns="109728"/>
+          <a:bodyPr wrap="square" lIns="137160" tIns="109728" rtlCol="0" anchor="ctr"/>
           <a:lstStyle/>
           <a:p>
             <a:pPr algn="ctr">
@@ -8510,11 +9479,41 @@
                 <a:tableStyleId>{5C22544A-7EE6-4342-B048-85BDC9FD1C3A}</a:tableStyleId>
               </a:tblPr>
               <a:tblGrid>
-                <a:gridCol w="3383280"/>
-                <a:gridCol w="1828800"/>
-                <a:gridCol w="1828800"/>
-                <a:gridCol w="1828800"/>
-                <a:gridCol w="1828800"/>
+                <a:gridCol w="3383280">
+                  <a:extLst>
+                    <a:ext uri="{9D8B030D-6E8A-4147-A177-3AD203B41FA5}">
+                      <a16:colId xmlns:a16="http://schemas.microsoft.com/office/drawing/2014/main" val="20000"/>
+                    </a:ext>
+                  </a:extLst>
+                </a:gridCol>
+                <a:gridCol w="1828800">
+                  <a:extLst>
+                    <a:ext uri="{9D8B030D-6E8A-4147-A177-3AD203B41FA5}">
+                      <a16:colId xmlns:a16="http://schemas.microsoft.com/office/drawing/2014/main" val="20001"/>
+                    </a:ext>
+                  </a:extLst>
+                </a:gridCol>
+                <a:gridCol w="1828800">
+                  <a:extLst>
+                    <a:ext uri="{9D8B030D-6E8A-4147-A177-3AD203B41FA5}">
+                      <a16:colId xmlns:a16="http://schemas.microsoft.com/office/drawing/2014/main" val="20002"/>
+                    </a:ext>
+                  </a:extLst>
+                </a:gridCol>
+                <a:gridCol w="1828800">
+                  <a:extLst>
+                    <a:ext uri="{9D8B030D-6E8A-4147-A177-3AD203B41FA5}">
+                      <a16:colId xmlns:a16="http://schemas.microsoft.com/office/drawing/2014/main" val="20003"/>
+                    </a:ext>
+                  </a:extLst>
+                </a:gridCol>
+                <a:gridCol w="1828800">
+                  <a:extLst>
+                    <a:ext uri="{9D8B030D-6E8A-4147-A177-3AD203B41FA5}">
+                      <a16:colId xmlns:a16="http://schemas.microsoft.com/office/drawing/2014/main" val="20004"/>
+                    </a:ext>
+                  </a:extLst>
+                </a:gridCol>
               </a:tblGrid>
               <a:tr h="434340">
                 <a:tc>
@@ -8523,13 +9522,14 @@
                     <a:lstStyle/>
                     <a:p>
                       <a:pPr>
-                        <a:defRPr b="1" sz="1100">
+                        <a:defRPr sz="1100" b="1">
                           <a:solidFill>
                             <a:srgbClr val="FFFFFF"/>
                           </a:solidFill>
                         </a:defRPr>
                       </a:pPr>
                       <a:r>
+                        <a:rPr dirty="0"/>
                         <a:t>Target Variable &amp; Model Specification</a:t>
                       </a:r>
                     </a:p>
@@ -8546,7 +9546,7 @@
                     <a:lstStyle/>
                     <a:p>
                       <a:pPr>
-                        <a:defRPr b="1" sz="1100">
+                        <a:defRPr sz="1100" b="1">
                           <a:solidFill>
                             <a:srgbClr val="FFFFFF"/>
                           </a:solidFill>
@@ -8569,7 +9569,7 @@
                     <a:lstStyle/>
                     <a:p>
                       <a:pPr>
-                        <a:defRPr b="1" sz="1100">
+                        <a:defRPr sz="1100" b="1">
                           <a:solidFill>
                             <a:srgbClr val="FFFFFF"/>
                           </a:solidFill>
@@ -8592,7 +9592,7 @@
                     <a:lstStyle/>
                     <a:p>
                       <a:pPr>
-                        <a:defRPr b="1" sz="1100">
+                        <a:defRPr sz="1100" b="1">
                           <a:solidFill>
                             <a:srgbClr val="FFFFFF"/>
                           </a:solidFill>
@@ -8615,7 +9615,7 @@
                     <a:lstStyle/>
                     <a:p>
                       <a:pPr>
-                        <a:defRPr b="1" sz="1100">
+                        <a:defRPr sz="1100" b="1">
                           <a:solidFill>
                             <a:srgbClr val="FFFFFF"/>
                           </a:solidFill>
@@ -8632,6 +9632,11 @@
                     </a:solidFill>
                   </a:tcPr>
                 </a:tc>
+                <a:extLst>
+                  <a:ext uri="{0D108BD9-81ED-4DB2-BD59-A6C34878D82A}">
+                    <a16:rowId xmlns:a16="http://schemas.microsoft.com/office/drawing/2014/main" val="10000"/>
+                  </a:ext>
+                </a:extLst>
               </a:tr>
               <a:tr h="434340">
                 <a:tc>
@@ -8749,6 +9754,11 @@
                     </a:solidFill>
                   </a:tcPr>
                 </a:tc>
+                <a:extLst>
+                  <a:ext uri="{0D108BD9-81ED-4DB2-BD59-A6C34878D82A}">
+                    <a16:rowId xmlns:a16="http://schemas.microsoft.com/office/drawing/2014/main" val="10001"/>
+                  </a:ext>
+                </a:extLst>
               </a:tr>
               <a:tr h="434340">
                 <a:tc>
@@ -8866,6 +9876,11 @@
                     </a:solidFill>
                   </a:tcPr>
                 </a:tc>
+                <a:extLst>
+                  <a:ext uri="{0D108BD9-81ED-4DB2-BD59-A6C34878D82A}">
+                    <a16:rowId xmlns:a16="http://schemas.microsoft.com/office/drawing/2014/main" val="10002"/>
+                  </a:ext>
+                </a:extLst>
               </a:tr>
               <a:tr h="434340">
                 <a:tc>
@@ -8983,6 +9998,11 @@
                     </a:solidFill>
                   </a:tcPr>
                 </a:tc>
+                <a:extLst>
+                  <a:ext uri="{0D108BD9-81ED-4DB2-BD59-A6C34878D82A}">
+                    <a16:rowId xmlns:a16="http://schemas.microsoft.com/office/drawing/2014/main" val="10003"/>
+                  </a:ext>
+                </a:extLst>
               </a:tr>
               <a:tr h="434340">
                 <a:tc>
@@ -9100,6 +10120,11 @@
                     </a:solidFill>
                   </a:tcPr>
                 </a:tc>
+                <a:extLst>
+                  <a:ext uri="{0D108BD9-81ED-4DB2-BD59-A6C34878D82A}">
+                    <a16:rowId xmlns:a16="http://schemas.microsoft.com/office/drawing/2014/main" val="10004"/>
+                  </a:ext>
+                </a:extLst>
               </a:tr>
               <a:tr h="434340">
                 <a:tc>
@@ -9217,6 +10242,11 @@
                     </a:solidFill>
                   </a:tcPr>
                 </a:tc>
+                <a:extLst>
+                  <a:ext uri="{0D108BD9-81ED-4DB2-BD59-A6C34878D82A}">
+                    <a16:rowId xmlns:a16="http://schemas.microsoft.com/office/drawing/2014/main" val="10005"/>
+                  </a:ext>
+                </a:extLst>
               </a:tr>
               <a:tr h="434340">
                 <a:tc>
@@ -9334,6 +10364,11 @@
                     </a:solidFill>
                   </a:tcPr>
                 </a:tc>
+                <a:extLst>
+                  <a:ext uri="{0D108BD9-81ED-4DB2-BD59-A6C34878D82A}">
+                    <a16:rowId xmlns:a16="http://schemas.microsoft.com/office/drawing/2014/main" val="10006"/>
+                  </a:ext>
+                </a:extLst>
               </a:tr>
               <a:tr h="434340">
                 <a:tc>
@@ -9451,6 +10486,11 @@
                     </a:solidFill>
                   </a:tcPr>
                 </a:tc>
+                <a:extLst>
+                  <a:ext uri="{0D108BD9-81ED-4DB2-BD59-A6C34878D82A}">
+                    <a16:rowId xmlns:a16="http://schemas.microsoft.com/office/drawing/2014/main" val="10007"/>
+                  </a:ext>
+                </a:extLst>
               </a:tr>
             </a:tbl>
           </a:graphicData>
@@ -9465,7 +10505,7 @@
 </file>
 
 <file path=ppt/slides/slide9.xml><?xml version="1.0" encoding="utf-8"?>
-<p:sld xmlns:a="http://schemas.openxmlformats.org/drawingml/2006/main" xmlns:p="http://schemas.openxmlformats.org/presentationml/2006/main" xmlns:r="http://schemas.openxmlformats.org/officeDocument/2006/relationships">
+<p:sld xmlns:a="http://schemas.openxmlformats.org/drawingml/2006/main" xmlns:r="http://schemas.openxmlformats.org/officeDocument/2006/relationships" xmlns:p="http://schemas.openxmlformats.org/presentationml/2006/main">
   <p:cSld>
     <p:spTree>
       <p:nvGrpSpPr>
@@ -9473,7 +10513,14 @@
         <p:cNvGrpSpPr/>
         <p:nvPr/>
       </p:nvGrpSpPr>
-      <p:grpSpPr/>
+      <p:grpSpPr>
+        <a:xfrm>
+          <a:off x="0" y="0"/>
+          <a:ext cx="0" cy="0"/>
+          <a:chOff x="0" y="0"/>
+          <a:chExt cx="0" cy="0"/>
+        </a:xfrm>
+      </p:grpSpPr>
       <p:sp>
         <p:nvSpPr>
           <p:cNvPr id="2" name="Rectangle 1"/>
@@ -9512,7 +10559,7 @@
           </a:fontRef>
         </p:style>
         <p:txBody>
-          <a:bodyPr rtlCol="0" anchor="ctr" wrap="square" lIns="731520" tIns="137160"/>
+          <a:bodyPr wrap="square" lIns="731520" tIns="137160" rtlCol="0" anchor="ctr"/>
           <a:lstStyle/>
           <a:p>
             <a:pPr algn="ctr">
@@ -9523,6 +10570,7 @@
               </a:defRPr>
             </a:pPr>
             <a:r>
+              <a:rPr dirty="0"/>
               <a:t>PHASE 4: IN-DEPTH MODEL EVALUATION</a:t>
             </a:r>
           </a:p>
@@ -9535,6 +10583,7 @@
               </a:defRPr>
             </a:pPr>
             <a:r>
+              <a:rPr dirty="0"/>
               <a:t>6. Detailed Results: Energy Yield (TEY) &amp; PCR Diagnostics</a:t>
             </a:r>
           </a:p>
@@ -9578,7 +10627,7 @@
           </a:fontRef>
         </p:style>
         <p:txBody>
-          <a:bodyPr rtlCol="0" anchor="ctr" wrap="square" lIns="228600" tIns="182880"/>
+          <a:bodyPr wrap="square" lIns="228600" tIns="182880" rtlCol="0" anchor="ctr"/>
           <a:lstStyle/>
           <a:p>
             <a:pPr algn="ctr">
@@ -9589,19 +10638,16 @@
               </a:defRPr>
             </a:pPr>
             <a:r>
+              <a:rPr dirty="0"/>
               <a:t>TEY Model Diagnostics &amp; Multicollinearity</a:t>
             </a:r>
           </a:p>
           <a:p>
-            <a:br/>
-            <a:pPr>
-              <a:defRPr b="1" sz="1100">
-                <a:solidFill>
-                  <a:srgbClr val="296299"/>
-                </a:solidFill>
-              </a:defRPr>
-            </a:pPr>
-            <a:r>
+            <a:br>
+              <a:rPr dirty="0"/>
+            </a:br>
+            <a:r>
+              <a:rPr dirty="0"/>
               <a:t>Multicollinearity Diagnostics (Slide 115):</a:t>
             </a:r>
           </a:p>
@@ -9614,23 +10660,23 @@
               </a:defRPr>
             </a:pPr>
             <a:r>
+              <a:rPr dirty="0"/>
               <a:t>• Extreme VIF scores diagnosed in operating telemetry: CDP (342.82), TIT (262.12), GTEP (260.47), TAT (133.21).</a:t>
             </a:r>
-            <a:br/>
-            <a:r>
+            <a:br>
+              <a:rPr dirty="0"/>
+            </a:br>
+            <a:r>
+              <a:rPr dirty="0"/>
               <a:t>• Predictor covariance eigen-decomposition reveals 4 PCs capture 90.76% of total feature variance.</a:t>
             </a:r>
           </a:p>
           <a:p>
-            <a:br/>
-            <a:pPr>
-              <a:defRPr b="1" sz="1100">
-                <a:solidFill>
-                  <a:srgbClr val="296299"/>
-                </a:solidFill>
-              </a:defRPr>
-            </a:pPr>
-            <a:r>
+            <a:br>
+              <a:rPr dirty="0"/>
+            </a:br>
+            <a:r>
+              <a:rPr dirty="0"/>
               <a:t>OLS vs. PCR Tradeoff (Slides 70, 106):</a:t>
             </a:r>
           </a:p>
@@ -9643,23 +10689,23 @@
               </a:defRPr>
             </a:pPr>
             <a:r>
+              <a:rPr dirty="0"/>
               <a:t>• Full OLS: Highest raw test accuracy (Test R² = 0.9501, RMSE = 3.35 MWh), but predictor weights suffer from severe collinear instability.</a:t>
             </a:r>
-            <a:br/>
-            <a:r>
+            <a:br>
+              <a:rPr dirty="0"/>
+            </a:br>
+            <a:r>
+              <a:rPr dirty="0"/>
               <a:t>• PCR (4 PCs): Achieves Test R² = 0.9397 (RMSE = 3.68 MWh) while projecting onto strictly orthogonal coordinates, guaranteeing stable physical interpretation.</a:t>
             </a:r>
           </a:p>
           <a:p>
-            <a:br/>
-            <a:pPr>
-              <a:defRPr b="1" sz="1100">
-                <a:solidFill>
-                  <a:srgbClr val="296299"/>
-                </a:solidFill>
-              </a:defRPr>
-            </a:pPr>
-            <a:r>
+            <a:br>
+              <a:rPr dirty="0"/>
+            </a:br>
+            <a:r>
+              <a:rPr dirty="0"/>
               <a:t>Residual Analysis (Slides 104, 108):</a:t>
             </a:r>
           </a:p>
@@ -9672,7 +10718,32 @@
               </a:defRPr>
             </a:pPr>
             <a:r>
-              <a:t>• Residuals $e_i = y_i - \hat{y}_i$ are zero-centered with symmetric Gaussian distribution and homoscedastic variance across the full 100–180 MWh generator span.</a:t>
+              <a:rPr dirty="0"/>
+              <a:t>• Residuals $</a:t>
+            </a:r>
+            <a:r>
+              <a:rPr dirty="0" err="1"/>
+              <a:t>e_i</a:t>
+            </a:r>
+            <a:r>
+              <a:rPr dirty="0"/>
+              <a:t> = </a:t>
+            </a:r>
+            <a:r>
+              <a:rPr dirty="0" err="1"/>
+              <a:t>y_i</a:t>
+            </a:r>
+            <a:r>
+              <a:rPr dirty="0"/>
+              <a:t> - \hat{y}_</a:t>
+            </a:r>
+            <a:r>
+              <a:rPr dirty="0" err="1"/>
+              <a:t>i</a:t>
+            </a:r>
+            <a:r>
+              <a:rPr dirty="0"/>
+              <a:t>$ are zero-centered with symmetric Gaussian distribution and homoscedastic variance across the full 100–180 MWh generator span.</a:t>
             </a:r>
           </a:p>
         </p:txBody>

</xml_diff>